<commit_message>
Merge Heavy classes above 55 tm on slide; add 7441C price estimate
Co-Authored-By: Claude Opus 5.5 <noreply@anthropic.com>
Claude-Session: https://claude.ai/code/session_01Pbxjp9hvsGyGE8VjiFxi6d
</commit_message>
<xml_diff>
--- a/slides/Slide_tm_Positioning.pptx
+++ b/slides/Slide_tm_Positioning.pptx
@@ -1036,7 +1036,7 @@
                 <a:ea typeface="Arial" pitchFamily="34" charset="-122"/>
                 <a:cs typeface="Arial" pitchFamily="34" charset="-120"/>
               </a:rPr>
-              <a:t>In Medium, F.lli Ferrari has a priced crane for 70% of units; the &gt;35–40 tm class (30%) has no Ferrari price yet (7441C)</a:t>
+              <a:t>In Medium, F.lli Ferrari has a crane in every tm class, but Sany Palfinger leads three of the four classes</a:t>
             </a:r>
             <a:endParaRPr lang="en-US" sz="1800" dirty="0"/>
           </a:p>
@@ -3744,7 +3744,7 @@
                       <a:tailEnd type="none" w="med" len="med"/>
                     </a:lnB>
                     <a:solidFill>
-                      <a:srgbClr val="161D25"/>
+                      <a:srgbClr val="3A0E14"/>
                     </a:solidFill>
                   </a:tcPr>
                 </a:tc>
@@ -3812,7 +3812,7 @@
                       <a:tailEnd type="none" w="med" len="med"/>
                     </a:lnB>
                     <a:solidFill>
-                      <a:srgbClr val="161D25"/>
+                      <a:srgbClr val="3A0E14"/>
                     </a:solidFill>
                   </a:tcPr>
                 </a:tc>
@@ -3825,7 +3825,28 @@
                         <a:buNone/>
                       </a:pPr>
                       <a:r>
-                        <a:rPr lang="en-US" sz="1100" i="1" dirty="0">
+                        <a:rPr lang="en-US" sz="1100" b="1" dirty="0">
+                          <a:solidFill>
+                            <a:srgbClr val="EEF1F4"/>
+                          </a:solidFill>
+                          <a:latin typeface="Arial" pitchFamily="34" charset="0"/>
+                          <a:ea typeface="Arial" pitchFamily="34" charset="-122"/>
+                          <a:cs typeface="Arial" pitchFamily="34" charset="-120"/>
+                        </a:rPr>
+                        <a:t>Rp 1.630.000.000</a:t>
+                      </a:r>
+                      <a:endParaRPr lang="en-US" sz="1100" dirty="0">
+                        <a:latin typeface="Arial" charset="0"/>
+                        <a:ea typeface="Arial" charset="0"/>
+                        <a:cs typeface="Arial" charset="0"/>
+                      </a:endParaRPr>
+                    </a:p>
+                    <a:p>
+                      <a:pPr algn="ctr" indent="0" marL="0">
+                        <a:buNone/>
+                      </a:pPr>
+                      <a:r>
+                        <a:rPr lang="en-US" sz="800" i="1" dirty="0">
                           <a:solidFill>
                             <a:srgbClr val="9AA6B2"/>
                           </a:solidFill>
@@ -3833,7 +3854,7 @@
                           <a:ea typeface="Arial" pitchFamily="34" charset="-122"/>
                           <a:cs typeface="Arial" pitchFamily="34" charset="-120"/>
                         </a:rPr>
-                        <a:t>Price not yet known</a:t>
+                        <a:t>estimate</a:t>
                       </a:r>
                       <a:endParaRPr lang="en-US" sz="1100" dirty="0">
                         <a:latin typeface="Arial" charset="0"/>
@@ -3880,7 +3901,7 @@
                       <a:tailEnd type="none" w="med" len="med"/>
                     </a:lnB>
                     <a:solidFill>
-                      <a:srgbClr val="161D25"/>
+                      <a:srgbClr val="3A0E14"/>
                     </a:solidFill>
                   </a:tcPr>
                 </a:tc>
@@ -4894,71 +4915,7 @@
       </p:sp>
       <p:sp>
         <p:nvSpPr>
-          <p:cNvPr id="21" name="Shape 14"/>
-          <p:cNvSpPr/>
-          <p:nvPr/>
-        </p:nvSpPr>
-        <p:spPr>
-          <a:xfrm>
-            <a:off x="3977640" y="5074920"/>
-            <a:ext cx="164592" cy="128016"/>
-          </a:xfrm>
-          <a:prstGeom prst="rect">
-            <a:avLst/>
-          </a:prstGeom>
-          <a:solidFill>
-            <a:srgbClr val="161D25"/>
-          </a:solidFill>
-          <a:ln w="12700">
-            <a:solidFill>
-              <a:srgbClr val="161D25"/>
-            </a:solidFill>
-            <a:prstDash val="solid"/>
-          </a:ln>
-        </p:spPr>
-      </p:sp>
-      <p:sp>
-        <p:nvSpPr>
-          <p:cNvPr id="22" name="Text 15"/>
-          <p:cNvSpPr txBox="1"/>
-          <p:nvPr/>
-        </p:nvSpPr>
-        <p:spPr>
-          <a:xfrm>
-            <a:off x="4215384" y="5047488"/>
-            <a:ext cx="2834640" cy="201168"/>
-          </a:xfrm>
-          <a:prstGeom prst="rect">
-            <a:avLst/>
-          </a:prstGeom>
-          <a:noFill/>
-          <a:ln/>
-        </p:spPr>
-        <p:txBody>
-          <a:bodyPr wrap="square" lIns="0" tIns="0" rIns="0" bIns="0" rtlCol="0" anchor="t"/>
-          <a:lstStyle/>
-          <a:p>
-            <a:pPr indent="0" marL="0">
-              <a:buNone/>
-            </a:pPr>
-            <a:r>
-              <a:rPr lang="en-US" sz="850" dirty="0">
-                <a:solidFill>
-                  <a:srgbClr val="9AA6B2"/>
-                </a:solidFill>
-                <a:latin typeface="Arial" pitchFamily="34" charset="0"/>
-                <a:ea typeface="Arial" pitchFamily="34" charset="-122"/>
-                <a:cs typeface="Arial" pitchFamily="34" charset="-120"/>
-              </a:rPr>
-              <a:t>Ferrari model exists, price not yet known</a:t>
-            </a:r>
-            <a:endParaRPr lang="en-US" sz="850" dirty="0"/>
-          </a:p>
-        </p:txBody>
-      </p:sp>
-      <p:sp>
-        <p:nvSpPr>
-          <p:cNvPr id="23" name="Text 16"/>
+          <p:cNvPr id="21" name="Text 14"/>
           <p:cNvSpPr txBox="1"/>
           <p:nvPr/>
         </p:nvSpPr>
@@ -4989,7 +4946,7 @@
                 <a:ea typeface="Arial" pitchFamily="34" charset="-122"/>
                 <a:cs typeface="Arial" pitchFamily="34" charset="-120"/>
               </a:rPr>
-              <a:t>Source: Indonesia import records, HS 84269100 + 84264900, Jan 2023 – 14 Aug 2026; truck-mounted knuckle boom cranes only, Zoomlion excluded. Best-selling model = most units in the class (variants merged). Competitor price = average import unit price × Rp 17.803/USD (JISDOR 23 Sep 2026) + import duty (0% China – ACFTA; 5% Europe, assumed), PPN 11%, PPh 22 2.5% — import cost before distributor margin. Ferrari = catalogue model closest in tm to the best seller; price = TSP selling price to customers, crane only, incl. GP, warranty and tax. Prices rounded to Rp 10.000.000.</a:t>
+              <a:t>Source: Indonesia import records, HS 84269100 + 84264900, Jan 2023 – 14 Aug 2026; truck-mounted knuckle boom cranes only, Zoomlion excluded. Best-selling model = most units in the class (variants merged). Competitor price = average import unit price × Rp 17.803/USD (JISDOR 23 Sep 2026) + import duty (0% China – ACFTA; 5% Europe, assumed), PPN 11%, PPh 22 2.5% — import cost before distributor margin. Ferrari = catalogue model closest in tm to the best seller; price = TSP selling price to customers, crane only, incl. GP, warranty and tax. 7441C estimate = FBR350R A4 price + 4.9 tm × Rp 40.311.952 per tm (price step from FBR350R A4 to 746 A4 in the price list). Prices rounded to Rp 10.000.000.</a:t>
             </a:r>
             <a:endParaRPr lang="en-US" sz="750" dirty="0"/>
           </a:p>
@@ -5099,7 +5056,7 @@
                 <a:ea typeface="Arial" pitchFamily="34" charset="-122"/>
                 <a:cs typeface="Arial" pitchFamily="34" charset="-120"/>
               </a:rPr>
-              <a:t>In Heavy, F.lli Ferrari has a priced crane for 34% of units; the &gt;50–55 tm class (55%) has no Ferrari model (PK 53002 leads)</a:t>
+              <a:t>In Heavy, F.lli Ferrari has a priced crane for 45% of units; the &gt;50–55 tm class (55%) has no Ferrari model (PK 53002 leads)</a:t>
             </a:r>
             <a:endParaRPr lang="en-US" sz="1800" dirty="0"/>
           </a:p>
@@ -5935,7 +5892,7 @@
                   </a:tcPr>
                 </a:tc>
               </a:tr>
-              <a:tr h="535577">
+              <a:tr h="731520">
                 <a:tc>
                   <a:txBody>
                     <a:bodyPr/>
@@ -6606,7 +6563,7 @@
                   </a:tcPr>
                 </a:tc>
               </a:tr>
-              <a:tr h="535577">
+              <a:tr h="731520">
                 <a:tc>
                   <a:txBody>
                     <a:bodyPr/>
@@ -7147,7 +7104,7 @@
                   <a:tcPr/>
                 </a:tc>
               </a:tr>
-              <a:tr h="535577">
+              <a:tr h="731520">
                 <a:tc>
                   <a:txBody>
                     <a:bodyPr/>
@@ -7165,7 +7122,28 @@
                           <a:ea typeface="Arial" pitchFamily="34" charset="-122"/>
                           <a:cs typeface="Arial" pitchFamily="34" charset="-120"/>
                         </a:rPr>
-                        <a:t>&gt;55–60 tm</a:t>
+                        <a:t>&gt;55 tm</a:t>
+                      </a:r>
+                      <a:endParaRPr lang="en-US" sz="1100" dirty="0">
+                        <a:latin typeface="Arial" charset="0"/>
+                        <a:ea typeface="Arial" charset="0"/>
+                        <a:cs typeface="Arial" charset="0"/>
+                      </a:endParaRPr>
+                    </a:p>
+                    <a:p>
+                      <a:pPr algn="ctr" indent="0" marL="0">
+                        <a:buNone/>
+                      </a:pPr>
+                      <a:r>
+                        <a:rPr lang="en-US" sz="800" dirty="0">
+                          <a:solidFill>
+                            <a:srgbClr val="9AA6B2"/>
+                          </a:solidFill>
+                          <a:latin typeface="Arial" pitchFamily="34" charset="0"/>
+                          <a:ea typeface="Arial" pitchFamily="34" charset="-122"/>
+                          <a:cs typeface="Arial" pitchFamily="34" charset="-120"/>
+                        </a:rPr>
+                        <a:t>7 models</a:t>
                       </a:r>
                       <a:endParaRPr lang="en-US" sz="1100" dirty="0">
                         <a:latin typeface="Arial" charset="0"/>
@@ -7233,7 +7211,7 @@
                           <a:ea typeface="Arial" pitchFamily="34" charset="-122"/>
                           <a:cs typeface="Arial" pitchFamily="34" charset="-120"/>
                         </a:rPr>
-                        <a:t>3</a:t>
+                        <a:t>11</a:t>
                       </a:r>
                       <a:endParaRPr lang="en-US" sz="1100" dirty="0">
                         <a:latin typeface="Arial" charset="0"/>
@@ -7358,7 +7336,7 @@
                           <a:ea typeface="Arial" pitchFamily="34" charset="-122"/>
                           <a:cs typeface="Arial" pitchFamily="34" charset="-120"/>
                         </a:rPr>
-                        <a:t>HB660R</a:t>
+                        <a:t>PK 76002 EH D</a:t>
                       </a:r>
                       <a:endParaRPr lang="en-US" sz="1100" dirty="0">
                         <a:latin typeface="Arial" charset="0"/>
@@ -7426,7 +7404,7 @@
                           <a:ea typeface="Arial" pitchFamily="34" charset="-122"/>
                           <a:cs typeface="Arial" pitchFamily="34" charset="-120"/>
                         </a:rPr>
-                        <a:t>60</a:t>
+                        <a:t>71.6</a:t>
                       </a:r>
                       <a:endParaRPr lang="en-US" sz="1100" dirty="0">
                         <a:latin typeface="Arial" charset="0"/>
@@ -7494,7 +7472,7 @@
                           <a:ea typeface="Arial" pitchFamily="34" charset="-122"/>
                           <a:cs typeface="Arial" pitchFamily="34" charset="-120"/>
                         </a:rPr>
-                        <a:t>2 · 67%</a:t>
+                        <a:t>2 · 18%</a:t>
                       </a:r>
                       <a:endParaRPr lang="en-US" sz="1100" dirty="0">
                         <a:latin typeface="Arial" charset="0"/>
@@ -7562,7 +7540,7 @@
                           <a:ea typeface="Arial" pitchFamily="34" charset="-122"/>
                           <a:cs typeface="Arial" pitchFamily="34" charset="-120"/>
                         </a:rPr>
-                        <a:t>Rp 1.840.000.000</a:t>
+                        <a:t>Rp 2.290.000.000</a:t>
                       </a:r>
                       <a:endParaRPr lang="en-US" sz="1100" dirty="0">
                         <a:latin typeface="Arial" charset="0"/>
@@ -7816,2430 +7794,6 @@
                       <a:srgbClr val="3A0E14"/>
                     </a:solidFill>
                   </a:tcPr>
-                </a:tc>
-              </a:tr>
-              <a:tr h="535577">
-                <a:tc>
-                  <a:txBody>
-                    <a:bodyPr/>
-                    <a:lstStyle/>
-                    <a:p>
-                      <a:pPr algn="ctr" indent="0" marL="0">
-                        <a:buNone/>
-                      </a:pPr>
-                      <a:r>
-                        <a:rPr lang="en-US" sz="1100" b="1" dirty="0">
-                          <a:solidFill>
-                            <a:srgbClr val="4F9CF9"/>
-                          </a:solidFill>
-                          <a:latin typeface="Arial" pitchFamily="34" charset="0"/>
-                          <a:ea typeface="Arial" pitchFamily="34" charset="-122"/>
-                          <a:cs typeface="Arial" pitchFamily="34" charset="-120"/>
-                        </a:rPr>
-                        <a:t>&gt;60–65 tm</a:t>
-                      </a:r>
-                      <a:endParaRPr lang="en-US" sz="1100" dirty="0">
-                        <a:latin typeface="Arial" charset="0"/>
-                        <a:ea typeface="Arial" charset="0"/>
-                        <a:cs typeface="Arial" charset="0"/>
-                      </a:endParaRPr>
-                    </a:p>
-                  </a:txBody>
-                  <a:tcPr marL="45720" marR="45720" marT="18288" marB="18288" anchor="ctr">
-                    <a:lnL w="12700" cap="flat" cmpd="sng" algn="ctr">
-                      <a:solidFill>
-                        <a:srgbClr val="0F141A"/>
-                      </a:solidFill>
-                      <a:prstDash val="solid"/>
-                      <a:round/>
-                      <a:headEnd type="none" w="med" len="med"/>
-                      <a:tailEnd type="none" w="med" len="med"/>
-                    </a:lnL>
-                    <a:lnR w="12700" cap="flat" cmpd="sng" algn="ctr">
-                      <a:solidFill>
-                        <a:srgbClr val="0F141A"/>
-                      </a:solidFill>
-                      <a:prstDash val="solid"/>
-                      <a:round/>
-                      <a:headEnd type="none" w="med" len="med"/>
-                      <a:tailEnd type="none" w="med" len="med"/>
-                    </a:lnR>
-                    <a:lnT w="12700" cap="flat" cmpd="sng" algn="ctr">
-                      <a:solidFill>
-                        <a:srgbClr val="0F141A"/>
-                      </a:solidFill>
-                      <a:prstDash val="solid"/>
-                      <a:round/>
-                      <a:headEnd type="none" w="med" len="med"/>
-                      <a:tailEnd type="none" w="med" len="med"/>
-                    </a:lnT>
-                    <a:lnB w="12700" cap="flat" cmpd="sng" algn="ctr">
-                      <a:solidFill>
-                        <a:srgbClr val="0F141A"/>
-                      </a:solidFill>
-                      <a:prstDash val="solid"/>
-                      <a:round/>
-                      <a:headEnd type="none" w="med" len="med"/>
-                      <a:tailEnd type="none" w="med" len="med"/>
-                    </a:lnB>
-                    <a:solidFill>
-                      <a:srgbClr val="161D25"/>
-                    </a:solidFill>
-                  </a:tcPr>
-                </a:tc>
-                <a:tc>
-                  <a:txBody>
-                    <a:bodyPr/>
-                    <a:lstStyle/>
-                    <a:p>
-                      <a:pPr algn="ctr" indent="0" marL="0">
-                        <a:buNone/>
-                      </a:pPr>
-                      <a:r>
-                        <a:rPr lang="en-US" sz="1100" dirty="0">
-                          <a:solidFill>
-                            <a:srgbClr val="EEF1F4"/>
-                          </a:solidFill>
-                          <a:latin typeface="Arial" pitchFamily="34" charset="0"/>
-                          <a:ea typeface="Arial" pitchFamily="34" charset="-122"/>
-                          <a:cs typeface="Arial" pitchFamily="34" charset="-120"/>
-                        </a:rPr>
-                        <a:t>1</a:t>
-                      </a:r>
-                      <a:endParaRPr lang="en-US" sz="1100" dirty="0">
-                        <a:latin typeface="Arial" charset="0"/>
-                        <a:ea typeface="Arial" charset="0"/>
-                        <a:cs typeface="Arial" charset="0"/>
-                      </a:endParaRPr>
-                    </a:p>
-                  </a:txBody>
-                  <a:tcPr marL="45720" marR="45720" marT="18288" marB="18288" anchor="ctr">
-                    <a:lnL w="12700" cap="flat" cmpd="sng" algn="ctr">
-                      <a:solidFill>
-                        <a:srgbClr val="0F141A"/>
-                      </a:solidFill>
-                      <a:prstDash val="solid"/>
-                      <a:round/>
-                      <a:headEnd type="none" w="med" len="med"/>
-                      <a:tailEnd type="none" w="med" len="med"/>
-                    </a:lnL>
-                    <a:lnR w="12700" cap="flat" cmpd="sng" algn="ctr">
-                      <a:solidFill>
-                        <a:srgbClr val="0F141A"/>
-                      </a:solidFill>
-                      <a:prstDash val="solid"/>
-                      <a:round/>
-                      <a:headEnd type="none" w="med" len="med"/>
-                      <a:tailEnd type="none" w="med" len="med"/>
-                    </a:lnR>
-                    <a:lnT w="12700" cap="flat" cmpd="sng" algn="ctr">
-                      <a:solidFill>
-                        <a:srgbClr val="0F141A"/>
-                      </a:solidFill>
-                      <a:prstDash val="solid"/>
-                      <a:round/>
-                      <a:headEnd type="none" w="med" len="med"/>
-                      <a:tailEnd type="none" w="med" len="med"/>
-                    </a:lnT>
-                    <a:lnB w="12700" cap="flat" cmpd="sng" algn="ctr">
-                      <a:solidFill>
-                        <a:srgbClr val="0F141A"/>
-                      </a:solidFill>
-                      <a:prstDash val="solid"/>
-                      <a:round/>
-                      <a:headEnd type="none" w="med" len="med"/>
-                      <a:tailEnd type="none" w="med" len="med"/>
-                    </a:lnB>
-                    <a:solidFill>
-                      <a:srgbClr val="161D25"/>
-                    </a:solidFill>
-                  </a:tcPr>
-                </a:tc>
-                <a:tc>
-                  <a:txBody>
-                    <a:bodyPr/>
-                    <a:lstStyle/>
-                    <a:p>
-                      <a:pPr algn="ctr" indent="0" marL="0">
-                        <a:buNone/>
-                      </a:pPr>
-                      <a:endParaRPr lang="en-US" sz="1100" dirty="0">
-                        <a:latin typeface="Arial" charset="0"/>
-                        <a:ea typeface="Arial" charset="0"/>
-                        <a:cs typeface="Arial" charset="0"/>
-                      </a:endParaRPr>
-                    </a:p>
-                  </a:txBody>
-                  <a:tcPr marL="45720" marR="45720" marT="18288" marB="18288" anchor="ctr">
-                    <a:lnL w="12700" cap="flat" cmpd="sng" algn="ctr">
-                      <a:solidFill>
-                        <a:srgbClr val="0F141A"/>
-                      </a:solidFill>
-                      <a:prstDash val="solid"/>
-                      <a:round/>
-                      <a:headEnd type="none" w="med" len="med"/>
-                      <a:tailEnd type="none" w="med" len="med"/>
-                    </a:lnL>
-                    <a:lnR w="12700" cap="flat" cmpd="sng" algn="ctr">
-                      <a:solidFill>
-                        <a:srgbClr val="0F141A"/>
-                      </a:solidFill>
-                      <a:prstDash val="solid"/>
-                      <a:round/>
-                      <a:headEnd type="none" w="med" len="med"/>
-                      <a:tailEnd type="none" w="med" len="med"/>
-                    </a:lnR>
-                    <a:lnT w="12700" cap="flat" cmpd="sng" algn="ctr">
-                      <a:solidFill>
-                        <a:srgbClr val="0F141A"/>
-                      </a:solidFill>
-                      <a:prstDash val="solid"/>
-                      <a:round/>
-                      <a:headEnd type="none" w="med" len="med"/>
-                      <a:tailEnd type="none" w="med" len="med"/>
-                    </a:lnT>
-                    <a:lnB w="12700" cap="flat" cmpd="sng" algn="ctr">
-                      <a:solidFill>
-                        <a:srgbClr val="0F141A"/>
-                      </a:solidFill>
-                      <a:prstDash val="solid"/>
-                      <a:round/>
-                      <a:headEnd type="none" w="med" len="med"/>
-                      <a:tailEnd type="none" w="med" len="med"/>
-                    </a:lnB>
-                    <a:solidFill>
-                      <a:srgbClr val="161D25"/>
-                    </a:solidFill>
-                  </a:tcPr>
-                </a:tc>
-                <a:tc>
-                  <a:txBody>
-                    <a:bodyPr/>
-                    <a:lstStyle/>
-                    <a:p>
-                      <a:pPr algn="ctr" indent="0" marL="0">
-                        <a:buNone/>
-                      </a:pPr>
-                      <a:r>
-                        <a:rPr lang="en-US" sz="1100" b="1" dirty="0">
-                          <a:solidFill>
-                            <a:srgbClr val="EEF1F4"/>
-                          </a:solidFill>
-                          <a:latin typeface="Arial" pitchFamily="34" charset="0"/>
-                          <a:ea typeface="Arial" pitchFamily="34" charset="-122"/>
-                          <a:cs typeface="Arial" pitchFamily="34" charset="-120"/>
-                        </a:rPr>
-                        <a:t>SPK61502</a:t>
-                      </a:r>
-                      <a:endParaRPr lang="en-US" sz="1100" dirty="0">
-                        <a:latin typeface="Arial" charset="0"/>
-                        <a:ea typeface="Arial" charset="0"/>
-                        <a:cs typeface="Arial" charset="0"/>
-                      </a:endParaRPr>
-                    </a:p>
-                  </a:txBody>
-                  <a:tcPr marL="45720" marR="45720" marT="18288" marB="18288" anchor="ctr">
-                    <a:lnL w="12700" cap="flat" cmpd="sng" algn="ctr">
-                      <a:solidFill>
-                        <a:srgbClr val="0F141A"/>
-                      </a:solidFill>
-                      <a:prstDash val="solid"/>
-                      <a:round/>
-                      <a:headEnd type="none" w="med" len="med"/>
-                      <a:tailEnd type="none" w="med" len="med"/>
-                    </a:lnL>
-                    <a:lnR w="12700" cap="flat" cmpd="sng" algn="ctr">
-                      <a:solidFill>
-                        <a:srgbClr val="0F141A"/>
-                      </a:solidFill>
-                      <a:prstDash val="solid"/>
-                      <a:round/>
-                      <a:headEnd type="none" w="med" len="med"/>
-                      <a:tailEnd type="none" w="med" len="med"/>
-                    </a:lnR>
-                    <a:lnT w="12700" cap="flat" cmpd="sng" algn="ctr">
-                      <a:solidFill>
-                        <a:srgbClr val="0F141A"/>
-                      </a:solidFill>
-                      <a:prstDash val="solid"/>
-                      <a:round/>
-                      <a:headEnd type="none" w="med" len="med"/>
-                      <a:tailEnd type="none" w="med" len="med"/>
-                    </a:lnT>
-                    <a:lnB w="12700" cap="flat" cmpd="sng" algn="ctr">
-                      <a:solidFill>
-                        <a:srgbClr val="0F141A"/>
-                      </a:solidFill>
-                      <a:prstDash val="solid"/>
-                      <a:round/>
-                      <a:headEnd type="none" w="med" len="med"/>
-                      <a:tailEnd type="none" w="med" len="med"/>
-                    </a:lnB>
-                    <a:solidFill>
-                      <a:srgbClr val="161D25"/>
-                    </a:solidFill>
-                  </a:tcPr>
-                </a:tc>
-                <a:tc>
-                  <a:txBody>
-                    <a:bodyPr/>
-                    <a:lstStyle/>
-                    <a:p>
-                      <a:pPr algn="ctr" indent="0" marL="0">
-                        <a:buNone/>
-                      </a:pPr>
-                      <a:r>
-                        <a:rPr lang="en-US" sz="1100" dirty="0">
-                          <a:solidFill>
-                            <a:srgbClr val="EEF1F4"/>
-                          </a:solidFill>
-                          <a:latin typeface="Arial" pitchFamily="34" charset="0"/>
-                          <a:ea typeface="Arial" pitchFamily="34" charset="-122"/>
-                          <a:cs typeface="Arial" pitchFamily="34" charset="-120"/>
-                        </a:rPr>
-                        <a:t>61.5</a:t>
-                      </a:r>
-                      <a:endParaRPr lang="en-US" sz="1100" dirty="0">
-                        <a:latin typeface="Arial" charset="0"/>
-                        <a:ea typeface="Arial" charset="0"/>
-                        <a:cs typeface="Arial" charset="0"/>
-                      </a:endParaRPr>
-                    </a:p>
-                  </a:txBody>
-                  <a:tcPr marL="45720" marR="45720" marT="18288" marB="18288" anchor="ctr">
-                    <a:lnL w="12700" cap="flat" cmpd="sng" algn="ctr">
-                      <a:solidFill>
-                        <a:srgbClr val="0F141A"/>
-                      </a:solidFill>
-                      <a:prstDash val="solid"/>
-                      <a:round/>
-                      <a:headEnd type="none" w="med" len="med"/>
-                      <a:tailEnd type="none" w="med" len="med"/>
-                    </a:lnL>
-                    <a:lnR w="12700" cap="flat" cmpd="sng" algn="ctr">
-                      <a:solidFill>
-                        <a:srgbClr val="0F141A"/>
-                      </a:solidFill>
-                      <a:prstDash val="solid"/>
-                      <a:round/>
-                      <a:headEnd type="none" w="med" len="med"/>
-                      <a:tailEnd type="none" w="med" len="med"/>
-                    </a:lnR>
-                    <a:lnT w="12700" cap="flat" cmpd="sng" algn="ctr">
-                      <a:solidFill>
-                        <a:srgbClr val="0F141A"/>
-                      </a:solidFill>
-                      <a:prstDash val="solid"/>
-                      <a:round/>
-                      <a:headEnd type="none" w="med" len="med"/>
-                      <a:tailEnd type="none" w="med" len="med"/>
-                    </a:lnT>
-                    <a:lnB w="12700" cap="flat" cmpd="sng" algn="ctr">
-                      <a:solidFill>
-                        <a:srgbClr val="0F141A"/>
-                      </a:solidFill>
-                      <a:prstDash val="solid"/>
-                      <a:round/>
-                      <a:headEnd type="none" w="med" len="med"/>
-                      <a:tailEnd type="none" w="med" len="med"/>
-                    </a:lnB>
-                    <a:solidFill>
-                      <a:srgbClr val="161D25"/>
-                    </a:solidFill>
-                  </a:tcPr>
-                </a:tc>
-                <a:tc>
-                  <a:txBody>
-                    <a:bodyPr/>
-                    <a:lstStyle/>
-                    <a:p>
-                      <a:pPr algn="ctr" indent="0" marL="0">
-                        <a:buNone/>
-                      </a:pPr>
-                      <a:r>
-                        <a:rPr lang="en-US" sz="1100" dirty="0">
-                          <a:solidFill>
-                            <a:srgbClr val="EEF1F4"/>
-                          </a:solidFill>
-                          <a:latin typeface="Arial" pitchFamily="34" charset="0"/>
-                          <a:ea typeface="Arial" pitchFamily="34" charset="-122"/>
-                          <a:cs typeface="Arial" pitchFamily="34" charset="-120"/>
-                        </a:rPr>
-                        <a:t>1 · 100%</a:t>
-                      </a:r>
-                      <a:endParaRPr lang="en-US" sz="1100" dirty="0">
-                        <a:latin typeface="Arial" charset="0"/>
-                        <a:ea typeface="Arial" charset="0"/>
-                        <a:cs typeface="Arial" charset="0"/>
-                      </a:endParaRPr>
-                    </a:p>
-                  </a:txBody>
-                  <a:tcPr marL="45720" marR="45720" marT="18288" marB="18288" anchor="ctr">
-                    <a:lnL w="12700" cap="flat" cmpd="sng" algn="ctr">
-                      <a:solidFill>
-                        <a:srgbClr val="0F141A"/>
-                      </a:solidFill>
-                      <a:prstDash val="solid"/>
-                      <a:round/>
-                      <a:headEnd type="none" w="med" len="med"/>
-                      <a:tailEnd type="none" w="med" len="med"/>
-                    </a:lnL>
-                    <a:lnR w="12700" cap="flat" cmpd="sng" algn="ctr">
-                      <a:solidFill>
-                        <a:srgbClr val="0F141A"/>
-                      </a:solidFill>
-                      <a:prstDash val="solid"/>
-                      <a:round/>
-                      <a:headEnd type="none" w="med" len="med"/>
-                      <a:tailEnd type="none" w="med" len="med"/>
-                    </a:lnR>
-                    <a:lnT w="12700" cap="flat" cmpd="sng" algn="ctr">
-                      <a:solidFill>
-                        <a:srgbClr val="0F141A"/>
-                      </a:solidFill>
-                      <a:prstDash val="solid"/>
-                      <a:round/>
-                      <a:headEnd type="none" w="med" len="med"/>
-                      <a:tailEnd type="none" w="med" len="med"/>
-                    </a:lnT>
-                    <a:lnB w="12700" cap="flat" cmpd="sng" algn="ctr">
-                      <a:solidFill>
-                        <a:srgbClr val="0F141A"/>
-                      </a:solidFill>
-                      <a:prstDash val="solid"/>
-                      <a:round/>
-                      <a:headEnd type="none" w="med" len="med"/>
-                      <a:tailEnd type="none" w="med" len="med"/>
-                    </a:lnB>
-                    <a:solidFill>
-                      <a:srgbClr val="161D25"/>
-                    </a:solidFill>
-                  </a:tcPr>
-                </a:tc>
-                <a:tc>
-                  <a:txBody>
-                    <a:bodyPr/>
-                    <a:lstStyle/>
-                    <a:p>
-                      <a:pPr algn="ctr" indent="0" marL="0">
-                        <a:buNone/>
-                      </a:pPr>
-                      <a:r>
-                        <a:rPr lang="en-US" sz="1100" dirty="0">
-                          <a:solidFill>
-                            <a:srgbClr val="EEF1F4"/>
-                          </a:solidFill>
-                          <a:latin typeface="Arial" pitchFamily="34" charset="0"/>
-                          <a:ea typeface="Arial" pitchFamily="34" charset="-122"/>
-                          <a:cs typeface="Arial" pitchFamily="34" charset="-120"/>
-                        </a:rPr>
-                        <a:t>Rp 1.400.000.000</a:t>
-                      </a:r>
-                      <a:endParaRPr lang="en-US" sz="1100" dirty="0">
-                        <a:latin typeface="Arial" charset="0"/>
-                        <a:ea typeface="Arial" charset="0"/>
-                        <a:cs typeface="Arial" charset="0"/>
-                      </a:endParaRPr>
-                    </a:p>
-                  </a:txBody>
-                  <a:tcPr marL="45720" marR="45720" marT="18288" marB="18288" anchor="ctr">
-                    <a:lnL w="12700" cap="flat" cmpd="sng" algn="ctr">
-                      <a:solidFill>
-                        <a:srgbClr val="0F141A"/>
-                      </a:solidFill>
-                      <a:prstDash val="solid"/>
-                      <a:round/>
-                      <a:headEnd type="none" w="med" len="med"/>
-                      <a:tailEnd type="none" w="med" len="med"/>
-                    </a:lnL>
-                    <a:lnR w="12700" cap="flat" cmpd="sng" algn="ctr">
-                      <a:solidFill>
-                        <a:srgbClr val="0F141A"/>
-                      </a:solidFill>
-                      <a:prstDash val="solid"/>
-                      <a:round/>
-                      <a:headEnd type="none" w="med" len="med"/>
-                      <a:tailEnd type="none" w="med" len="med"/>
-                    </a:lnR>
-                    <a:lnT w="12700" cap="flat" cmpd="sng" algn="ctr">
-                      <a:solidFill>
-                        <a:srgbClr val="0F141A"/>
-                      </a:solidFill>
-                      <a:prstDash val="solid"/>
-                      <a:round/>
-                      <a:headEnd type="none" w="med" len="med"/>
-                      <a:tailEnd type="none" w="med" len="med"/>
-                    </a:lnT>
-                    <a:lnB w="12700" cap="flat" cmpd="sng" algn="ctr">
-                      <a:solidFill>
-                        <a:srgbClr val="0F141A"/>
-                      </a:solidFill>
-                      <a:prstDash val="solid"/>
-                      <a:round/>
-                      <a:headEnd type="none" w="med" len="med"/>
-                      <a:tailEnd type="none" w="med" len="med"/>
-                    </a:lnB>
-                    <a:solidFill>
-                      <a:srgbClr val="161D25"/>
-                    </a:solidFill>
-                  </a:tcPr>
-                </a:tc>
-                <a:tc>
-                  <a:txBody>
-                    <a:bodyPr/>
-                    <a:lstStyle/>
-                    <a:p>
-                      <a:pPr algn="ctr" indent="0" marL="0">
-                        <a:buNone/>
-                      </a:pPr>
-                      <a:r>
-                        <a:rPr lang="en-US" sz="1100" b="1" dirty="0">
-                          <a:solidFill>
-                            <a:srgbClr val="EEF1F4"/>
-                          </a:solidFill>
-                          <a:latin typeface="Arial" pitchFamily="34" charset="0"/>
-                          <a:ea typeface="Arial" pitchFamily="34" charset="-122"/>
-                          <a:cs typeface="Arial" pitchFamily="34" charset="-120"/>
-                        </a:rPr>
-                        <a:t>9661C</a:t>
-                      </a:r>
-                      <a:endParaRPr lang="en-US" sz="1100" dirty="0">
-                        <a:latin typeface="Arial" charset="0"/>
-                        <a:ea typeface="Arial" charset="0"/>
-                        <a:cs typeface="Arial" charset="0"/>
-                      </a:endParaRPr>
-                    </a:p>
-                  </a:txBody>
-                  <a:tcPr marL="45720" marR="45720" marT="18288" marB="18288" anchor="ctr">
-                    <a:lnL w="12700" cap="flat" cmpd="sng" algn="ctr">
-                      <a:solidFill>
-                        <a:srgbClr val="0F141A"/>
-                      </a:solidFill>
-                      <a:prstDash val="solid"/>
-                      <a:round/>
-                      <a:headEnd type="none" w="med" len="med"/>
-                      <a:tailEnd type="none" w="med" len="med"/>
-                    </a:lnL>
-                    <a:lnR w="12700" cap="flat" cmpd="sng" algn="ctr">
-                      <a:solidFill>
-                        <a:srgbClr val="0F141A"/>
-                      </a:solidFill>
-                      <a:prstDash val="solid"/>
-                      <a:round/>
-                      <a:headEnd type="none" w="med" len="med"/>
-                      <a:tailEnd type="none" w="med" len="med"/>
-                    </a:lnR>
-                    <a:lnT w="12700" cap="flat" cmpd="sng" algn="ctr">
-                      <a:solidFill>
-                        <a:srgbClr val="0F141A"/>
-                      </a:solidFill>
-                      <a:prstDash val="solid"/>
-                      <a:round/>
-                      <a:headEnd type="none" w="med" len="med"/>
-                      <a:tailEnd type="none" w="med" len="med"/>
-                    </a:lnT>
-                    <a:lnB w="12700" cap="flat" cmpd="sng" algn="ctr">
-                      <a:solidFill>
-                        <a:srgbClr val="0F141A"/>
-                      </a:solidFill>
-                      <a:prstDash val="solid"/>
-                      <a:round/>
-                      <a:headEnd type="none" w="med" len="med"/>
-                      <a:tailEnd type="none" w="med" len="med"/>
-                    </a:lnB>
-                    <a:solidFill>
-                      <a:srgbClr val="161D25"/>
-                    </a:solidFill>
-                  </a:tcPr>
-                </a:tc>
-                <a:tc>
-                  <a:txBody>
-                    <a:bodyPr/>
-                    <a:lstStyle/>
-                    <a:p>
-                      <a:pPr algn="ctr" indent="0" marL="0">
-                        <a:buNone/>
-                      </a:pPr>
-                      <a:r>
-                        <a:rPr lang="en-US" sz="1100" dirty="0">
-                          <a:solidFill>
-                            <a:srgbClr val="EEF1F4"/>
-                          </a:solidFill>
-                          <a:latin typeface="Arial" pitchFamily="34" charset="0"/>
-                          <a:ea typeface="Arial" pitchFamily="34" charset="-122"/>
-                          <a:cs typeface="Arial" pitchFamily="34" charset="-120"/>
-                        </a:rPr>
-                        <a:t>63.2</a:t>
-                      </a:r>
-                      <a:endParaRPr lang="en-US" sz="1100" dirty="0">
-                        <a:latin typeface="Arial" charset="0"/>
-                        <a:ea typeface="Arial" charset="0"/>
-                        <a:cs typeface="Arial" charset="0"/>
-                      </a:endParaRPr>
-                    </a:p>
-                  </a:txBody>
-                  <a:tcPr marL="45720" marR="45720" marT="18288" marB="18288" anchor="ctr">
-                    <a:lnL w="12700" cap="flat" cmpd="sng" algn="ctr">
-                      <a:solidFill>
-                        <a:srgbClr val="0F141A"/>
-                      </a:solidFill>
-                      <a:prstDash val="solid"/>
-                      <a:round/>
-                      <a:headEnd type="none" w="med" len="med"/>
-                      <a:tailEnd type="none" w="med" len="med"/>
-                    </a:lnL>
-                    <a:lnR w="12700" cap="flat" cmpd="sng" algn="ctr">
-                      <a:solidFill>
-                        <a:srgbClr val="0F141A"/>
-                      </a:solidFill>
-                      <a:prstDash val="solid"/>
-                      <a:round/>
-                      <a:headEnd type="none" w="med" len="med"/>
-                      <a:tailEnd type="none" w="med" len="med"/>
-                    </a:lnR>
-                    <a:lnT w="12700" cap="flat" cmpd="sng" algn="ctr">
-                      <a:solidFill>
-                        <a:srgbClr val="0F141A"/>
-                      </a:solidFill>
-                      <a:prstDash val="solid"/>
-                      <a:round/>
-                      <a:headEnd type="none" w="med" len="med"/>
-                      <a:tailEnd type="none" w="med" len="med"/>
-                    </a:lnT>
-                    <a:lnB w="12700" cap="flat" cmpd="sng" algn="ctr">
-                      <a:solidFill>
-                        <a:srgbClr val="0F141A"/>
-                      </a:solidFill>
-                      <a:prstDash val="solid"/>
-                      <a:round/>
-                      <a:headEnd type="none" w="med" len="med"/>
-                      <a:tailEnd type="none" w="med" len="med"/>
-                    </a:lnB>
-                    <a:solidFill>
-                      <a:srgbClr val="161D25"/>
-                    </a:solidFill>
-                  </a:tcPr>
-                </a:tc>
-                <a:tc>
-                  <a:txBody>
-                    <a:bodyPr/>
-                    <a:lstStyle/>
-                    <a:p>
-                      <a:pPr algn="ctr" indent="0" marL="0">
-                        <a:buNone/>
-                      </a:pPr>
-                      <a:r>
-                        <a:rPr lang="en-US" sz="1100" i="1" dirty="0">
-                          <a:solidFill>
-                            <a:srgbClr val="9AA6B2"/>
-                          </a:solidFill>
-                          <a:latin typeface="Arial" pitchFamily="34" charset="0"/>
-                          <a:ea typeface="Arial" pitchFamily="34" charset="-122"/>
-                          <a:cs typeface="Arial" pitchFamily="34" charset="-120"/>
-                        </a:rPr>
-                        <a:t>Price not yet known</a:t>
-                      </a:r>
-                      <a:endParaRPr lang="en-US" sz="1100" dirty="0">
-                        <a:latin typeface="Arial" charset="0"/>
-                        <a:ea typeface="Arial" charset="0"/>
-                        <a:cs typeface="Arial" charset="0"/>
-                      </a:endParaRPr>
-                    </a:p>
-                  </a:txBody>
-                  <a:tcPr marL="45720" marR="45720" marT="18288" marB="18288" anchor="ctr">
-                    <a:lnL w="12700" cap="flat" cmpd="sng" algn="ctr">
-                      <a:solidFill>
-                        <a:srgbClr val="0F141A"/>
-                      </a:solidFill>
-                      <a:prstDash val="solid"/>
-                      <a:round/>
-                      <a:headEnd type="none" w="med" len="med"/>
-                      <a:tailEnd type="none" w="med" len="med"/>
-                    </a:lnL>
-                    <a:lnR w="12700" cap="flat" cmpd="sng" algn="ctr">
-                      <a:solidFill>
-                        <a:srgbClr val="0F141A"/>
-                      </a:solidFill>
-                      <a:prstDash val="solid"/>
-                      <a:round/>
-                      <a:headEnd type="none" w="med" len="med"/>
-                      <a:tailEnd type="none" w="med" len="med"/>
-                    </a:lnR>
-                    <a:lnT w="12700" cap="flat" cmpd="sng" algn="ctr">
-                      <a:solidFill>
-                        <a:srgbClr val="0F141A"/>
-                      </a:solidFill>
-                      <a:prstDash val="solid"/>
-                      <a:round/>
-                      <a:headEnd type="none" w="med" len="med"/>
-                      <a:tailEnd type="none" w="med" len="med"/>
-                    </a:lnT>
-                    <a:lnB w="12700" cap="flat" cmpd="sng" algn="ctr">
-                      <a:solidFill>
-                        <a:srgbClr val="0F141A"/>
-                      </a:solidFill>
-                      <a:prstDash val="solid"/>
-                      <a:round/>
-                      <a:headEnd type="none" w="med" len="med"/>
-                      <a:tailEnd type="none" w="med" len="med"/>
-                    </a:lnB>
-                    <a:solidFill>
-                      <a:srgbClr val="161D25"/>
-                    </a:solidFill>
-                  </a:tcPr>
-                </a:tc>
-              </a:tr>
-              <a:tr h="535577">
-                <a:tc>
-                  <a:txBody>
-                    <a:bodyPr/>
-                    <a:lstStyle/>
-                    <a:p>
-                      <a:pPr algn="ctr" indent="0" marL="0">
-                        <a:buNone/>
-                      </a:pPr>
-                      <a:r>
-                        <a:rPr lang="en-US" sz="1100" b="1" dirty="0">
-                          <a:solidFill>
-                            <a:srgbClr val="4F9CF9"/>
-                          </a:solidFill>
-                          <a:latin typeface="Arial" pitchFamily="34" charset="0"/>
-                          <a:ea typeface="Arial" pitchFamily="34" charset="-122"/>
-                          <a:cs typeface="Arial" pitchFamily="34" charset="-120"/>
-                        </a:rPr>
-                        <a:t>&gt;70–75 tm</a:t>
-                      </a:r>
-                      <a:endParaRPr lang="en-US" sz="1100" dirty="0">
-                        <a:latin typeface="Arial" charset="0"/>
-                        <a:ea typeface="Arial" charset="0"/>
-                        <a:cs typeface="Arial" charset="0"/>
-                      </a:endParaRPr>
-                    </a:p>
-                  </a:txBody>
-                  <a:tcPr marL="45720" marR="45720" marT="18288" marB="18288" anchor="ctr">
-                    <a:lnL w="12700" cap="flat" cmpd="sng" algn="ctr">
-                      <a:solidFill>
-                        <a:srgbClr val="0F141A"/>
-                      </a:solidFill>
-                      <a:prstDash val="solid"/>
-                      <a:round/>
-                      <a:headEnd type="none" w="med" len="med"/>
-                      <a:tailEnd type="none" w="med" len="med"/>
-                    </a:lnL>
-                    <a:lnR w="12700" cap="flat" cmpd="sng" algn="ctr">
-                      <a:solidFill>
-                        <a:srgbClr val="0F141A"/>
-                      </a:solidFill>
-                      <a:prstDash val="solid"/>
-                      <a:round/>
-                      <a:headEnd type="none" w="med" len="med"/>
-                      <a:tailEnd type="none" w="med" len="med"/>
-                    </a:lnR>
-                    <a:lnT w="12700" cap="flat" cmpd="sng" algn="ctr">
-                      <a:solidFill>
-                        <a:srgbClr val="0F141A"/>
-                      </a:solidFill>
-                      <a:prstDash val="solid"/>
-                      <a:round/>
-                      <a:headEnd type="none" w="med" len="med"/>
-                      <a:tailEnd type="none" w="med" len="med"/>
-                    </a:lnT>
-                    <a:lnB w="12700" cap="flat" cmpd="sng" algn="ctr">
-                      <a:solidFill>
-                        <a:srgbClr val="0F141A"/>
-                      </a:solidFill>
-                      <a:prstDash val="solid"/>
-                      <a:round/>
-                      <a:headEnd type="none" w="med" len="med"/>
-                      <a:tailEnd type="none" w="med" len="med"/>
-                    </a:lnB>
-                    <a:solidFill>
-                      <a:srgbClr val="161D25"/>
-                    </a:solidFill>
-                  </a:tcPr>
-                </a:tc>
-                <a:tc>
-                  <a:txBody>
-                    <a:bodyPr/>
-                    <a:lstStyle/>
-                    <a:p>
-                      <a:pPr algn="ctr" indent="0" marL="0">
-                        <a:buNone/>
-                      </a:pPr>
-                      <a:r>
-                        <a:rPr lang="en-US" sz="1100" dirty="0">
-                          <a:solidFill>
-                            <a:srgbClr val="EEF1F4"/>
-                          </a:solidFill>
-                          <a:latin typeface="Arial" pitchFamily="34" charset="0"/>
-                          <a:ea typeface="Arial" pitchFamily="34" charset="-122"/>
-                          <a:cs typeface="Arial" pitchFamily="34" charset="-120"/>
-                        </a:rPr>
-                        <a:t>2</a:t>
-                      </a:r>
-                      <a:endParaRPr lang="en-US" sz="1100" dirty="0">
-                        <a:latin typeface="Arial" charset="0"/>
-                        <a:ea typeface="Arial" charset="0"/>
-                        <a:cs typeface="Arial" charset="0"/>
-                      </a:endParaRPr>
-                    </a:p>
-                  </a:txBody>
-                  <a:tcPr marL="45720" marR="45720" marT="18288" marB="18288" anchor="ctr">
-                    <a:lnL w="12700" cap="flat" cmpd="sng" algn="ctr">
-                      <a:solidFill>
-                        <a:srgbClr val="0F141A"/>
-                      </a:solidFill>
-                      <a:prstDash val="solid"/>
-                      <a:round/>
-                      <a:headEnd type="none" w="med" len="med"/>
-                      <a:tailEnd type="none" w="med" len="med"/>
-                    </a:lnL>
-                    <a:lnR w="12700" cap="flat" cmpd="sng" algn="ctr">
-                      <a:solidFill>
-                        <a:srgbClr val="0F141A"/>
-                      </a:solidFill>
-                      <a:prstDash val="solid"/>
-                      <a:round/>
-                      <a:headEnd type="none" w="med" len="med"/>
-                      <a:tailEnd type="none" w="med" len="med"/>
-                    </a:lnR>
-                    <a:lnT w="12700" cap="flat" cmpd="sng" algn="ctr">
-                      <a:solidFill>
-                        <a:srgbClr val="0F141A"/>
-                      </a:solidFill>
-                      <a:prstDash val="solid"/>
-                      <a:round/>
-                      <a:headEnd type="none" w="med" len="med"/>
-                      <a:tailEnd type="none" w="med" len="med"/>
-                    </a:lnT>
-                    <a:lnB w="12700" cap="flat" cmpd="sng" algn="ctr">
-                      <a:solidFill>
-                        <a:srgbClr val="0F141A"/>
-                      </a:solidFill>
-                      <a:prstDash val="solid"/>
-                      <a:round/>
-                      <a:headEnd type="none" w="med" len="med"/>
-                      <a:tailEnd type="none" w="med" len="med"/>
-                    </a:lnB>
-                    <a:solidFill>
-                      <a:srgbClr val="161D25"/>
-                    </a:solidFill>
-                  </a:tcPr>
-                </a:tc>
-                <a:tc>
-                  <a:txBody>
-                    <a:bodyPr/>
-                    <a:lstStyle/>
-                    <a:p>
-                      <a:pPr algn="ctr" indent="0" marL="0">
-                        <a:buNone/>
-                      </a:pPr>
-                      <a:endParaRPr lang="en-US" sz="1100" dirty="0">
-                        <a:latin typeface="Arial" charset="0"/>
-                        <a:ea typeface="Arial" charset="0"/>
-                        <a:cs typeface="Arial" charset="0"/>
-                      </a:endParaRPr>
-                    </a:p>
-                  </a:txBody>
-                  <a:tcPr marL="45720" marR="45720" marT="18288" marB="18288" anchor="ctr">
-                    <a:lnL w="12700" cap="flat" cmpd="sng" algn="ctr">
-                      <a:solidFill>
-                        <a:srgbClr val="0F141A"/>
-                      </a:solidFill>
-                      <a:prstDash val="solid"/>
-                      <a:round/>
-                      <a:headEnd type="none" w="med" len="med"/>
-                      <a:tailEnd type="none" w="med" len="med"/>
-                    </a:lnL>
-                    <a:lnR w="12700" cap="flat" cmpd="sng" algn="ctr">
-                      <a:solidFill>
-                        <a:srgbClr val="0F141A"/>
-                      </a:solidFill>
-                      <a:prstDash val="solid"/>
-                      <a:round/>
-                      <a:headEnd type="none" w="med" len="med"/>
-                      <a:tailEnd type="none" w="med" len="med"/>
-                    </a:lnR>
-                    <a:lnT w="12700" cap="flat" cmpd="sng" algn="ctr">
-                      <a:solidFill>
-                        <a:srgbClr val="0F141A"/>
-                      </a:solidFill>
-                      <a:prstDash val="solid"/>
-                      <a:round/>
-                      <a:headEnd type="none" w="med" len="med"/>
-                      <a:tailEnd type="none" w="med" len="med"/>
-                    </a:lnT>
-                    <a:lnB w="12700" cap="flat" cmpd="sng" algn="ctr">
-                      <a:solidFill>
-                        <a:srgbClr val="0F141A"/>
-                      </a:solidFill>
-                      <a:prstDash val="solid"/>
-                      <a:round/>
-                      <a:headEnd type="none" w="med" len="med"/>
-                      <a:tailEnd type="none" w="med" len="med"/>
-                    </a:lnB>
-                    <a:solidFill>
-                      <a:srgbClr val="161D25"/>
-                    </a:solidFill>
-                  </a:tcPr>
-                </a:tc>
-                <a:tc>
-                  <a:txBody>
-                    <a:bodyPr/>
-                    <a:lstStyle/>
-                    <a:p>
-                      <a:pPr algn="ctr" indent="0" marL="0">
-                        <a:buNone/>
-                      </a:pPr>
-                      <a:r>
-                        <a:rPr lang="en-US" sz="1100" b="1" dirty="0">
-                          <a:solidFill>
-                            <a:srgbClr val="EEF1F4"/>
-                          </a:solidFill>
-                          <a:latin typeface="Arial" pitchFamily="34" charset="0"/>
-                          <a:ea typeface="Arial" pitchFamily="34" charset="-122"/>
-                          <a:cs typeface="Arial" pitchFamily="34" charset="-120"/>
-                        </a:rPr>
-                        <a:t>PK 76002 EH D</a:t>
-                      </a:r>
-                      <a:endParaRPr lang="en-US" sz="1100" dirty="0">
-                        <a:latin typeface="Arial" charset="0"/>
-                        <a:ea typeface="Arial" charset="0"/>
-                        <a:cs typeface="Arial" charset="0"/>
-                      </a:endParaRPr>
-                    </a:p>
-                  </a:txBody>
-                  <a:tcPr marL="45720" marR="45720" marT="18288" marB="18288" anchor="ctr">
-                    <a:lnL w="12700" cap="flat" cmpd="sng" algn="ctr">
-                      <a:solidFill>
-                        <a:srgbClr val="0F141A"/>
-                      </a:solidFill>
-                      <a:prstDash val="solid"/>
-                      <a:round/>
-                      <a:headEnd type="none" w="med" len="med"/>
-                      <a:tailEnd type="none" w="med" len="med"/>
-                    </a:lnL>
-                    <a:lnR w="12700" cap="flat" cmpd="sng" algn="ctr">
-                      <a:solidFill>
-                        <a:srgbClr val="0F141A"/>
-                      </a:solidFill>
-                      <a:prstDash val="solid"/>
-                      <a:round/>
-                      <a:headEnd type="none" w="med" len="med"/>
-                      <a:tailEnd type="none" w="med" len="med"/>
-                    </a:lnR>
-                    <a:lnT w="12700" cap="flat" cmpd="sng" algn="ctr">
-                      <a:solidFill>
-                        <a:srgbClr val="0F141A"/>
-                      </a:solidFill>
-                      <a:prstDash val="solid"/>
-                      <a:round/>
-                      <a:headEnd type="none" w="med" len="med"/>
-                      <a:tailEnd type="none" w="med" len="med"/>
-                    </a:lnT>
-                    <a:lnB w="12700" cap="flat" cmpd="sng" algn="ctr">
-                      <a:solidFill>
-                        <a:srgbClr val="0F141A"/>
-                      </a:solidFill>
-                      <a:prstDash val="solid"/>
-                      <a:round/>
-                      <a:headEnd type="none" w="med" len="med"/>
-                      <a:tailEnd type="none" w="med" len="med"/>
-                    </a:lnB>
-                    <a:solidFill>
-                      <a:srgbClr val="161D25"/>
-                    </a:solidFill>
-                  </a:tcPr>
-                </a:tc>
-                <a:tc>
-                  <a:txBody>
-                    <a:bodyPr/>
-                    <a:lstStyle/>
-                    <a:p>
-                      <a:pPr algn="ctr" indent="0" marL="0">
-                        <a:buNone/>
-                      </a:pPr>
-                      <a:r>
-                        <a:rPr lang="en-US" sz="1100" dirty="0">
-                          <a:solidFill>
-                            <a:srgbClr val="EEF1F4"/>
-                          </a:solidFill>
-                          <a:latin typeface="Arial" pitchFamily="34" charset="0"/>
-                          <a:ea typeface="Arial" pitchFamily="34" charset="-122"/>
-                          <a:cs typeface="Arial" pitchFamily="34" charset="-120"/>
-                        </a:rPr>
-                        <a:t>71.6</a:t>
-                      </a:r>
-                      <a:endParaRPr lang="en-US" sz="1100" dirty="0">
-                        <a:latin typeface="Arial" charset="0"/>
-                        <a:ea typeface="Arial" charset="0"/>
-                        <a:cs typeface="Arial" charset="0"/>
-                      </a:endParaRPr>
-                    </a:p>
-                  </a:txBody>
-                  <a:tcPr marL="45720" marR="45720" marT="18288" marB="18288" anchor="ctr">
-                    <a:lnL w="12700" cap="flat" cmpd="sng" algn="ctr">
-                      <a:solidFill>
-                        <a:srgbClr val="0F141A"/>
-                      </a:solidFill>
-                      <a:prstDash val="solid"/>
-                      <a:round/>
-                      <a:headEnd type="none" w="med" len="med"/>
-                      <a:tailEnd type="none" w="med" len="med"/>
-                    </a:lnL>
-                    <a:lnR w="12700" cap="flat" cmpd="sng" algn="ctr">
-                      <a:solidFill>
-                        <a:srgbClr val="0F141A"/>
-                      </a:solidFill>
-                      <a:prstDash val="solid"/>
-                      <a:round/>
-                      <a:headEnd type="none" w="med" len="med"/>
-                      <a:tailEnd type="none" w="med" len="med"/>
-                    </a:lnR>
-                    <a:lnT w="12700" cap="flat" cmpd="sng" algn="ctr">
-                      <a:solidFill>
-                        <a:srgbClr val="0F141A"/>
-                      </a:solidFill>
-                      <a:prstDash val="solid"/>
-                      <a:round/>
-                      <a:headEnd type="none" w="med" len="med"/>
-                      <a:tailEnd type="none" w="med" len="med"/>
-                    </a:lnT>
-                    <a:lnB w="12700" cap="flat" cmpd="sng" algn="ctr">
-                      <a:solidFill>
-                        <a:srgbClr val="0F141A"/>
-                      </a:solidFill>
-                      <a:prstDash val="solid"/>
-                      <a:round/>
-                      <a:headEnd type="none" w="med" len="med"/>
-                      <a:tailEnd type="none" w="med" len="med"/>
-                    </a:lnB>
-                    <a:solidFill>
-                      <a:srgbClr val="161D25"/>
-                    </a:solidFill>
-                  </a:tcPr>
-                </a:tc>
-                <a:tc>
-                  <a:txBody>
-                    <a:bodyPr/>
-                    <a:lstStyle/>
-                    <a:p>
-                      <a:pPr algn="ctr" indent="0" marL="0">
-                        <a:buNone/>
-                      </a:pPr>
-                      <a:r>
-                        <a:rPr lang="en-US" sz="1100" dirty="0">
-                          <a:solidFill>
-                            <a:srgbClr val="EEF1F4"/>
-                          </a:solidFill>
-                          <a:latin typeface="Arial" pitchFamily="34" charset="0"/>
-                          <a:ea typeface="Arial" pitchFamily="34" charset="-122"/>
-                          <a:cs typeface="Arial" pitchFamily="34" charset="-120"/>
-                        </a:rPr>
-                        <a:t>2 · 100%</a:t>
-                      </a:r>
-                      <a:endParaRPr lang="en-US" sz="1100" dirty="0">
-                        <a:latin typeface="Arial" charset="0"/>
-                        <a:ea typeface="Arial" charset="0"/>
-                        <a:cs typeface="Arial" charset="0"/>
-                      </a:endParaRPr>
-                    </a:p>
-                  </a:txBody>
-                  <a:tcPr marL="45720" marR="45720" marT="18288" marB="18288" anchor="ctr">
-                    <a:lnL w="12700" cap="flat" cmpd="sng" algn="ctr">
-                      <a:solidFill>
-                        <a:srgbClr val="0F141A"/>
-                      </a:solidFill>
-                      <a:prstDash val="solid"/>
-                      <a:round/>
-                      <a:headEnd type="none" w="med" len="med"/>
-                      <a:tailEnd type="none" w="med" len="med"/>
-                    </a:lnL>
-                    <a:lnR w="12700" cap="flat" cmpd="sng" algn="ctr">
-                      <a:solidFill>
-                        <a:srgbClr val="0F141A"/>
-                      </a:solidFill>
-                      <a:prstDash val="solid"/>
-                      <a:round/>
-                      <a:headEnd type="none" w="med" len="med"/>
-                      <a:tailEnd type="none" w="med" len="med"/>
-                    </a:lnR>
-                    <a:lnT w="12700" cap="flat" cmpd="sng" algn="ctr">
-                      <a:solidFill>
-                        <a:srgbClr val="0F141A"/>
-                      </a:solidFill>
-                      <a:prstDash val="solid"/>
-                      <a:round/>
-                      <a:headEnd type="none" w="med" len="med"/>
-                      <a:tailEnd type="none" w="med" len="med"/>
-                    </a:lnT>
-                    <a:lnB w="12700" cap="flat" cmpd="sng" algn="ctr">
-                      <a:solidFill>
-                        <a:srgbClr val="0F141A"/>
-                      </a:solidFill>
-                      <a:prstDash val="solid"/>
-                      <a:round/>
-                      <a:headEnd type="none" w="med" len="med"/>
-                      <a:tailEnd type="none" w="med" len="med"/>
-                    </a:lnB>
-                    <a:solidFill>
-                      <a:srgbClr val="161D25"/>
-                    </a:solidFill>
-                  </a:tcPr>
-                </a:tc>
-                <a:tc>
-                  <a:txBody>
-                    <a:bodyPr/>
-                    <a:lstStyle/>
-                    <a:p>
-                      <a:pPr algn="ctr" indent="0" marL="0">
-                        <a:buNone/>
-                      </a:pPr>
-                      <a:r>
-                        <a:rPr lang="en-US" sz="1100" dirty="0">
-                          <a:solidFill>
-                            <a:srgbClr val="EEF1F4"/>
-                          </a:solidFill>
-                          <a:latin typeface="Arial" pitchFamily="34" charset="0"/>
-                          <a:ea typeface="Arial" pitchFamily="34" charset="-122"/>
-                          <a:cs typeface="Arial" pitchFamily="34" charset="-120"/>
-                        </a:rPr>
-                        <a:t>Rp 2.290.000.000</a:t>
-                      </a:r>
-                      <a:endParaRPr lang="en-US" sz="1100" dirty="0">
-                        <a:latin typeface="Arial" charset="0"/>
-                        <a:ea typeface="Arial" charset="0"/>
-                        <a:cs typeface="Arial" charset="0"/>
-                      </a:endParaRPr>
-                    </a:p>
-                  </a:txBody>
-                  <a:tcPr marL="45720" marR="45720" marT="18288" marB="18288" anchor="ctr">
-                    <a:lnL w="12700" cap="flat" cmpd="sng" algn="ctr">
-                      <a:solidFill>
-                        <a:srgbClr val="0F141A"/>
-                      </a:solidFill>
-                      <a:prstDash val="solid"/>
-                      <a:round/>
-                      <a:headEnd type="none" w="med" len="med"/>
-                      <a:tailEnd type="none" w="med" len="med"/>
-                    </a:lnL>
-                    <a:lnR w="12700" cap="flat" cmpd="sng" algn="ctr">
-                      <a:solidFill>
-                        <a:srgbClr val="0F141A"/>
-                      </a:solidFill>
-                      <a:prstDash val="solid"/>
-                      <a:round/>
-                      <a:headEnd type="none" w="med" len="med"/>
-                      <a:tailEnd type="none" w="med" len="med"/>
-                    </a:lnR>
-                    <a:lnT w="12700" cap="flat" cmpd="sng" algn="ctr">
-                      <a:solidFill>
-                        <a:srgbClr val="0F141A"/>
-                      </a:solidFill>
-                      <a:prstDash val="solid"/>
-                      <a:round/>
-                      <a:headEnd type="none" w="med" len="med"/>
-                      <a:tailEnd type="none" w="med" len="med"/>
-                    </a:lnT>
-                    <a:lnB w="12700" cap="flat" cmpd="sng" algn="ctr">
-                      <a:solidFill>
-                        <a:srgbClr val="0F141A"/>
-                      </a:solidFill>
-                      <a:prstDash val="solid"/>
-                      <a:round/>
-                      <a:headEnd type="none" w="med" len="med"/>
-                      <a:tailEnd type="none" w="med" len="med"/>
-                    </a:lnB>
-                    <a:solidFill>
-                      <a:srgbClr val="161D25"/>
-                    </a:solidFill>
-                  </a:tcPr>
-                </a:tc>
-                <a:tc>
-                  <a:txBody>
-                    <a:bodyPr/>
-                    <a:lstStyle/>
-                    <a:p>
-                      <a:pPr algn="ctr" indent="0" marL="0">
-                        <a:buNone/>
-                      </a:pPr>
-                      <a:r>
-                        <a:rPr lang="en-US" sz="1100" b="1" dirty="0">
-                          <a:solidFill>
-                            <a:srgbClr val="EEF1F4"/>
-                          </a:solidFill>
-                          <a:latin typeface="Arial" pitchFamily="34" charset="0"/>
-                          <a:ea typeface="Arial" pitchFamily="34" charset="-122"/>
-                          <a:cs typeface="Arial" pitchFamily="34" charset="-120"/>
-                        </a:rPr>
-                        <a:t>990R</a:t>
-                      </a:r>
-                      <a:endParaRPr lang="en-US" sz="1100" dirty="0">
-                        <a:latin typeface="Arial" charset="0"/>
-                        <a:ea typeface="Arial" charset="0"/>
-                        <a:cs typeface="Arial" charset="0"/>
-                      </a:endParaRPr>
-                    </a:p>
-                  </a:txBody>
-                  <a:tcPr marL="45720" marR="45720" marT="18288" marB="18288" anchor="ctr">
-                    <a:lnL w="12700" cap="flat" cmpd="sng" algn="ctr">
-                      <a:solidFill>
-                        <a:srgbClr val="0F141A"/>
-                      </a:solidFill>
-                      <a:prstDash val="solid"/>
-                      <a:round/>
-                      <a:headEnd type="none" w="med" len="med"/>
-                      <a:tailEnd type="none" w="med" len="med"/>
-                    </a:lnL>
-                    <a:lnR w="12700" cap="flat" cmpd="sng" algn="ctr">
-                      <a:solidFill>
-                        <a:srgbClr val="0F141A"/>
-                      </a:solidFill>
-                      <a:prstDash val="solid"/>
-                      <a:round/>
-                      <a:headEnd type="none" w="med" len="med"/>
-                      <a:tailEnd type="none" w="med" len="med"/>
-                    </a:lnR>
-                    <a:lnT w="12700" cap="flat" cmpd="sng" algn="ctr">
-                      <a:solidFill>
-                        <a:srgbClr val="0F141A"/>
-                      </a:solidFill>
-                      <a:prstDash val="solid"/>
-                      <a:round/>
-                      <a:headEnd type="none" w="med" len="med"/>
-                      <a:tailEnd type="none" w="med" len="med"/>
-                    </a:lnT>
-                    <a:lnB w="12700" cap="flat" cmpd="sng" algn="ctr">
-                      <a:solidFill>
-                        <a:srgbClr val="0F141A"/>
-                      </a:solidFill>
-                      <a:prstDash val="solid"/>
-                      <a:round/>
-                      <a:headEnd type="none" w="med" len="med"/>
-                      <a:tailEnd type="none" w="med" len="med"/>
-                    </a:lnB>
-                    <a:solidFill>
-                      <a:srgbClr val="161D25"/>
-                    </a:solidFill>
-                  </a:tcPr>
-                </a:tc>
-                <a:tc>
-                  <a:txBody>
-                    <a:bodyPr/>
-                    <a:lstStyle/>
-                    <a:p>
-                      <a:pPr algn="ctr" indent="0" marL="0">
-                        <a:buNone/>
-                      </a:pPr>
-                      <a:r>
-                        <a:rPr lang="en-US" sz="1100" dirty="0">
-                          <a:solidFill>
-                            <a:srgbClr val="EEF1F4"/>
-                          </a:solidFill>
-                          <a:latin typeface="Arial" pitchFamily="34" charset="0"/>
-                          <a:ea typeface="Arial" pitchFamily="34" charset="-122"/>
-                          <a:cs typeface="Arial" pitchFamily="34" charset="-120"/>
-                        </a:rPr>
-                        <a:t>74</a:t>
-                      </a:r>
-                      <a:endParaRPr lang="en-US" sz="1100" dirty="0">
-                        <a:latin typeface="Arial" charset="0"/>
-                        <a:ea typeface="Arial" charset="0"/>
-                        <a:cs typeface="Arial" charset="0"/>
-                      </a:endParaRPr>
-                    </a:p>
-                  </a:txBody>
-                  <a:tcPr marL="45720" marR="45720" marT="18288" marB="18288" anchor="ctr">
-                    <a:lnL w="12700" cap="flat" cmpd="sng" algn="ctr">
-                      <a:solidFill>
-                        <a:srgbClr val="0F141A"/>
-                      </a:solidFill>
-                      <a:prstDash val="solid"/>
-                      <a:round/>
-                      <a:headEnd type="none" w="med" len="med"/>
-                      <a:tailEnd type="none" w="med" len="med"/>
-                    </a:lnL>
-                    <a:lnR w="12700" cap="flat" cmpd="sng" algn="ctr">
-                      <a:solidFill>
-                        <a:srgbClr val="0F141A"/>
-                      </a:solidFill>
-                      <a:prstDash val="solid"/>
-                      <a:round/>
-                      <a:headEnd type="none" w="med" len="med"/>
-                      <a:tailEnd type="none" w="med" len="med"/>
-                    </a:lnR>
-                    <a:lnT w="12700" cap="flat" cmpd="sng" algn="ctr">
-                      <a:solidFill>
-                        <a:srgbClr val="0F141A"/>
-                      </a:solidFill>
-                      <a:prstDash val="solid"/>
-                      <a:round/>
-                      <a:headEnd type="none" w="med" len="med"/>
-                      <a:tailEnd type="none" w="med" len="med"/>
-                    </a:lnT>
-                    <a:lnB w="12700" cap="flat" cmpd="sng" algn="ctr">
-                      <a:solidFill>
-                        <a:srgbClr val="0F141A"/>
-                      </a:solidFill>
-                      <a:prstDash val="solid"/>
-                      <a:round/>
-                      <a:headEnd type="none" w="med" len="med"/>
-                      <a:tailEnd type="none" w="med" len="med"/>
-                    </a:lnB>
-                    <a:solidFill>
-                      <a:srgbClr val="161D25"/>
-                    </a:solidFill>
-                  </a:tcPr>
-                </a:tc>
-                <a:tc>
-                  <a:txBody>
-                    <a:bodyPr/>
-                    <a:lstStyle/>
-                    <a:p>
-                      <a:pPr algn="ctr" indent="0" marL="0">
-                        <a:buNone/>
-                      </a:pPr>
-                      <a:r>
-                        <a:rPr lang="en-US" sz="1100" i="1" dirty="0">
-                          <a:solidFill>
-                            <a:srgbClr val="9AA6B2"/>
-                          </a:solidFill>
-                          <a:latin typeface="Arial" pitchFamily="34" charset="0"/>
-                          <a:ea typeface="Arial" pitchFamily="34" charset="-122"/>
-                          <a:cs typeface="Arial" pitchFamily="34" charset="-120"/>
-                        </a:rPr>
-                        <a:t>Price not yet known</a:t>
-                      </a:r>
-                      <a:endParaRPr lang="en-US" sz="1100" dirty="0">
-                        <a:latin typeface="Arial" charset="0"/>
-                        <a:ea typeface="Arial" charset="0"/>
-                        <a:cs typeface="Arial" charset="0"/>
-                      </a:endParaRPr>
-                    </a:p>
-                  </a:txBody>
-                  <a:tcPr marL="45720" marR="45720" marT="18288" marB="18288" anchor="ctr">
-                    <a:lnL w="12700" cap="flat" cmpd="sng" algn="ctr">
-                      <a:solidFill>
-                        <a:srgbClr val="0F141A"/>
-                      </a:solidFill>
-                      <a:prstDash val="solid"/>
-                      <a:round/>
-                      <a:headEnd type="none" w="med" len="med"/>
-                      <a:tailEnd type="none" w="med" len="med"/>
-                    </a:lnL>
-                    <a:lnR w="12700" cap="flat" cmpd="sng" algn="ctr">
-                      <a:solidFill>
-                        <a:srgbClr val="0F141A"/>
-                      </a:solidFill>
-                      <a:prstDash val="solid"/>
-                      <a:round/>
-                      <a:headEnd type="none" w="med" len="med"/>
-                      <a:tailEnd type="none" w="med" len="med"/>
-                    </a:lnR>
-                    <a:lnT w="12700" cap="flat" cmpd="sng" algn="ctr">
-                      <a:solidFill>
-                        <a:srgbClr val="0F141A"/>
-                      </a:solidFill>
-                      <a:prstDash val="solid"/>
-                      <a:round/>
-                      <a:headEnd type="none" w="med" len="med"/>
-                      <a:tailEnd type="none" w="med" len="med"/>
-                    </a:lnT>
-                    <a:lnB w="12700" cap="flat" cmpd="sng" algn="ctr">
-                      <a:solidFill>
-                        <a:srgbClr val="0F141A"/>
-                      </a:solidFill>
-                      <a:prstDash val="solid"/>
-                      <a:round/>
-                      <a:headEnd type="none" w="med" len="med"/>
-                      <a:tailEnd type="none" w="med" len="med"/>
-                    </a:lnB>
-                    <a:solidFill>
-                      <a:srgbClr val="161D25"/>
-                    </a:solidFill>
-                  </a:tcPr>
-                </a:tc>
-              </a:tr>
-              <a:tr h="535577">
-                <a:tc>
-                  <a:txBody>
-                    <a:bodyPr/>
-                    <a:lstStyle/>
-                    <a:p>
-                      <a:pPr algn="ctr" indent="0" marL="0">
-                        <a:buNone/>
-                      </a:pPr>
-                      <a:r>
-                        <a:rPr lang="en-US" sz="1100" b="1" dirty="0">
-                          <a:solidFill>
-                            <a:srgbClr val="4F9CF9"/>
-                          </a:solidFill>
-                          <a:latin typeface="Arial" pitchFamily="34" charset="0"/>
-                          <a:ea typeface="Arial" pitchFamily="34" charset="-122"/>
-                          <a:cs typeface="Arial" pitchFamily="34" charset="-120"/>
-                        </a:rPr>
-                        <a:t>&gt;80–85 tm</a:t>
-                      </a:r>
-                      <a:endParaRPr lang="en-US" sz="1100" dirty="0">
-                        <a:latin typeface="Arial" charset="0"/>
-                        <a:ea typeface="Arial" charset="0"/>
-                        <a:cs typeface="Arial" charset="0"/>
-                      </a:endParaRPr>
-                    </a:p>
-                  </a:txBody>
-                  <a:tcPr marL="45720" marR="45720" marT="18288" marB="18288" anchor="ctr">
-                    <a:lnL w="12700" cap="flat" cmpd="sng" algn="ctr">
-                      <a:solidFill>
-                        <a:srgbClr val="0F141A"/>
-                      </a:solidFill>
-                      <a:prstDash val="solid"/>
-                      <a:round/>
-                      <a:headEnd type="none" w="med" len="med"/>
-                      <a:tailEnd type="none" w="med" len="med"/>
-                    </a:lnL>
-                    <a:lnR w="12700" cap="flat" cmpd="sng" algn="ctr">
-                      <a:solidFill>
-                        <a:srgbClr val="0F141A"/>
-                      </a:solidFill>
-                      <a:prstDash val="solid"/>
-                      <a:round/>
-                      <a:headEnd type="none" w="med" len="med"/>
-                      <a:tailEnd type="none" w="med" len="med"/>
-                    </a:lnR>
-                    <a:lnT w="12700" cap="flat" cmpd="sng" algn="ctr">
-                      <a:solidFill>
-                        <a:srgbClr val="0F141A"/>
-                      </a:solidFill>
-                      <a:prstDash val="solid"/>
-                      <a:round/>
-                      <a:headEnd type="none" w="med" len="med"/>
-                      <a:tailEnd type="none" w="med" len="med"/>
-                    </a:lnT>
-                    <a:lnB w="12700" cap="flat" cmpd="sng" algn="ctr">
-                      <a:solidFill>
-                        <a:srgbClr val="0F141A"/>
-                      </a:solidFill>
-                      <a:prstDash val="solid"/>
-                      <a:round/>
-                      <a:headEnd type="none" w="med" len="med"/>
-                      <a:tailEnd type="none" w="med" len="med"/>
-                    </a:lnB>
-                    <a:solidFill>
-                      <a:srgbClr val="161D25"/>
-                    </a:solidFill>
-                  </a:tcPr>
-                </a:tc>
-                <a:tc>
-                  <a:txBody>
-                    <a:bodyPr/>
-                    <a:lstStyle/>
-                    <a:p>
-                      <a:pPr algn="ctr" indent="0" marL="0">
-                        <a:buNone/>
-                      </a:pPr>
-                      <a:r>
-                        <a:rPr lang="en-US" sz="1100" dirty="0">
-                          <a:solidFill>
-                            <a:srgbClr val="EEF1F4"/>
-                          </a:solidFill>
-                          <a:latin typeface="Arial" pitchFamily="34" charset="0"/>
-                          <a:ea typeface="Arial" pitchFamily="34" charset="-122"/>
-                          <a:cs typeface="Arial" pitchFamily="34" charset="-120"/>
-                        </a:rPr>
-                        <a:t>1</a:t>
-                      </a:r>
-                      <a:endParaRPr lang="en-US" sz="1100" dirty="0">
-                        <a:latin typeface="Arial" charset="0"/>
-                        <a:ea typeface="Arial" charset="0"/>
-                        <a:cs typeface="Arial" charset="0"/>
-                      </a:endParaRPr>
-                    </a:p>
-                  </a:txBody>
-                  <a:tcPr marL="45720" marR="45720" marT="18288" marB="18288" anchor="ctr">
-                    <a:lnL w="12700" cap="flat" cmpd="sng" algn="ctr">
-                      <a:solidFill>
-                        <a:srgbClr val="0F141A"/>
-                      </a:solidFill>
-                      <a:prstDash val="solid"/>
-                      <a:round/>
-                      <a:headEnd type="none" w="med" len="med"/>
-                      <a:tailEnd type="none" w="med" len="med"/>
-                    </a:lnL>
-                    <a:lnR w="12700" cap="flat" cmpd="sng" algn="ctr">
-                      <a:solidFill>
-                        <a:srgbClr val="0F141A"/>
-                      </a:solidFill>
-                      <a:prstDash val="solid"/>
-                      <a:round/>
-                      <a:headEnd type="none" w="med" len="med"/>
-                      <a:tailEnd type="none" w="med" len="med"/>
-                    </a:lnR>
-                    <a:lnT w="12700" cap="flat" cmpd="sng" algn="ctr">
-                      <a:solidFill>
-                        <a:srgbClr val="0F141A"/>
-                      </a:solidFill>
-                      <a:prstDash val="solid"/>
-                      <a:round/>
-                      <a:headEnd type="none" w="med" len="med"/>
-                      <a:tailEnd type="none" w="med" len="med"/>
-                    </a:lnT>
-                    <a:lnB w="12700" cap="flat" cmpd="sng" algn="ctr">
-                      <a:solidFill>
-                        <a:srgbClr val="0F141A"/>
-                      </a:solidFill>
-                      <a:prstDash val="solid"/>
-                      <a:round/>
-                      <a:headEnd type="none" w="med" len="med"/>
-                      <a:tailEnd type="none" w="med" len="med"/>
-                    </a:lnB>
-                    <a:solidFill>
-                      <a:srgbClr val="161D25"/>
-                    </a:solidFill>
-                  </a:tcPr>
-                </a:tc>
-                <a:tc>
-                  <a:txBody>
-                    <a:bodyPr/>
-                    <a:lstStyle/>
-                    <a:p>
-                      <a:pPr algn="ctr" indent="0" marL="0">
-                        <a:buNone/>
-                      </a:pPr>
-                      <a:endParaRPr lang="en-US" sz="1100" dirty="0">
-                        <a:latin typeface="Arial" charset="0"/>
-                        <a:ea typeface="Arial" charset="0"/>
-                        <a:cs typeface="Arial" charset="0"/>
-                      </a:endParaRPr>
-                    </a:p>
-                  </a:txBody>
-                  <a:tcPr marL="45720" marR="45720" marT="18288" marB="18288" anchor="ctr">
-                    <a:lnL w="12700" cap="flat" cmpd="sng" algn="ctr">
-                      <a:solidFill>
-                        <a:srgbClr val="0F141A"/>
-                      </a:solidFill>
-                      <a:prstDash val="solid"/>
-                      <a:round/>
-                      <a:headEnd type="none" w="med" len="med"/>
-                      <a:tailEnd type="none" w="med" len="med"/>
-                    </a:lnL>
-                    <a:lnR w="12700" cap="flat" cmpd="sng" algn="ctr">
-                      <a:solidFill>
-                        <a:srgbClr val="0F141A"/>
-                      </a:solidFill>
-                      <a:prstDash val="solid"/>
-                      <a:round/>
-                      <a:headEnd type="none" w="med" len="med"/>
-                      <a:tailEnd type="none" w="med" len="med"/>
-                    </a:lnR>
-                    <a:lnT w="12700" cap="flat" cmpd="sng" algn="ctr">
-                      <a:solidFill>
-                        <a:srgbClr val="0F141A"/>
-                      </a:solidFill>
-                      <a:prstDash val="solid"/>
-                      <a:round/>
-                      <a:headEnd type="none" w="med" len="med"/>
-                      <a:tailEnd type="none" w="med" len="med"/>
-                    </a:lnT>
-                    <a:lnB w="12700" cap="flat" cmpd="sng" algn="ctr">
-                      <a:solidFill>
-                        <a:srgbClr val="0F141A"/>
-                      </a:solidFill>
-                      <a:prstDash val="solid"/>
-                      <a:round/>
-                      <a:headEnd type="none" w="med" len="med"/>
-                      <a:tailEnd type="none" w="med" len="med"/>
-                    </a:lnB>
-                    <a:solidFill>
-                      <a:srgbClr val="161D25"/>
-                    </a:solidFill>
-                  </a:tcPr>
-                </a:tc>
-                <a:tc>
-                  <a:txBody>
-                    <a:bodyPr/>
-                    <a:lstStyle/>
-                    <a:p>
-                      <a:pPr algn="ctr" indent="0" marL="0">
-                        <a:buNone/>
-                      </a:pPr>
-                      <a:r>
-                        <a:rPr lang="en-US" sz="1100" b="1" dirty="0">
-                          <a:solidFill>
-                            <a:srgbClr val="EEF1F4"/>
-                          </a:solidFill>
-                          <a:latin typeface="Arial" pitchFamily="34" charset="0"/>
-                          <a:ea typeface="Arial" pitchFamily="34" charset="-122"/>
-                          <a:cs typeface="Arial" pitchFamily="34" charset="-120"/>
-                        </a:rPr>
-                        <a:t>PK 88002 EH C</a:t>
-                      </a:r>
-                      <a:endParaRPr lang="en-US" sz="1100" dirty="0">
-                        <a:latin typeface="Arial" charset="0"/>
-                        <a:ea typeface="Arial" charset="0"/>
-                        <a:cs typeface="Arial" charset="0"/>
-                      </a:endParaRPr>
-                    </a:p>
-                  </a:txBody>
-                  <a:tcPr marL="45720" marR="45720" marT="18288" marB="18288" anchor="ctr">
-                    <a:lnL w="12700" cap="flat" cmpd="sng" algn="ctr">
-                      <a:solidFill>
-                        <a:srgbClr val="0F141A"/>
-                      </a:solidFill>
-                      <a:prstDash val="solid"/>
-                      <a:round/>
-                      <a:headEnd type="none" w="med" len="med"/>
-                      <a:tailEnd type="none" w="med" len="med"/>
-                    </a:lnL>
-                    <a:lnR w="12700" cap="flat" cmpd="sng" algn="ctr">
-                      <a:solidFill>
-                        <a:srgbClr val="0F141A"/>
-                      </a:solidFill>
-                      <a:prstDash val="solid"/>
-                      <a:round/>
-                      <a:headEnd type="none" w="med" len="med"/>
-                      <a:tailEnd type="none" w="med" len="med"/>
-                    </a:lnR>
-                    <a:lnT w="12700" cap="flat" cmpd="sng" algn="ctr">
-                      <a:solidFill>
-                        <a:srgbClr val="0F141A"/>
-                      </a:solidFill>
-                      <a:prstDash val="solid"/>
-                      <a:round/>
-                      <a:headEnd type="none" w="med" len="med"/>
-                      <a:tailEnd type="none" w="med" len="med"/>
-                    </a:lnT>
-                    <a:lnB w="12700" cap="flat" cmpd="sng" algn="ctr">
-                      <a:solidFill>
-                        <a:srgbClr val="0F141A"/>
-                      </a:solidFill>
-                      <a:prstDash val="solid"/>
-                      <a:round/>
-                      <a:headEnd type="none" w="med" len="med"/>
-                      <a:tailEnd type="none" w="med" len="med"/>
-                    </a:lnB>
-                    <a:solidFill>
-                      <a:srgbClr val="161D25"/>
-                    </a:solidFill>
-                  </a:tcPr>
-                </a:tc>
-                <a:tc>
-                  <a:txBody>
-                    <a:bodyPr/>
-                    <a:lstStyle/>
-                    <a:p>
-                      <a:pPr algn="ctr" indent="0" marL="0">
-                        <a:buNone/>
-                      </a:pPr>
-                      <a:r>
-                        <a:rPr lang="en-US" sz="1100" dirty="0">
-                          <a:solidFill>
-                            <a:srgbClr val="EEF1F4"/>
-                          </a:solidFill>
-                          <a:latin typeface="Arial" pitchFamily="34" charset="0"/>
-                          <a:ea typeface="Arial" pitchFamily="34" charset="-122"/>
-                          <a:cs typeface="Arial" pitchFamily="34" charset="-120"/>
-                        </a:rPr>
-                        <a:t>81.6</a:t>
-                      </a:r>
-                      <a:endParaRPr lang="en-US" sz="1100" dirty="0">
-                        <a:latin typeface="Arial" charset="0"/>
-                        <a:ea typeface="Arial" charset="0"/>
-                        <a:cs typeface="Arial" charset="0"/>
-                      </a:endParaRPr>
-                    </a:p>
-                  </a:txBody>
-                  <a:tcPr marL="45720" marR="45720" marT="18288" marB="18288" anchor="ctr">
-                    <a:lnL w="12700" cap="flat" cmpd="sng" algn="ctr">
-                      <a:solidFill>
-                        <a:srgbClr val="0F141A"/>
-                      </a:solidFill>
-                      <a:prstDash val="solid"/>
-                      <a:round/>
-                      <a:headEnd type="none" w="med" len="med"/>
-                      <a:tailEnd type="none" w="med" len="med"/>
-                    </a:lnL>
-                    <a:lnR w="12700" cap="flat" cmpd="sng" algn="ctr">
-                      <a:solidFill>
-                        <a:srgbClr val="0F141A"/>
-                      </a:solidFill>
-                      <a:prstDash val="solid"/>
-                      <a:round/>
-                      <a:headEnd type="none" w="med" len="med"/>
-                      <a:tailEnd type="none" w="med" len="med"/>
-                    </a:lnR>
-                    <a:lnT w="12700" cap="flat" cmpd="sng" algn="ctr">
-                      <a:solidFill>
-                        <a:srgbClr val="0F141A"/>
-                      </a:solidFill>
-                      <a:prstDash val="solid"/>
-                      <a:round/>
-                      <a:headEnd type="none" w="med" len="med"/>
-                      <a:tailEnd type="none" w="med" len="med"/>
-                    </a:lnT>
-                    <a:lnB w="12700" cap="flat" cmpd="sng" algn="ctr">
-                      <a:solidFill>
-                        <a:srgbClr val="0F141A"/>
-                      </a:solidFill>
-                      <a:prstDash val="solid"/>
-                      <a:round/>
-                      <a:headEnd type="none" w="med" len="med"/>
-                      <a:tailEnd type="none" w="med" len="med"/>
-                    </a:lnB>
-                    <a:solidFill>
-                      <a:srgbClr val="161D25"/>
-                    </a:solidFill>
-                  </a:tcPr>
-                </a:tc>
-                <a:tc>
-                  <a:txBody>
-                    <a:bodyPr/>
-                    <a:lstStyle/>
-                    <a:p>
-                      <a:pPr algn="ctr" indent="0" marL="0">
-                        <a:buNone/>
-                      </a:pPr>
-                      <a:r>
-                        <a:rPr lang="en-US" sz="1100" dirty="0">
-                          <a:solidFill>
-                            <a:srgbClr val="EEF1F4"/>
-                          </a:solidFill>
-                          <a:latin typeface="Arial" pitchFamily="34" charset="0"/>
-                          <a:ea typeface="Arial" pitchFamily="34" charset="-122"/>
-                          <a:cs typeface="Arial" pitchFamily="34" charset="-120"/>
-                        </a:rPr>
-                        <a:t>1 · 100%</a:t>
-                      </a:r>
-                      <a:endParaRPr lang="en-US" sz="1100" dirty="0">
-                        <a:latin typeface="Arial" charset="0"/>
-                        <a:ea typeface="Arial" charset="0"/>
-                        <a:cs typeface="Arial" charset="0"/>
-                      </a:endParaRPr>
-                    </a:p>
-                  </a:txBody>
-                  <a:tcPr marL="45720" marR="45720" marT="18288" marB="18288" anchor="ctr">
-                    <a:lnL w="12700" cap="flat" cmpd="sng" algn="ctr">
-                      <a:solidFill>
-                        <a:srgbClr val="0F141A"/>
-                      </a:solidFill>
-                      <a:prstDash val="solid"/>
-                      <a:round/>
-                      <a:headEnd type="none" w="med" len="med"/>
-                      <a:tailEnd type="none" w="med" len="med"/>
-                    </a:lnL>
-                    <a:lnR w="12700" cap="flat" cmpd="sng" algn="ctr">
-                      <a:solidFill>
-                        <a:srgbClr val="0F141A"/>
-                      </a:solidFill>
-                      <a:prstDash val="solid"/>
-                      <a:round/>
-                      <a:headEnd type="none" w="med" len="med"/>
-                      <a:tailEnd type="none" w="med" len="med"/>
-                    </a:lnR>
-                    <a:lnT w="12700" cap="flat" cmpd="sng" algn="ctr">
-                      <a:solidFill>
-                        <a:srgbClr val="0F141A"/>
-                      </a:solidFill>
-                      <a:prstDash val="solid"/>
-                      <a:round/>
-                      <a:headEnd type="none" w="med" len="med"/>
-                      <a:tailEnd type="none" w="med" len="med"/>
-                    </a:lnT>
-                    <a:lnB w="12700" cap="flat" cmpd="sng" algn="ctr">
-                      <a:solidFill>
-                        <a:srgbClr val="0F141A"/>
-                      </a:solidFill>
-                      <a:prstDash val="solid"/>
-                      <a:round/>
-                      <a:headEnd type="none" w="med" len="med"/>
-                      <a:tailEnd type="none" w="med" len="med"/>
-                    </a:lnB>
-                    <a:solidFill>
-                      <a:srgbClr val="161D25"/>
-                    </a:solidFill>
-                  </a:tcPr>
-                </a:tc>
-                <a:tc>
-                  <a:txBody>
-                    <a:bodyPr/>
-                    <a:lstStyle/>
-                    <a:p>
-                      <a:pPr algn="ctr" indent="0" marL="0">
-                        <a:buNone/>
-                      </a:pPr>
-                      <a:r>
-                        <a:rPr lang="en-US" sz="1100" dirty="0">
-                          <a:solidFill>
-                            <a:srgbClr val="EEF1F4"/>
-                          </a:solidFill>
-                          <a:latin typeface="Arial" pitchFamily="34" charset="0"/>
-                          <a:ea typeface="Arial" pitchFamily="34" charset="-122"/>
-                          <a:cs typeface="Arial" pitchFamily="34" charset="-120"/>
-                        </a:rPr>
-                        <a:t>Rp 2.220.000.000</a:t>
-                      </a:r>
-                      <a:endParaRPr lang="en-US" sz="1100" dirty="0">
-                        <a:latin typeface="Arial" charset="0"/>
-                        <a:ea typeface="Arial" charset="0"/>
-                        <a:cs typeface="Arial" charset="0"/>
-                      </a:endParaRPr>
-                    </a:p>
-                  </a:txBody>
-                  <a:tcPr marL="45720" marR="45720" marT="18288" marB="18288" anchor="ctr">
-                    <a:lnL w="12700" cap="flat" cmpd="sng" algn="ctr">
-                      <a:solidFill>
-                        <a:srgbClr val="0F141A"/>
-                      </a:solidFill>
-                      <a:prstDash val="solid"/>
-                      <a:round/>
-                      <a:headEnd type="none" w="med" len="med"/>
-                      <a:tailEnd type="none" w="med" len="med"/>
-                    </a:lnL>
-                    <a:lnR w="12700" cap="flat" cmpd="sng" algn="ctr">
-                      <a:solidFill>
-                        <a:srgbClr val="0F141A"/>
-                      </a:solidFill>
-                      <a:prstDash val="solid"/>
-                      <a:round/>
-                      <a:headEnd type="none" w="med" len="med"/>
-                      <a:tailEnd type="none" w="med" len="med"/>
-                    </a:lnR>
-                    <a:lnT w="12700" cap="flat" cmpd="sng" algn="ctr">
-                      <a:solidFill>
-                        <a:srgbClr val="0F141A"/>
-                      </a:solidFill>
-                      <a:prstDash val="solid"/>
-                      <a:round/>
-                      <a:headEnd type="none" w="med" len="med"/>
-                      <a:tailEnd type="none" w="med" len="med"/>
-                    </a:lnT>
-                    <a:lnB w="12700" cap="flat" cmpd="sng" algn="ctr">
-                      <a:solidFill>
-                        <a:srgbClr val="0F141A"/>
-                      </a:solidFill>
-                      <a:prstDash val="solid"/>
-                      <a:round/>
-                      <a:headEnd type="none" w="med" len="med"/>
-                      <a:tailEnd type="none" w="med" len="med"/>
-                    </a:lnB>
-                    <a:solidFill>
-                      <a:srgbClr val="161D25"/>
-                    </a:solidFill>
-                  </a:tcPr>
-                </a:tc>
-                <a:tc gridSpan="3">
-                  <a:txBody>
-                    <a:bodyPr/>
-                    <a:lstStyle/>
-                    <a:p>
-                      <a:pPr algn="ctr" indent="0" marL="0">
-                        <a:buNone/>
-                      </a:pPr>
-                      <a:r>
-                        <a:rPr lang="en-US" sz="1100" b="1" dirty="0">
-                          <a:solidFill>
-                            <a:srgbClr val="E30613"/>
-                          </a:solidFill>
-                          <a:latin typeface="Arial" pitchFamily="34" charset="0"/>
-                          <a:ea typeface="Arial" pitchFamily="34" charset="-122"/>
-                          <a:cs typeface="Arial" pitchFamily="34" charset="-120"/>
-                        </a:rPr>
-                        <a:t>No Ferrari model</a:t>
-                      </a:r>
-                      <a:endParaRPr lang="en-US" sz="1100" dirty="0">
-                        <a:latin typeface="Arial" charset="0"/>
-                        <a:ea typeface="Arial" charset="0"/>
-                        <a:cs typeface="Arial" charset="0"/>
-                      </a:endParaRPr>
-                    </a:p>
-                  </a:txBody>
-                  <a:tcPr marL="45720" marR="45720" marT="18288" marB="18288" anchor="ctr">
-                    <a:lnL w="12700" cap="flat" cmpd="sng" algn="ctr">
-                      <a:solidFill>
-                        <a:srgbClr val="0F141A"/>
-                      </a:solidFill>
-                      <a:prstDash val="solid"/>
-                      <a:round/>
-                      <a:headEnd type="none" w="med" len="med"/>
-                      <a:tailEnd type="none" w="med" len="med"/>
-                    </a:lnL>
-                    <a:lnR w="12700" cap="flat" cmpd="sng" algn="ctr">
-                      <a:solidFill>
-                        <a:srgbClr val="0F141A"/>
-                      </a:solidFill>
-                      <a:prstDash val="solid"/>
-                      <a:round/>
-                      <a:headEnd type="none" w="med" len="med"/>
-                      <a:tailEnd type="none" w="med" len="med"/>
-                    </a:lnR>
-                    <a:lnT w="12700" cap="flat" cmpd="sng" algn="ctr">
-                      <a:solidFill>
-                        <a:srgbClr val="0F141A"/>
-                      </a:solidFill>
-                      <a:prstDash val="solid"/>
-                      <a:round/>
-                      <a:headEnd type="none" w="med" len="med"/>
-                      <a:tailEnd type="none" w="med" len="med"/>
-                    </a:lnT>
-                    <a:lnB w="12700" cap="flat" cmpd="sng" algn="ctr">
-                      <a:solidFill>
-                        <a:srgbClr val="0F141A"/>
-                      </a:solidFill>
-                      <a:prstDash val="solid"/>
-                      <a:round/>
-                      <a:headEnd type="none" w="med" len="med"/>
-                      <a:tailEnd type="none" w="med" len="med"/>
-                    </a:lnB>
-                    <a:solidFill>
-                      <a:srgbClr val="161D25"/>
-                    </a:solidFill>
-                  </a:tcPr>
-                </a:tc>
-                <a:tc hMerge="1">
-                  <a:tcPr/>
-                </a:tc>
-                <a:tc hMerge="1">
-                  <a:tcPr/>
-                </a:tc>
-              </a:tr>
-              <a:tr h="535577">
-                <a:tc>
-                  <a:txBody>
-                    <a:bodyPr/>
-                    <a:lstStyle/>
-                    <a:p>
-                      <a:pPr algn="ctr" indent="0" marL="0">
-                        <a:buNone/>
-                      </a:pPr>
-                      <a:r>
-                        <a:rPr lang="en-US" sz="1100" b="1" dirty="0">
-                          <a:solidFill>
-                            <a:srgbClr val="4F9CF9"/>
-                          </a:solidFill>
-                          <a:latin typeface="Arial" pitchFamily="34" charset="0"/>
-                          <a:ea typeface="Arial" pitchFamily="34" charset="-122"/>
-                          <a:cs typeface="Arial" pitchFamily="34" charset="-120"/>
-                        </a:rPr>
-                        <a:t>&gt;85–90 tm</a:t>
-                      </a:r>
-                      <a:endParaRPr lang="en-US" sz="1100" dirty="0">
-                        <a:latin typeface="Arial" charset="0"/>
-                        <a:ea typeface="Arial" charset="0"/>
-                        <a:cs typeface="Arial" charset="0"/>
-                      </a:endParaRPr>
-                    </a:p>
-                  </a:txBody>
-                  <a:tcPr marL="45720" marR="45720" marT="18288" marB="18288" anchor="ctr">
-                    <a:lnL w="12700" cap="flat" cmpd="sng" algn="ctr">
-                      <a:solidFill>
-                        <a:srgbClr val="0F141A"/>
-                      </a:solidFill>
-                      <a:prstDash val="solid"/>
-                      <a:round/>
-                      <a:headEnd type="none" w="med" len="med"/>
-                      <a:tailEnd type="none" w="med" len="med"/>
-                    </a:lnL>
-                    <a:lnR w="12700" cap="flat" cmpd="sng" algn="ctr">
-                      <a:solidFill>
-                        <a:srgbClr val="0F141A"/>
-                      </a:solidFill>
-                      <a:prstDash val="solid"/>
-                      <a:round/>
-                      <a:headEnd type="none" w="med" len="med"/>
-                      <a:tailEnd type="none" w="med" len="med"/>
-                    </a:lnR>
-                    <a:lnT w="12700" cap="flat" cmpd="sng" algn="ctr">
-                      <a:solidFill>
-                        <a:srgbClr val="0F141A"/>
-                      </a:solidFill>
-                      <a:prstDash val="solid"/>
-                      <a:round/>
-                      <a:headEnd type="none" w="med" len="med"/>
-                      <a:tailEnd type="none" w="med" len="med"/>
-                    </a:lnT>
-                    <a:lnB w="12700" cap="flat" cmpd="sng" algn="ctr">
-                      <a:solidFill>
-                        <a:srgbClr val="0F141A"/>
-                      </a:solidFill>
-                      <a:prstDash val="solid"/>
-                      <a:round/>
-                      <a:headEnd type="none" w="med" len="med"/>
-                      <a:tailEnd type="none" w="med" len="med"/>
-                    </a:lnB>
-                    <a:solidFill>
-                      <a:srgbClr val="161D25"/>
-                    </a:solidFill>
-                  </a:tcPr>
-                </a:tc>
-                <a:tc>
-                  <a:txBody>
-                    <a:bodyPr/>
-                    <a:lstStyle/>
-                    <a:p>
-                      <a:pPr algn="ctr" indent="0" marL="0">
-                        <a:buNone/>
-                      </a:pPr>
-                      <a:r>
-                        <a:rPr lang="en-US" sz="1100" dirty="0">
-                          <a:solidFill>
-                            <a:srgbClr val="EEF1F4"/>
-                          </a:solidFill>
-                          <a:latin typeface="Arial" pitchFamily="34" charset="0"/>
-                          <a:ea typeface="Arial" pitchFamily="34" charset="-122"/>
-                          <a:cs typeface="Arial" pitchFamily="34" charset="-120"/>
-                        </a:rPr>
-                        <a:t>4</a:t>
-                      </a:r>
-                      <a:endParaRPr lang="en-US" sz="1100" dirty="0">
-                        <a:latin typeface="Arial" charset="0"/>
-                        <a:ea typeface="Arial" charset="0"/>
-                        <a:cs typeface="Arial" charset="0"/>
-                      </a:endParaRPr>
-                    </a:p>
-                  </a:txBody>
-                  <a:tcPr marL="45720" marR="45720" marT="18288" marB="18288" anchor="ctr">
-                    <a:lnL w="12700" cap="flat" cmpd="sng" algn="ctr">
-                      <a:solidFill>
-                        <a:srgbClr val="0F141A"/>
-                      </a:solidFill>
-                      <a:prstDash val="solid"/>
-                      <a:round/>
-                      <a:headEnd type="none" w="med" len="med"/>
-                      <a:tailEnd type="none" w="med" len="med"/>
-                    </a:lnL>
-                    <a:lnR w="12700" cap="flat" cmpd="sng" algn="ctr">
-                      <a:solidFill>
-                        <a:srgbClr val="0F141A"/>
-                      </a:solidFill>
-                      <a:prstDash val="solid"/>
-                      <a:round/>
-                      <a:headEnd type="none" w="med" len="med"/>
-                      <a:tailEnd type="none" w="med" len="med"/>
-                    </a:lnR>
-                    <a:lnT w="12700" cap="flat" cmpd="sng" algn="ctr">
-                      <a:solidFill>
-                        <a:srgbClr val="0F141A"/>
-                      </a:solidFill>
-                      <a:prstDash val="solid"/>
-                      <a:round/>
-                      <a:headEnd type="none" w="med" len="med"/>
-                      <a:tailEnd type="none" w="med" len="med"/>
-                    </a:lnT>
-                    <a:lnB w="12700" cap="flat" cmpd="sng" algn="ctr">
-                      <a:solidFill>
-                        <a:srgbClr val="0F141A"/>
-                      </a:solidFill>
-                      <a:prstDash val="solid"/>
-                      <a:round/>
-                      <a:headEnd type="none" w="med" len="med"/>
-                      <a:tailEnd type="none" w="med" len="med"/>
-                    </a:lnB>
-                    <a:solidFill>
-                      <a:srgbClr val="161D25"/>
-                    </a:solidFill>
-                  </a:tcPr>
-                </a:tc>
-                <a:tc>
-                  <a:txBody>
-                    <a:bodyPr/>
-                    <a:lstStyle/>
-                    <a:p>
-                      <a:pPr algn="ctr" indent="0" marL="0">
-                        <a:buNone/>
-                      </a:pPr>
-                      <a:endParaRPr lang="en-US" sz="1100" dirty="0">
-                        <a:latin typeface="Arial" charset="0"/>
-                        <a:ea typeface="Arial" charset="0"/>
-                        <a:cs typeface="Arial" charset="0"/>
-                      </a:endParaRPr>
-                    </a:p>
-                  </a:txBody>
-                  <a:tcPr marL="45720" marR="45720" marT="18288" marB="18288" anchor="ctr">
-                    <a:lnL w="12700" cap="flat" cmpd="sng" algn="ctr">
-                      <a:solidFill>
-                        <a:srgbClr val="0F141A"/>
-                      </a:solidFill>
-                      <a:prstDash val="solid"/>
-                      <a:round/>
-                      <a:headEnd type="none" w="med" len="med"/>
-                      <a:tailEnd type="none" w="med" len="med"/>
-                    </a:lnL>
-                    <a:lnR w="12700" cap="flat" cmpd="sng" algn="ctr">
-                      <a:solidFill>
-                        <a:srgbClr val="0F141A"/>
-                      </a:solidFill>
-                      <a:prstDash val="solid"/>
-                      <a:round/>
-                      <a:headEnd type="none" w="med" len="med"/>
-                      <a:tailEnd type="none" w="med" len="med"/>
-                    </a:lnR>
-                    <a:lnT w="12700" cap="flat" cmpd="sng" algn="ctr">
-                      <a:solidFill>
-                        <a:srgbClr val="0F141A"/>
-                      </a:solidFill>
-                      <a:prstDash val="solid"/>
-                      <a:round/>
-                      <a:headEnd type="none" w="med" len="med"/>
-                      <a:tailEnd type="none" w="med" len="med"/>
-                    </a:lnT>
-                    <a:lnB w="12700" cap="flat" cmpd="sng" algn="ctr">
-                      <a:solidFill>
-                        <a:srgbClr val="0F141A"/>
-                      </a:solidFill>
-                      <a:prstDash val="solid"/>
-                      <a:round/>
-                      <a:headEnd type="none" w="med" len="med"/>
-                      <a:tailEnd type="none" w="med" len="med"/>
-                    </a:lnB>
-                    <a:solidFill>
-                      <a:srgbClr val="161D25"/>
-                    </a:solidFill>
-                  </a:tcPr>
-                </a:tc>
-                <a:tc>
-                  <a:txBody>
-                    <a:bodyPr/>
-                    <a:lstStyle/>
-                    <a:p>
-                      <a:pPr algn="ctr" indent="0" marL="0">
-                        <a:buNone/>
-                      </a:pPr>
-                      <a:r>
-                        <a:rPr lang="en-US" sz="1100" b="1" dirty="0">
-                          <a:solidFill>
-                            <a:srgbClr val="EEF1F4"/>
-                          </a:solidFill>
-                          <a:latin typeface="Arial" pitchFamily="34" charset="0"/>
-                          <a:ea typeface="Arial" pitchFamily="34" charset="-122"/>
-                          <a:cs typeface="Arial" pitchFamily="34" charset="-120"/>
-                        </a:rPr>
-                        <a:t>GSQZ880.6</a:t>
-                      </a:r>
-                      <a:endParaRPr lang="en-US" sz="1100" dirty="0">
-                        <a:latin typeface="Arial" charset="0"/>
-                        <a:ea typeface="Arial" charset="0"/>
-                        <a:cs typeface="Arial" charset="0"/>
-                      </a:endParaRPr>
-                    </a:p>
-                  </a:txBody>
-                  <a:tcPr marL="45720" marR="45720" marT="18288" marB="18288" anchor="ctr">
-                    <a:lnL w="12700" cap="flat" cmpd="sng" algn="ctr">
-                      <a:solidFill>
-                        <a:srgbClr val="0F141A"/>
-                      </a:solidFill>
-                      <a:prstDash val="solid"/>
-                      <a:round/>
-                      <a:headEnd type="none" w="med" len="med"/>
-                      <a:tailEnd type="none" w="med" len="med"/>
-                    </a:lnL>
-                    <a:lnR w="12700" cap="flat" cmpd="sng" algn="ctr">
-                      <a:solidFill>
-                        <a:srgbClr val="0F141A"/>
-                      </a:solidFill>
-                      <a:prstDash val="solid"/>
-                      <a:round/>
-                      <a:headEnd type="none" w="med" len="med"/>
-                      <a:tailEnd type="none" w="med" len="med"/>
-                    </a:lnR>
-                    <a:lnT w="12700" cap="flat" cmpd="sng" algn="ctr">
-                      <a:solidFill>
-                        <a:srgbClr val="0F141A"/>
-                      </a:solidFill>
-                      <a:prstDash val="solid"/>
-                      <a:round/>
-                      <a:headEnd type="none" w="med" len="med"/>
-                      <a:tailEnd type="none" w="med" len="med"/>
-                    </a:lnT>
-                    <a:lnB w="12700" cap="flat" cmpd="sng" algn="ctr">
-                      <a:solidFill>
-                        <a:srgbClr val="0F141A"/>
-                      </a:solidFill>
-                      <a:prstDash val="solid"/>
-                      <a:round/>
-                      <a:headEnd type="none" w="med" len="med"/>
-                      <a:tailEnd type="none" w="med" len="med"/>
-                    </a:lnB>
-                    <a:solidFill>
-                      <a:srgbClr val="161D25"/>
-                    </a:solidFill>
-                  </a:tcPr>
-                </a:tc>
-                <a:tc>
-                  <a:txBody>
-                    <a:bodyPr/>
-                    <a:lstStyle/>
-                    <a:p>
-                      <a:pPr algn="ctr" indent="0" marL="0">
-                        <a:buNone/>
-                      </a:pPr>
-                      <a:r>
-                        <a:rPr lang="en-US" sz="1100" dirty="0">
-                          <a:solidFill>
-                            <a:srgbClr val="EEF1F4"/>
-                          </a:solidFill>
-                          <a:latin typeface="Arial" pitchFamily="34" charset="0"/>
-                          <a:ea typeface="Arial" pitchFamily="34" charset="-122"/>
-                          <a:cs typeface="Arial" pitchFamily="34" charset="-120"/>
-                        </a:rPr>
-                        <a:t>88</a:t>
-                      </a:r>
-                      <a:endParaRPr lang="en-US" sz="1100" dirty="0">
-                        <a:latin typeface="Arial" charset="0"/>
-                        <a:ea typeface="Arial" charset="0"/>
-                        <a:cs typeface="Arial" charset="0"/>
-                      </a:endParaRPr>
-                    </a:p>
-                  </a:txBody>
-                  <a:tcPr marL="45720" marR="45720" marT="18288" marB="18288" anchor="ctr">
-                    <a:lnL w="12700" cap="flat" cmpd="sng" algn="ctr">
-                      <a:solidFill>
-                        <a:srgbClr val="0F141A"/>
-                      </a:solidFill>
-                      <a:prstDash val="solid"/>
-                      <a:round/>
-                      <a:headEnd type="none" w="med" len="med"/>
-                      <a:tailEnd type="none" w="med" len="med"/>
-                    </a:lnL>
-                    <a:lnR w="12700" cap="flat" cmpd="sng" algn="ctr">
-                      <a:solidFill>
-                        <a:srgbClr val="0F141A"/>
-                      </a:solidFill>
-                      <a:prstDash val="solid"/>
-                      <a:round/>
-                      <a:headEnd type="none" w="med" len="med"/>
-                      <a:tailEnd type="none" w="med" len="med"/>
-                    </a:lnR>
-                    <a:lnT w="12700" cap="flat" cmpd="sng" algn="ctr">
-                      <a:solidFill>
-                        <a:srgbClr val="0F141A"/>
-                      </a:solidFill>
-                      <a:prstDash val="solid"/>
-                      <a:round/>
-                      <a:headEnd type="none" w="med" len="med"/>
-                      <a:tailEnd type="none" w="med" len="med"/>
-                    </a:lnT>
-                    <a:lnB w="12700" cap="flat" cmpd="sng" algn="ctr">
-                      <a:solidFill>
-                        <a:srgbClr val="0F141A"/>
-                      </a:solidFill>
-                      <a:prstDash val="solid"/>
-                      <a:round/>
-                      <a:headEnd type="none" w="med" len="med"/>
-                      <a:tailEnd type="none" w="med" len="med"/>
-                    </a:lnB>
-                    <a:solidFill>
-                      <a:srgbClr val="161D25"/>
-                    </a:solidFill>
-                  </a:tcPr>
-                </a:tc>
-                <a:tc>
-                  <a:txBody>
-                    <a:bodyPr/>
-                    <a:lstStyle/>
-                    <a:p>
-                      <a:pPr algn="ctr" indent="0" marL="0">
-                        <a:buNone/>
-                      </a:pPr>
-                      <a:r>
-                        <a:rPr lang="en-US" sz="1100" dirty="0">
-                          <a:solidFill>
-                            <a:srgbClr val="EEF1F4"/>
-                          </a:solidFill>
-                          <a:latin typeface="Arial" pitchFamily="34" charset="0"/>
-                          <a:ea typeface="Arial" pitchFamily="34" charset="-122"/>
-                          <a:cs typeface="Arial" pitchFamily="34" charset="-120"/>
-                        </a:rPr>
-                        <a:t>2 · 50%</a:t>
-                      </a:r>
-                      <a:endParaRPr lang="en-US" sz="1100" dirty="0">
-                        <a:latin typeface="Arial" charset="0"/>
-                        <a:ea typeface="Arial" charset="0"/>
-                        <a:cs typeface="Arial" charset="0"/>
-                      </a:endParaRPr>
-                    </a:p>
-                  </a:txBody>
-                  <a:tcPr marL="45720" marR="45720" marT="18288" marB="18288" anchor="ctr">
-                    <a:lnL w="12700" cap="flat" cmpd="sng" algn="ctr">
-                      <a:solidFill>
-                        <a:srgbClr val="0F141A"/>
-                      </a:solidFill>
-                      <a:prstDash val="solid"/>
-                      <a:round/>
-                      <a:headEnd type="none" w="med" len="med"/>
-                      <a:tailEnd type="none" w="med" len="med"/>
-                    </a:lnL>
-                    <a:lnR w="12700" cap="flat" cmpd="sng" algn="ctr">
-                      <a:solidFill>
-                        <a:srgbClr val="0F141A"/>
-                      </a:solidFill>
-                      <a:prstDash val="solid"/>
-                      <a:round/>
-                      <a:headEnd type="none" w="med" len="med"/>
-                      <a:tailEnd type="none" w="med" len="med"/>
-                    </a:lnR>
-                    <a:lnT w="12700" cap="flat" cmpd="sng" algn="ctr">
-                      <a:solidFill>
-                        <a:srgbClr val="0F141A"/>
-                      </a:solidFill>
-                      <a:prstDash val="solid"/>
-                      <a:round/>
-                      <a:headEnd type="none" w="med" len="med"/>
-                      <a:tailEnd type="none" w="med" len="med"/>
-                    </a:lnT>
-                    <a:lnB w="12700" cap="flat" cmpd="sng" algn="ctr">
-                      <a:solidFill>
-                        <a:srgbClr val="0F141A"/>
-                      </a:solidFill>
-                      <a:prstDash val="solid"/>
-                      <a:round/>
-                      <a:headEnd type="none" w="med" len="med"/>
-                      <a:tailEnd type="none" w="med" len="med"/>
-                    </a:lnB>
-                    <a:solidFill>
-                      <a:srgbClr val="161D25"/>
-                    </a:solidFill>
-                  </a:tcPr>
-                </a:tc>
-                <a:tc>
-                  <a:txBody>
-                    <a:bodyPr/>
-                    <a:lstStyle/>
-                    <a:p>
-                      <a:pPr algn="ctr" indent="0" marL="0">
-                        <a:buNone/>
-                      </a:pPr>
-                      <a:r>
-                        <a:rPr lang="en-US" sz="1100" dirty="0">
-                          <a:solidFill>
-                            <a:srgbClr val="EEF1F4"/>
-                          </a:solidFill>
-                          <a:latin typeface="Arial" pitchFamily="34" charset="0"/>
-                          <a:ea typeface="Arial" pitchFamily="34" charset="-122"/>
-                          <a:cs typeface="Arial" pitchFamily="34" charset="-120"/>
-                        </a:rPr>
-                        <a:t>Rp 1.320.000.000</a:t>
-                      </a:r>
-                      <a:endParaRPr lang="en-US" sz="1100" dirty="0">
-                        <a:latin typeface="Arial" charset="0"/>
-                        <a:ea typeface="Arial" charset="0"/>
-                        <a:cs typeface="Arial" charset="0"/>
-                      </a:endParaRPr>
-                    </a:p>
-                  </a:txBody>
-                  <a:tcPr marL="45720" marR="45720" marT="18288" marB="18288" anchor="ctr">
-                    <a:lnL w="12700" cap="flat" cmpd="sng" algn="ctr">
-                      <a:solidFill>
-                        <a:srgbClr val="0F141A"/>
-                      </a:solidFill>
-                      <a:prstDash val="solid"/>
-                      <a:round/>
-                      <a:headEnd type="none" w="med" len="med"/>
-                      <a:tailEnd type="none" w="med" len="med"/>
-                    </a:lnL>
-                    <a:lnR w="12700" cap="flat" cmpd="sng" algn="ctr">
-                      <a:solidFill>
-                        <a:srgbClr val="0F141A"/>
-                      </a:solidFill>
-                      <a:prstDash val="solid"/>
-                      <a:round/>
-                      <a:headEnd type="none" w="med" len="med"/>
-                      <a:tailEnd type="none" w="med" len="med"/>
-                    </a:lnR>
-                    <a:lnT w="12700" cap="flat" cmpd="sng" algn="ctr">
-                      <a:solidFill>
-                        <a:srgbClr val="0F141A"/>
-                      </a:solidFill>
-                      <a:prstDash val="solid"/>
-                      <a:round/>
-                      <a:headEnd type="none" w="med" len="med"/>
-                      <a:tailEnd type="none" w="med" len="med"/>
-                    </a:lnT>
-                    <a:lnB w="12700" cap="flat" cmpd="sng" algn="ctr">
-                      <a:solidFill>
-                        <a:srgbClr val="0F141A"/>
-                      </a:solidFill>
-                      <a:prstDash val="solid"/>
-                      <a:round/>
-                      <a:headEnd type="none" w="med" len="med"/>
-                      <a:tailEnd type="none" w="med" len="med"/>
-                    </a:lnB>
-                    <a:solidFill>
-                      <a:srgbClr val="161D25"/>
-                    </a:solidFill>
-                  </a:tcPr>
-                </a:tc>
-                <a:tc gridSpan="3">
-                  <a:txBody>
-                    <a:bodyPr/>
-                    <a:lstStyle/>
-                    <a:p>
-                      <a:pPr algn="ctr" indent="0" marL="0">
-                        <a:buNone/>
-                      </a:pPr>
-                      <a:r>
-                        <a:rPr lang="en-US" sz="1100" b="1" dirty="0">
-                          <a:solidFill>
-                            <a:srgbClr val="E30613"/>
-                          </a:solidFill>
-                          <a:latin typeface="Arial" pitchFamily="34" charset="0"/>
-                          <a:ea typeface="Arial" pitchFamily="34" charset="-122"/>
-                          <a:cs typeface="Arial" pitchFamily="34" charset="-120"/>
-                        </a:rPr>
-                        <a:t>No Ferrari model</a:t>
-                      </a:r>
-                      <a:endParaRPr lang="en-US" sz="1100" dirty="0">
-                        <a:latin typeface="Arial" charset="0"/>
-                        <a:ea typeface="Arial" charset="0"/>
-                        <a:cs typeface="Arial" charset="0"/>
-                      </a:endParaRPr>
-                    </a:p>
-                  </a:txBody>
-                  <a:tcPr marL="45720" marR="45720" marT="18288" marB="18288" anchor="ctr">
-                    <a:lnL w="12700" cap="flat" cmpd="sng" algn="ctr">
-                      <a:solidFill>
-                        <a:srgbClr val="0F141A"/>
-                      </a:solidFill>
-                      <a:prstDash val="solid"/>
-                      <a:round/>
-                      <a:headEnd type="none" w="med" len="med"/>
-                      <a:tailEnd type="none" w="med" len="med"/>
-                    </a:lnL>
-                    <a:lnR w="12700" cap="flat" cmpd="sng" algn="ctr">
-                      <a:solidFill>
-                        <a:srgbClr val="0F141A"/>
-                      </a:solidFill>
-                      <a:prstDash val="solid"/>
-                      <a:round/>
-                      <a:headEnd type="none" w="med" len="med"/>
-                      <a:tailEnd type="none" w="med" len="med"/>
-                    </a:lnR>
-                    <a:lnT w="12700" cap="flat" cmpd="sng" algn="ctr">
-                      <a:solidFill>
-                        <a:srgbClr val="0F141A"/>
-                      </a:solidFill>
-                      <a:prstDash val="solid"/>
-                      <a:round/>
-                      <a:headEnd type="none" w="med" len="med"/>
-                      <a:tailEnd type="none" w="med" len="med"/>
-                    </a:lnT>
-                    <a:lnB w="12700" cap="flat" cmpd="sng" algn="ctr">
-                      <a:solidFill>
-                        <a:srgbClr val="0F141A"/>
-                      </a:solidFill>
-                      <a:prstDash val="solid"/>
-                      <a:round/>
-                      <a:headEnd type="none" w="med" len="med"/>
-                      <a:tailEnd type="none" w="med" len="med"/>
-                    </a:lnB>
-                    <a:solidFill>
-                      <a:srgbClr val="161D25"/>
-                    </a:solidFill>
-                  </a:tcPr>
-                </a:tc>
-                <a:tc hMerge="1">
-                  <a:tcPr/>
-                </a:tc>
-                <a:tc hMerge="1">
-                  <a:tcPr/>
                 </a:tc>
               </a:tr>
             </a:tbl>
@@ -10254,7 +7808,7 @@
         </p:nvSpPr>
         <p:spPr>
           <a:xfrm>
-            <a:off x="2514600" y="2096589"/>
+            <a:off x="2514600" y="2194560"/>
             <a:ext cx="1143000" cy="329184"/>
           </a:xfrm>
           <a:prstGeom prst="roundRect">
@@ -10289,7 +7843,7 @@
         </p:blipFill>
         <p:spPr>
           <a:xfrm>
-            <a:off x="2560320" y="2143530"/>
+            <a:off x="2560320" y="2241502"/>
             <a:ext cx="1051560" cy="235301"/>
           </a:xfrm>
           <a:prstGeom prst="rect">
@@ -10305,7 +7859,7 @@
         </p:nvSpPr>
         <p:spPr>
           <a:xfrm>
-            <a:off x="2514600" y="2632166"/>
+            <a:off x="2514600" y="2926080"/>
             <a:ext cx="1143000" cy="329184"/>
           </a:xfrm>
           <a:prstGeom prst="roundRect">
@@ -10340,7 +7894,7 @@
         </p:blipFill>
         <p:spPr>
           <a:xfrm>
-            <a:off x="2560320" y="2680332"/>
+            <a:off x="2560320" y="2974246"/>
             <a:ext cx="1051560" cy="232852"/>
           </a:xfrm>
           <a:prstGeom prst="rect">
@@ -10356,7 +7910,7 @@
         </p:nvSpPr>
         <p:spPr>
           <a:xfrm>
-            <a:off x="2514600" y="3167743"/>
+            <a:off x="2514600" y="3657600"/>
             <a:ext cx="1143000" cy="329184"/>
           </a:xfrm>
           <a:prstGeom prst="roundRect">
@@ -10377,7 +7931,7 @@
       </p:sp>
       <p:pic>
         <p:nvPicPr>
-          <p:cNvPr id="14" name="Image 2" descr="assets/logo_hyva.png">    </p:cNvPr>
+          <p:cNvPr id="14" name="Image 2" descr="assets/logo_palfinger.png">    </p:cNvPr>
           <p:cNvPicPr>
             <a:picLocks noChangeAspect="1"/>
           </p:cNvPicPr>
@@ -10391,8 +7945,8 @@
         </p:blipFill>
         <p:spPr>
           <a:xfrm>
-            <a:off x="2815986" y="3204319"/>
-            <a:ext cx="540228" cy="256032"/>
+            <a:off x="2560320" y="3705766"/>
+            <a:ext cx="1051560" cy="232852"/>
           </a:xfrm>
           <a:prstGeom prst="rect">
             <a:avLst/>
@@ -10407,212 +7961,8 @@
         </p:nvSpPr>
         <p:spPr>
           <a:xfrm>
-            <a:off x="2514600" y="3703320"/>
-            <a:ext cx="1143000" cy="329184"/>
-          </a:xfrm>
-          <a:prstGeom prst="roundRect">
-            <a:avLst>
-              <a:gd name="adj" fmla="val 11111"/>
-            </a:avLst>
-          </a:prstGeom>
-          <a:solidFill>
-            <a:srgbClr val="FFFFFF"/>
-          </a:solidFill>
-          <a:ln w="12700">
-            <a:solidFill>
-              <a:srgbClr val="FFFFFF"/>
-            </a:solidFill>
-            <a:prstDash val="solid"/>
-          </a:ln>
-        </p:spPr>
-      </p:sp>
-      <p:pic>
-        <p:nvPicPr>
-          <p:cNvPr id="16" name="Image 3" descr="assets/logo_sanypalfinger.png">    </p:cNvPr>
-          <p:cNvPicPr>
-            <a:picLocks noChangeAspect="1"/>
-          </p:cNvPicPr>
-          <p:nvPr/>
-        </p:nvPicPr>
-        <p:blipFill>
-          <a:blip r:embed="rId4"/>
-          <a:stretch>
-            <a:fillRect/>
-          </a:stretch>
-        </p:blipFill>
-        <p:spPr>
-          <a:xfrm>
-            <a:off x="2560320" y="3755901"/>
-            <a:ext cx="1051560" cy="224022"/>
-          </a:xfrm>
-          <a:prstGeom prst="rect">
-            <a:avLst/>
-          </a:prstGeom>
-        </p:spPr>
-      </p:pic>
-      <p:sp>
-        <p:nvSpPr>
-          <p:cNvPr id="17" name="Shape 10"/>
-          <p:cNvSpPr/>
-          <p:nvPr/>
-        </p:nvSpPr>
-        <p:spPr>
-          <a:xfrm>
-            <a:off x="2514600" y="4238897"/>
-            <a:ext cx="1143000" cy="329184"/>
-          </a:xfrm>
-          <a:prstGeom prst="roundRect">
-            <a:avLst>
-              <a:gd name="adj" fmla="val 11111"/>
-            </a:avLst>
-          </a:prstGeom>
-          <a:solidFill>
-            <a:srgbClr val="FFFFFF"/>
-          </a:solidFill>
-          <a:ln w="12700">
-            <a:solidFill>
-              <a:srgbClr val="FFFFFF"/>
-            </a:solidFill>
-            <a:prstDash val="solid"/>
-          </a:ln>
-        </p:spPr>
-      </p:sp>
-      <p:pic>
-        <p:nvPicPr>
-          <p:cNvPr id="18" name="Image 4" descr="assets/logo_palfinger.png">    </p:cNvPr>
-          <p:cNvPicPr>
-            <a:picLocks noChangeAspect="1"/>
-          </p:cNvPicPr>
-          <p:nvPr/>
-        </p:nvPicPr>
-        <p:blipFill>
-          <a:blip r:embed="rId5"/>
-          <a:stretch>
-            <a:fillRect/>
-          </a:stretch>
-        </p:blipFill>
-        <p:spPr>
-          <a:xfrm>
-            <a:off x="2560320" y="4287063"/>
-            <a:ext cx="1051560" cy="232852"/>
-          </a:xfrm>
-          <a:prstGeom prst="rect">
-            <a:avLst/>
-          </a:prstGeom>
-        </p:spPr>
-      </p:pic>
-      <p:sp>
-        <p:nvSpPr>
-          <p:cNvPr id="19" name="Shape 11"/>
-          <p:cNvSpPr/>
-          <p:nvPr/>
-        </p:nvSpPr>
-        <p:spPr>
-          <a:xfrm>
-            <a:off x="2514600" y="4774474"/>
-            <a:ext cx="1143000" cy="329184"/>
-          </a:xfrm>
-          <a:prstGeom prst="roundRect">
-            <a:avLst>
-              <a:gd name="adj" fmla="val 11111"/>
-            </a:avLst>
-          </a:prstGeom>
-          <a:solidFill>
-            <a:srgbClr val="FFFFFF"/>
-          </a:solidFill>
-          <a:ln w="12700">
-            <a:solidFill>
-              <a:srgbClr val="FFFFFF"/>
-            </a:solidFill>
-            <a:prstDash val="solid"/>
-          </a:ln>
-        </p:spPr>
-      </p:sp>
-      <p:pic>
-        <p:nvPicPr>
-          <p:cNvPr id="20" name="Image 5" descr="assets/logo_palfinger.png">    </p:cNvPr>
-          <p:cNvPicPr>
-            <a:picLocks noChangeAspect="1"/>
-          </p:cNvPicPr>
-          <p:nvPr/>
-        </p:nvPicPr>
-        <p:blipFill>
-          <a:blip r:embed="rId6"/>
-          <a:stretch>
-            <a:fillRect/>
-          </a:stretch>
-        </p:blipFill>
-        <p:spPr>
-          <a:xfrm>
-            <a:off x="2560320" y="4822640"/>
-            <a:ext cx="1051560" cy="232852"/>
-          </a:xfrm>
-          <a:prstGeom prst="rect">
-            <a:avLst/>
-          </a:prstGeom>
-        </p:spPr>
-      </p:pic>
-      <p:sp>
-        <p:nvSpPr>
-          <p:cNvPr id="21" name="Shape 12"/>
-          <p:cNvSpPr/>
-          <p:nvPr/>
-        </p:nvSpPr>
-        <p:spPr>
-          <a:xfrm>
-            <a:off x="2514600" y="5310051"/>
-            <a:ext cx="1143000" cy="329184"/>
-          </a:xfrm>
-          <a:prstGeom prst="roundRect">
-            <a:avLst>
-              <a:gd name="adj" fmla="val 11111"/>
-            </a:avLst>
-          </a:prstGeom>
-          <a:solidFill>
-            <a:srgbClr val="FFFFFF"/>
-          </a:solidFill>
-          <a:ln w="12700">
-            <a:solidFill>
-              <a:srgbClr val="FFFFFF"/>
-            </a:solidFill>
-            <a:prstDash val="solid"/>
-          </a:ln>
-        </p:spPr>
-      </p:sp>
-      <p:pic>
-        <p:nvPicPr>
-          <p:cNvPr id="22" name="Image 6" descr="assets/logo_xcmg.png">    </p:cNvPr>
-          <p:cNvPicPr>
-            <a:picLocks noChangeAspect="1"/>
-          </p:cNvPicPr>
-          <p:nvPr/>
-        </p:nvPicPr>
-        <p:blipFill>
-          <a:blip r:embed="rId7"/>
-          <a:stretch>
-            <a:fillRect/>
-          </a:stretch>
-        </p:blipFill>
-        <p:spPr>
-          <a:xfrm>
-            <a:off x="2560320" y="5360019"/>
-            <a:ext cx="1051560" cy="229248"/>
-          </a:xfrm>
-          <a:prstGeom prst="rect">
-            <a:avLst/>
-          </a:prstGeom>
-        </p:spPr>
-      </p:pic>
-      <p:sp>
-        <p:nvSpPr>
-          <p:cNvPr id="23" name="Shape 13"/>
-          <p:cNvSpPr/>
-          <p:nvPr/>
-        </p:nvSpPr>
-        <p:spPr>
-          <a:xfrm>
             <a:off x="411480" y="2011680"/>
-            <a:ext cx="411480" cy="3712464"/>
+            <a:ext cx="411480" cy="2157984"/>
           </a:xfrm>
           <a:prstGeom prst="rect">
             <a:avLst/>
@@ -10630,14 +7980,14 @@
       </p:sp>
       <p:sp>
         <p:nvSpPr>
-          <p:cNvPr id="24" name="Text 14"/>
+          <p:cNvPr id="16" name="Text 10"/>
           <p:cNvSpPr txBox="1"/>
           <p:nvPr/>
         </p:nvSpPr>
         <p:spPr>
           <a:xfrm rot="16200000">
-            <a:off x="-1257300" y="3662172"/>
-            <a:ext cx="3749040" cy="411480"/>
+            <a:off x="-480060" y="2884932"/>
+            <a:ext cx="2194560" cy="411480"/>
           </a:xfrm>
           <a:prstGeom prst="rect">
             <a:avLst/>
@@ -10669,13 +8019,13 @@
       </p:sp>
       <p:sp>
         <p:nvSpPr>
-          <p:cNvPr id="25" name="Shape 15"/>
+          <p:cNvPr id="17" name="Shape 11"/>
           <p:cNvSpPr/>
           <p:nvPr/>
         </p:nvSpPr>
         <p:spPr>
           <a:xfrm>
-            <a:off x="868680" y="5897880"/>
+            <a:off x="868680" y="4343400"/>
             <a:ext cx="164592" cy="128016"/>
           </a:xfrm>
           <a:prstGeom prst="rect">
@@ -10694,13 +8044,13 @@
       </p:sp>
       <p:sp>
         <p:nvSpPr>
-          <p:cNvPr id="26" name="Text 16"/>
+          <p:cNvPr id="18" name="Text 12"/>
           <p:cNvSpPr txBox="1"/>
           <p:nvPr/>
         </p:nvSpPr>
         <p:spPr>
           <a:xfrm>
-            <a:off x="1106424" y="5870448"/>
+            <a:off x="1106424" y="4315968"/>
             <a:ext cx="2834640" cy="201168"/>
           </a:xfrm>
           <a:prstGeom prst="rect">
@@ -10733,77 +8083,13 @@
       </p:sp>
       <p:sp>
         <p:nvSpPr>
-          <p:cNvPr id="27" name="Shape 17"/>
+          <p:cNvPr id="19" name="Shape 13"/>
           <p:cNvSpPr/>
           <p:nvPr/>
         </p:nvSpPr>
         <p:spPr>
           <a:xfrm>
-            <a:off x="3977640" y="5897880"/>
-            <a:ext cx="164592" cy="128016"/>
-          </a:xfrm>
-          <a:prstGeom prst="rect">
-            <a:avLst/>
-          </a:prstGeom>
-          <a:solidFill>
-            <a:srgbClr val="161D25"/>
-          </a:solidFill>
-          <a:ln w="12700">
-            <a:solidFill>
-              <a:srgbClr val="161D25"/>
-            </a:solidFill>
-            <a:prstDash val="solid"/>
-          </a:ln>
-        </p:spPr>
-      </p:sp>
-      <p:sp>
-        <p:nvSpPr>
-          <p:cNvPr id="28" name="Text 18"/>
-          <p:cNvSpPr txBox="1"/>
-          <p:nvPr/>
-        </p:nvSpPr>
-        <p:spPr>
-          <a:xfrm>
-            <a:off x="4215384" y="5870448"/>
-            <a:ext cx="2834640" cy="201168"/>
-          </a:xfrm>
-          <a:prstGeom prst="rect">
-            <a:avLst/>
-          </a:prstGeom>
-          <a:noFill/>
-          <a:ln/>
-        </p:spPr>
-        <p:txBody>
-          <a:bodyPr wrap="square" lIns="0" tIns="0" rIns="0" bIns="0" rtlCol="0" anchor="t"/>
-          <a:lstStyle/>
-          <a:p>
-            <a:pPr indent="0" marL="0">
-              <a:buNone/>
-            </a:pPr>
-            <a:r>
-              <a:rPr lang="en-US" sz="850" dirty="0">
-                <a:solidFill>
-                  <a:srgbClr val="9AA6B2"/>
-                </a:solidFill>
-                <a:latin typeface="Arial" pitchFamily="34" charset="0"/>
-                <a:ea typeface="Arial" pitchFamily="34" charset="-122"/>
-                <a:cs typeface="Arial" pitchFamily="34" charset="-120"/>
-              </a:rPr>
-              <a:t>Ferrari model exists, price not yet known</a:t>
-            </a:r>
-            <a:endParaRPr lang="en-US" sz="850" dirty="0"/>
-          </a:p>
-        </p:txBody>
-      </p:sp>
-      <p:sp>
-        <p:nvSpPr>
-          <p:cNvPr id="29" name="Shape 19"/>
-          <p:cNvSpPr/>
-          <p:nvPr/>
-        </p:nvSpPr>
-        <p:spPr>
-          <a:xfrm>
-            <a:off x="7086600" y="5897880"/>
+            <a:off x="3977640" y="4343400"/>
             <a:ext cx="164592" cy="128016"/>
           </a:xfrm>
           <a:prstGeom prst="rect">
@@ -10822,13 +8108,13 @@
       </p:sp>
       <p:sp>
         <p:nvSpPr>
-          <p:cNvPr id="30" name="Text 20"/>
+          <p:cNvPr id="20" name="Text 14"/>
           <p:cNvSpPr txBox="1"/>
           <p:nvPr/>
         </p:nvSpPr>
         <p:spPr>
           <a:xfrm>
-            <a:off x="7324344" y="5870448"/>
+            <a:off x="4215384" y="4315968"/>
             <a:ext cx="2834640" cy="201168"/>
           </a:xfrm>
           <a:prstGeom prst="rect">
@@ -10861,7 +8147,7 @@
       </p:sp>
       <p:sp>
         <p:nvSpPr>
-          <p:cNvPr id="31" name="Text 21"/>
+          <p:cNvPr id="21" name="Text 15"/>
           <p:cNvSpPr txBox="1"/>
           <p:nvPr/>
         </p:nvSpPr>
@@ -10892,7 +8178,7 @@
                 <a:ea typeface="Arial" pitchFamily="34" charset="-122"/>
                 <a:cs typeface="Arial" pitchFamily="34" charset="-120"/>
               </a:rPr>
-              <a:t>Source: Indonesia import records, HS 84269100 + 84264900, Jan 2023 – 14 Aug 2026; truck-mounted knuckle boom cranes only, Zoomlion excluded. Best-selling model = most units in the class (variants merged). Competitor price = average import unit price × Rp 17.803/USD (JISDOR 23 Sep 2026) + import duty (0% China – ACFTA; 5% Europe, assumed), PPN 11%, PPh 22 2.5% — import cost before distributor margin. Ferrari = catalogue model closest in tm to the best seller; price = TSP selling price to customers, crane only, incl. GP, warranty and tax. Prices rounded to Rp 10.000.000.</a:t>
+              <a:t>Source: Indonesia import records, HS 84269100 + 84264900, Jan 2023 – 14 Aug 2026; truck-mounted knuckle boom cranes only, Zoomlion excluded. Best-selling model = most units in the class (variants merged). Competitor price = average import unit price × Rp 17.803/USD (JISDOR 23 Sep 2026) + import duty (0% China – ACFTA; 5% Europe, assumed), PPN 11%, PPh 22 2.5% — import cost before distributor margin. Ferrari = catalogue model closest in tm to the best seller; price = TSP selling price to customers, crane only, incl. GP, warranty and tax. Classes above 55 tm merged (few units each); tied best sellers ranked by import value. Prices rounded to Rp 10.000.000.</a:t>
             </a:r>
             <a:endParaRPr lang="en-US" sz="750" dirty="0"/>
           </a:p>

</xml_diff>

<commit_message>
Exclude Hyva; add product photos to tm positioning slides
Co-Authored-By: Claude Opus 5.5 <noreply@anthropic.com>
Claude-Session: https://claude.ai/code/session_01Pbxjp9hvsGyGE8VjiFxi6d
</commit_message>
<xml_diff>
--- a/slides/Slide_tm_Positioning.pptx
+++ b/slides/Slide_tm_Positioning.pptx
@@ -1180,17 +1180,16 @@
               <a:tblPr/>
               <a:tblGrid>
                 <a:gridCol w="868680"/>
-                <a:gridCol w="685800"/>
+                <a:gridCol w="640080"/>
+                <a:gridCol w="1371600"/>
+                <a:gridCol w="1600200"/>
+                <a:gridCol w="822960"/>
+                <a:gridCol w="1371600"/>
+                <a:gridCol w="1371600"/>
                 <a:gridCol w="1325880"/>
-                <a:gridCol w="1371600"/>
-                <a:gridCol w="731520"/>
-                <a:gridCol w="914400"/>
-                <a:gridCol w="1417320"/>
-                <a:gridCol w="1325880"/>
-                <a:gridCol w="731520"/>
                 <a:gridCol w="1536192"/>
               </a:tblGrid>
-              <a:tr h="457200">
+              <a:tr h="411480">
                 <a:tc>
                   <a:txBody>
                     <a:bodyPr/>
@@ -1327,75 +1326,7 @@
                     </a:solidFill>
                   </a:tcPr>
                 </a:tc>
-                <a:tc>
-                  <a:txBody>
-                    <a:bodyPr/>
-                    <a:lstStyle/>
-                    <a:p>
-                      <a:pPr algn="ctr" indent="0" marL="0">
-                        <a:buNone/>
-                      </a:pPr>
-                      <a:r>
-                        <a:rPr lang="en-US" sz="900" b="1" dirty="0">
-                          <a:solidFill>
-                            <a:srgbClr val="9AA6B2"/>
-                          </a:solidFill>
-                          <a:latin typeface="Arial" pitchFamily="34" charset="0"/>
-                          <a:ea typeface="Arial" pitchFamily="34" charset="-122"/>
-                          <a:cs typeface="Arial" pitchFamily="34" charset="-120"/>
-                        </a:rPr>
-                        <a:t>Brand</a:t>
-                      </a:r>
-                      <a:endParaRPr lang="en-US" sz="900" dirty="0">
-                        <a:latin typeface="Arial" charset="0"/>
-                        <a:ea typeface="Arial" charset="0"/>
-                        <a:cs typeface="Arial" charset="0"/>
-                      </a:endParaRPr>
-                    </a:p>
-                  </a:txBody>
-                  <a:tcPr marL="45720" marR="45720" marT="18288" marB="18288" anchor="ctr">
-                    <a:lnL w="12700" cap="flat" cmpd="sng" algn="ctr">
-                      <a:solidFill>
-                        <a:srgbClr val="0F141A"/>
-                      </a:solidFill>
-                      <a:prstDash val="solid"/>
-                      <a:round/>
-                      <a:headEnd type="none" w="med" len="med"/>
-                      <a:tailEnd type="none" w="med" len="med"/>
-                    </a:lnL>
-                    <a:lnR w="12700" cap="flat" cmpd="sng" algn="ctr">
-                      <a:solidFill>
-                        <a:srgbClr val="0F141A"/>
-                      </a:solidFill>
-                      <a:prstDash val="solid"/>
-                      <a:round/>
-                      <a:headEnd type="none" w="med" len="med"/>
-                      <a:tailEnd type="none" w="med" len="med"/>
-                    </a:lnR>
-                    <a:lnT w="12700" cap="flat" cmpd="sng" algn="ctr">
-                      <a:solidFill>
-                        <a:srgbClr val="0F141A"/>
-                      </a:solidFill>
-                      <a:prstDash val="solid"/>
-                      <a:round/>
-                      <a:headEnd type="none" w="med" len="med"/>
-                      <a:tailEnd type="none" w="med" len="med"/>
-                    </a:lnT>
-                    <a:lnB w="12700" cap="flat" cmpd="sng" algn="ctr">
-                      <a:solidFill>
-                        <a:srgbClr val="0F141A"/>
-                      </a:solidFill>
-                      <a:prstDash val="solid"/>
-                      <a:round/>
-                      <a:headEnd type="none" w="med" len="med"/>
-                      <a:tailEnd type="none" w="med" len="med"/>
-                    </a:lnB>
-                    <a:solidFill>
-                      <a:srgbClr val="26303A"/>
-                    </a:solidFill>
-                  </a:tcPr>
-                </a:tc>
-                <a:tc>
+                <a:tc gridSpan="2">
                   <a:txBody>
                     <a:bodyPr/>
                     <a:lstStyle/>
@@ -1463,73 +1394,8 @@
                     </a:solidFill>
                   </a:tcPr>
                 </a:tc>
-                <a:tc>
-                  <a:txBody>
-                    <a:bodyPr/>
-                    <a:lstStyle/>
-                    <a:p>
-                      <a:pPr algn="ctr" indent="0" marL="0">
-                        <a:buNone/>
-                      </a:pPr>
-                      <a:r>
-                        <a:rPr lang="en-US" sz="900" b="1" dirty="0">
-                          <a:solidFill>
-                            <a:srgbClr val="9AA6B2"/>
-                          </a:solidFill>
-                          <a:latin typeface="Arial" pitchFamily="34" charset="0"/>
-                          <a:ea typeface="Arial" pitchFamily="34" charset="-122"/>
-                          <a:cs typeface="Arial" pitchFamily="34" charset="-120"/>
-                        </a:rPr>
-                        <a:t>Max Lifting Moment (tm)</a:t>
-                      </a:r>
-                      <a:endParaRPr lang="en-US" sz="900" dirty="0">
-                        <a:latin typeface="Arial" charset="0"/>
-                        <a:ea typeface="Arial" charset="0"/>
-                        <a:cs typeface="Arial" charset="0"/>
-                      </a:endParaRPr>
-                    </a:p>
-                  </a:txBody>
-                  <a:tcPr marL="45720" marR="45720" marT="18288" marB="18288" anchor="ctr">
-                    <a:lnL w="12700" cap="flat" cmpd="sng" algn="ctr">
-                      <a:solidFill>
-                        <a:srgbClr val="0F141A"/>
-                      </a:solidFill>
-                      <a:prstDash val="solid"/>
-                      <a:round/>
-                      <a:headEnd type="none" w="med" len="med"/>
-                      <a:tailEnd type="none" w="med" len="med"/>
-                    </a:lnL>
-                    <a:lnR w="12700" cap="flat" cmpd="sng" algn="ctr">
-                      <a:solidFill>
-                        <a:srgbClr val="0F141A"/>
-                      </a:solidFill>
-                      <a:prstDash val="solid"/>
-                      <a:round/>
-                      <a:headEnd type="none" w="med" len="med"/>
-                      <a:tailEnd type="none" w="med" len="med"/>
-                    </a:lnR>
-                    <a:lnT w="12700" cap="flat" cmpd="sng" algn="ctr">
-                      <a:solidFill>
-                        <a:srgbClr val="0F141A"/>
-                      </a:solidFill>
-                      <a:prstDash val="solid"/>
-                      <a:round/>
-                      <a:headEnd type="none" w="med" len="med"/>
-                      <a:tailEnd type="none" w="med" len="med"/>
-                    </a:lnT>
-                    <a:lnB w="12700" cap="flat" cmpd="sng" algn="ctr">
-                      <a:solidFill>
-                        <a:srgbClr val="0F141A"/>
-                      </a:solidFill>
-                      <a:prstDash val="solid"/>
-                      <a:round/>
-                      <a:headEnd type="none" w="med" len="med"/>
-                      <a:tailEnd type="none" w="med" len="med"/>
-                    </a:lnB>
-                    <a:solidFill>
-                      <a:srgbClr val="26303A"/>
-                    </a:solidFill>
-                  </a:tcPr>
+                <a:tc hMerge="1">
+                  <a:tcPr/>
                 </a:tc>
                 <a:tc>
                   <a:txBody>
@@ -1667,7 +1533,7 @@
                     </a:solidFill>
                   </a:tcPr>
                 </a:tc>
-                <a:tc>
+                <a:tc gridSpan="2">
                   <a:txBody>
                     <a:bodyPr/>
                     <a:lstStyle/>
@@ -1735,73 +1601,8 @@
                     </a:solidFill>
                   </a:tcPr>
                 </a:tc>
-                <a:tc>
-                  <a:txBody>
-                    <a:bodyPr/>
-                    <a:lstStyle/>
-                    <a:p>
-                      <a:pPr algn="ctr" indent="0" marL="0">
-                        <a:buNone/>
-                      </a:pPr>
-                      <a:r>
-                        <a:rPr lang="en-US" sz="900" b="1" dirty="0">
-                          <a:solidFill>
-                            <a:srgbClr val="FFFFFF"/>
-                          </a:solidFill>
-                          <a:latin typeface="Arial" pitchFamily="34" charset="0"/>
-                          <a:ea typeface="Arial" pitchFamily="34" charset="-122"/>
-                          <a:cs typeface="Arial" pitchFamily="34" charset="-120"/>
-                        </a:rPr>
-                        <a:t>Max Lifting Moment (tm)</a:t>
-                      </a:r>
-                      <a:endParaRPr lang="en-US" sz="900" dirty="0">
-                        <a:latin typeface="Arial" charset="0"/>
-                        <a:ea typeface="Arial" charset="0"/>
-                        <a:cs typeface="Arial" charset="0"/>
-                      </a:endParaRPr>
-                    </a:p>
-                  </a:txBody>
-                  <a:tcPr marL="45720" marR="45720" marT="18288" marB="18288" anchor="ctr">
-                    <a:lnL w="12700" cap="flat" cmpd="sng" algn="ctr">
-                      <a:solidFill>
-                        <a:srgbClr val="0F141A"/>
-                      </a:solidFill>
-                      <a:prstDash val="solid"/>
-                      <a:round/>
-                      <a:headEnd type="none" w="med" len="med"/>
-                      <a:tailEnd type="none" w="med" len="med"/>
-                    </a:lnL>
-                    <a:lnR w="12700" cap="flat" cmpd="sng" algn="ctr">
-                      <a:solidFill>
-                        <a:srgbClr val="0F141A"/>
-                      </a:solidFill>
-                      <a:prstDash val="solid"/>
-                      <a:round/>
-                      <a:headEnd type="none" w="med" len="med"/>
-                      <a:tailEnd type="none" w="med" len="med"/>
-                    </a:lnR>
-                    <a:lnT w="12700" cap="flat" cmpd="sng" algn="ctr">
-                      <a:solidFill>
-                        <a:srgbClr val="0F141A"/>
-                      </a:solidFill>
-                      <a:prstDash val="solid"/>
-                      <a:round/>
-                      <a:headEnd type="none" w="med" len="med"/>
-                      <a:tailEnd type="none" w="med" len="med"/>
-                    </a:lnT>
-                    <a:lnB w="12700" cap="flat" cmpd="sng" algn="ctr">
-                      <a:solidFill>
-                        <a:srgbClr val="0F141A"/>
-                      </a:solidFill>
-                      <a:prstDash val="solid"/>
-                      <a:round/>
-                      <a:headEnd type="none" w="med" len="med"/>
-                      <a:tailEnd type="none" w="med" len="med"/>
-                    </a:lnB>
-                    <a:solidFill>
-                      <a:srgbClr val="E30613"/>
-                    </a:solidFill>
-                  </a:tcPr>
+                <a:tc hMerge="1">
+                  <a:tcPr/>
                 </a:tc>
                 <a:tc>
                   <a:txBody>
@@ -1872,7 +1673,7 @@
                   </a:tcPr>
                 </a:tc>
               </a:tr>
-              <a:tr h="731520">
+              <a:tr h="960120">
                 <a:tc>
                   <a:txBody>
                     <a:bodyPr/>
@@ -2074,85 +1875,6 @@
                       <a:pPr algn="ctr" indent="0" marL="0">
                         <a:buNone/>
                       </a:pPr>
-                      <a:r>
-                        <a:rPr lang="en-US" sz="1100" b="1" dirty="0">
-                          <a:solidFill>
-                            <a:srgbClr val="EEF1F4"/>
-                          </a:solidFill>
-                          <a:latin typeface="Arial" pitchFamily="34" charset="0"/>
-                          <a:ea typeface="Arial" pitchFamily="34" charset="-122"/>
-                          <a:cs typeface="Arial" pitchFamily="34" charset="-120"/>
-                        </a:rPr>
-                        <a:t>V825</a:t>
-                      </a:r>
-                      <a:endParaRPr lang="en-US" sz="1100" dirty="0">
-                        <a:latin typeface="Arial" charset="0"/>
-                        <a:ea typeface="Arial" charset="0"/>
-                        <a:cs typeface="Arial" charset="0"/>
-                      </a:endParaRPr>
-                    </a:p>
-                  </a:txBody>
-                  <a:tcPr marL="45720" marR="45720" marT="18288" marB="18288" anchor="ctr">
-                    <a:lnL w="12700" cap="flat" cmpd="sng" algn="ctr">
-                      <a:solidFill>
-                        <a:srgbClr val="0F141A"/>
-                      </a:solidFill>
-                      <a:prstDash val="solid"/>
-                      <a:round/>
-                      <a:headEnd type="none" w="med" len="med"/>
-                      <a:tailEnd type="none" w="med" len="med"/>
-                    </a:lnL>
-                    <a:lnR w="12700" cap="flat" cmpd="sng" algn="ctr">
-                      <a:solidFill>
-                        <a:srgbClr val="0F141A"/>
-                      </a:solidFill>
-                      <a:prstDash val="solid"/>
-                      <a:round/>
-                      <a:headEnd type="none" w="med" len="med"/>
-                      <a:tailEnd type="none" w="med" len="med"/>
-                    </a:lnR>
-                    <a:lnT w="12700" cap="flat" cmpd="sng" algn="ctr">
-                      <a:solidFill>
-                        <a:srgbClr val="0F141A"/>
-                      </a:solidFill>
-                      <a:prstDash val="solid"/>
-                      <a:round/>
-                      <a:headEnd type="none" w="med" len="med"/>
-                      <a:tailEnd type="none" w="med" len="med"/>
-                    </a:lnT>
-                    <a:lnB w="12700" cap="flat" cmpd="sng" algn="ctr">
-                      <a:solidFill>
-                        <a:srgbClr val="0F141A"/>
-                      </a:solidFill>
-                      <a:prstDash val="solid"/>
-                      <a:round/>
-                      <a:headEnd type="none" w="med" len="med"/>
-                      <a:tailEnd type="none" w="med" len="med"/>
-                    </a:lnB>
-                    <a:solidFill>
-                      <a:srgbClr val="161D25"/>
-                    </a:solidFill>
-                  </a:tcPr>
-                </a:tc>
-                <a:tc>
-                  <a:txBody>
-                    <a:bodyPr/>
-                    <a:lstStyle/>
-                    <a:p>
-                      <a:pPr algn="ctr" indent="0" marL="0">
-                        <a:buNone/>
-                      </a:pPr>
-                      <a:r>
-                        <a:rPr lang="en-US" sz="1100" dirty="0">
-                          <a:solidFill>
-                            <a:srgbClr val="EEF1F4"/>
-                          </a:solidFill>
-                          <a:latin typeface="Arial" pitchFamily="34" charset="0"/>
-                          <a:ea typeface="Arial" pitchFamily="34" charset="-122"/>
-                          <a:cs typeface="Arial" pitchFamily="34" charset="-120"/>
-                        </a:rPr>
-                        <a:t>25.6</a:t>
-                      </a:r>
                       <a:endParaRPr lang="en-US" sz="1100" dirty="0">
                         <a:latin typeface="Arial" charset="0"/>
                         <a:ea typeface="Arial" charset="0"/>
@@ -2346,17 +2068,6 @@
                       <a:pPr algn="ctr" indent="0" marL="0">
                         <a:buNone/>
                       </a:pPr>
-                      <a:r>
-                        <a:rPr lang="en-US" sz="1100" b="1" dirty="0">
-                          <a:solidFill>
-                            <a:srgbClr val="EEF1F4"/>
-                          </a:solidFill>
-                          <a:latin typeface="Arial" pitchFamily="34" charset="0"/>
-                          <a:ea typeface="Arial" pitchFamily="34" charset="-122"/>
-                          <a:cs typeface="Arial" pitchFamily="34" charset="-120"/>
-                        </a:rPr>
-                        <a:t>268 A4</a:t>
-                      </a:r>
                       <a:endParaRPr lang="en-US" sz="1100" dirty="0">
                         <a:latin typeface="Arial" charset="0"/>
                         <a:ea typeface="Arial" charset="0"/>
@@ -2414,17 +2125,6 @@
                       <a:pPr algn="ctr" indent="0" marL="0">
                         <a:buNone/>
                       </a:pPr>
-                      <a:r>
-                        <a:rPr lang="en-US" sz="1100" dirty="0">
-                          <a:solidFill>
-                            <a:srgbClr val="EEF1F4"/>
-                          </a:solidFill>
-                          <a:latin typeface="Arial" pitchFamily="34" charset="0"/>
-                          <a:ea typeface="Arial" pitchFamily="34" charset="-122"/>
-                          <a:cs typeface="Arial" pitchFamily="34" charset="-120"/>
-                        </a:rPr>
-                        <a:t>25.4</a:t>
-                      </a:r>
                       <a:endParaRPr lang="en-US" sz="1100" dirty="0">
                         <a:latin typeface="Arial" charset="0"/>
                         <a:ea typeface="Arial" charset="0"/>
@@ -2543,7 +2243,7 @@
                   </a:tcPr>
                 </a:tc>
               </a:tr>
-              <a:tr h="731520">
+              <a:tr h="960120">
                 <a:tc>
                   <a:txBody>
                     <a:bodyPr/>
@@ -2629,7 +2329,7 @@
                           <a:ea typeface="Arial" pitchFamily="34" charset="-122"/>
                           <a:cs typeface="Arial" pitchFamily="34" charset="-120"/>
                         </a:rPr>
-                        <a:t>77</a:t>
+                        <a:t>76</a:t>
                       </a:r>
                       <a:endParaRPr lang="en-US" sz="1100" dirty="0">
                         <a:latin typeface="Arial" charset="0"/>
@@ -2745,85 +2445,6 @@
                       <a:pPr algn="ctr" indent="0" marL="0">
                         <a:buNone/>
                       </a:pPr>
-                      <a:r>
-                        <a:rPr lang="en-US" sz="1100" b="1" dirty="0">
-                          <a:solidFill>
-                            <a:srgbClr val="EEF1F4"/>
-                          </a:solidFill>
-                          <a:latin typeface="Arial" pitchFamily="34" charset="0"/>
-                          <a:ea typeface="Arial" pitchFamily="34" charset="-122"/>
-                          <a:cs typeface="Arial" pitchFamily="34" charset="-120"/>
-                        </a:rPr>
-                        <a:t>SPK32080</a:t>
-                      </a:r>
-                      <a:endParaRPr lang="en-US" sz="1100" dirty="0">
-                        <a:latin typeface="Arial" charset="0"/>
-                        <a:ea typeface="Arial" charset="0"/>
-                        <a:cs typeface="Arial" charset="0"/>
-                      </a:endParaRPr>
-                    </a:p>
-                  </a:txBody>
-                  <a:tcPr marL="45720" marR="45720" marT="18288" marB="18288" anchor="ctr">
-                    <a:lnL w="12700" cap="flat" cmpd="sng" algn="ctr">
-                      <a:solidFill>
-                        <a:srgbClr val="0F141A"/>
-                      </a:solidFill>
-                      <a:prstDash val="solid"/>
-                      <a:round/>
-                      <a:headEnd type="none" w="med" len="med"/>
-                      <a:tailEnd type="none" w="med" len="med"/>
-                    </a:lnL>
-                    <a:lnR w="12700" cap="flat" cmpd="sng" algn="ctr">
-                      <a:solidFill>
-                        <a:srgbClr val="0F141A"/>
-                      </a:solidFill>
-                      <a:prstDash val="solid"/>
-                      <a:round/>
-                      <a:headEnd type="none" w="med" len="med"/>
-                      <a:tailEnd type="none" w="med" len="med"/>
-                    </a:lnR>
-                    <a:lnT w="12700" cap="flat" cmpd="sng" algn="ctr">
-                      <a:solidFill>
-                        <a:srgbClr val="0F141A"/>
-                      </a:solidFill>
-                      <a:prstDash val="solid"/>
-                      <a:round/>
-                      <a:headEnd type="none" w="med" len="med"/>
-                      <a:tailEnd type="none" w="med" len="med"/>
-                    </a:lnT>
-                    <a:lnB w="12700" cap="flat" cmpd="sng" algn="ctr">
-                      <a:solidFill>
-                        <a:srgbClr val="0F141A"/>
-                      </a:solidFill>
-                      <a:prstDash val="solid"/>
-                      <a:round/>
-                      <a:headEnd type="none" w="med" len="med"/>
-                      <a:tailEnd type="none" w="med" len="med"/>
-                    </a:lnB>
-                    <a:solidFill>
-                      <a:srgbClr val="161D25"/>
-                    </a:solidFill>
-                  </a:tcPr>
-                </a:tc>
-                <a:tc>
-                  <a:txBody>
-                    <a:bodyPr/>
-                    <a:lstStyle/>
-                    <a:p>
-                      <a:pPr algn="ctr" indent="0" marL="0">
-                        <a:buNone/>
-                      </a:pPr>
-                      <a:r>
-                        <a:rPr lang="en-US" sz="1100" dirty="0">
-                          <a:solidFill>
-                            <a:srgbClr val="EEF1F4"/>
-                          </a:solidFill>
-                          <a:latin typeface="Arial" pitchFamily="34" charset="0"/>
-                          <a:ea typeface="Arial" pitchFamily="34" charset="-122"/>
-                          <a:cs typeface="Arial" pitchFamily="34" charset="-120"/>
-                        </a:rPr>
-                        <a:t>30.4</a:t>
-                      </a:r>
                       <a:endParaRPr lang="en-US" sz="1100" dirty="0">
                         <a:latin typeface="Arial" charset="0"/>
                         <a:ea typeface="Arial" charset="0"/>
@@ -3017,17 +2638,6 @@
                       <a:pPr algn="ctr" indent="0" marL="0">
                         <a:buNone/>
                       </a:pPr>
-                      <a:r>
-                        <a:rPr lang="en-US" sz="1100" b="1" dirty="0">
-                          <a:solidFill>
-                            <a:srgbClr val="EEF1F4"/>
-                          </a:solidFill>
-                          <a:latin typeface="Arial" pitchFamily="34" charset="0"/>
-                          <a:ea typeface="Arial" pitchFamily="34" charset="-122"/>
-                          <a:cs typeface="Arial" pitchFamily="34" charset="-120"/>
-                        </a:rPr>
-                        <a:t>FBR350R A4</a:t>
-                      </a:r>
                       <a:endParaRPr lang="en-US" sz="1100" dirty="0">
                         <a:latin typeface="Arial" charset="0"/>
                         <a:ea typeface="Arial" charset="0"/>
@@ -3085,17 +2695,6 @@
                       <a:pPr algn="ctr" indent="0" marL="0">
                         <a:buNone/>
                       </a:pPr>
-                      <a:r>
-                        <a:rPr lang="en-US" sz="1100" dirty="0">
-                          <a:solidFill>
-                            <a:srgbClr val="EEF1F4"/>
-                          </a:solidFill>
-                          <a:latin typeface="Arial" pitchFamily="34" charset="0"/>
-                          <a:ea typeface="Arial" pitchFamily="34" charset="-122"/>
-                          <a:cs typeface="Arial" pitchFamily="34" charset="-120"/>
-                        </a:rPr>
-                        <a:t>32.8</a:t>
-                      </a:r>
                       <a:endParaRPr lang="en-US" sz="1100" dirty="0">
                         <a:latin typeface="Arial" charset="0"/>
                         <a:ea typeface="Arial" charset="0"/>
@@ -3214,7 +2813,7 @@
                   </a:tcPr>
                 </a:tc>
               </a:tr>
-              <a:tr h="731520">
+              <a:tr h="960120">
                 <a:tc>
                   <a:txBody>
                     <a:bodyPr/>
@@ -3416,85 +3015,6 @@
                       <a:pPr algn="ctr" indent="0" marL="0">
                         <a:buNone/>
                       </a:pPr>
-                      <a:r>
-                        <a:rPr lang="en-US" sz="1100" b="1" dirty="0">
-                          <a:solidFill>
-                            <a:srgbClr val="EEF1F4"/>
-                          </a:solidFill>
-                          <a:latin typeface="Arial" pitchFamily="34" charset="0"/>
-                          <a:ea typeface="Arial" pitchFamily="34" charset="-122"/>
-                          <a:cs typeface="Arial" pitchFamily="34" charset="-120"/>
-                        </a:rPr>
-                        <a:t>SPK36080</a:t>
-                      </a:r>
-                      <a:endParaRPr lang="en-US" sz="1100" dirty="0">
-                        <a:latin typeface="Arial" charset="0"/>
-                        <a:ea typeface="Arial" charset="0"/>
-                        <a:cs typeface="Arial" charset="0"/>
-                      </a:endParaRPr>
-                    </a:p>
-                  </a:txBody>
-                  <a:tcPr marL="45720" marR="45720" marT="18288" marB="18288" anchor="ctr">
-                    <a:lnL w="12700" cap="flat" cmpd="sng" algn="ctr">
-                      <a:solidFill>
-                        <a:srgbClr val="0F141A"/>
-                      </a:solidFill>
-                      <a:prstDash val="solid"/>
-                      <a:round/>
-                      <a:headEnd type="none" w="med" len="med"/>
-                      <a:tailEnd type="none" w="med" len="med"/>
-                    </a:lnL>
-                    <a:lnR w="12700" cap="flat" cmpd="sng" algn="ctr">
-                      <a:solidFill>
-                        <a:srgbClr val="0F141A"/>
-                      </a:solidFill>
-                      <a:prstDash val="solid"/>
-                      <a:round/>
-                      <a:headEnd type="none" w="med" len="med"/>
-                      <a:tailEnd type="none" w="med" len="med"/>
-                    </a:lnR>
-                    <a:lnT w="12700" cap="flat" cmpd="sng" algn="ctr">
-                      <a:solidFill>
-                        <a:srgbClr val="0F141A"/>
-                      </a:solidFill>
-                      <a:prstDash val="solid"/>
-                      <a:round/>
-                      <a:headEnd type="none" w="med" len="med"/>
-                      <a:tailEnd type="none" w="med" len="med"/>
-                    </a:lnT>
-                    <a:lnB w="12700" cap="flat" cmpd="sng" algn="ctr">
-                      <a:solidFill>
-                        <a:srgbClr val="0F141A"/>
-                      </a:solidFill>
-                      <a:prstDash val="solid"/>
-                      <a:round/>
-                      <a:headEnd type="none" w="med" len="med"/>
-                      <a:tailEnd type="none" w="med" len="med"/>
-                    </a:lnB>
-                    <a:solidFill>
-                      <a:srgbClr val="161D25"/>
-                    </a:solidFill>
-                  </a:tcPr>
-                </a:tc>
-                <a:tc>
-                  <a:txBody>
-                    <a:bodyPr/>
-                    <a:lstStyle/>
-                    <a:p>
-                      <a:pPr algn="ctr" indent="0" marL="0">
-                        <a:buNone/>
-                      </a:pPr>
-                      <a:r>
-                        <a:rPr lang="en-US" sz="1100" dirty="0">
-                          <a:solidFill>
-                            <a:srgbClr val="EEF1F4"/>
-                          </a:solidFill>
-                          <a:latin typeface="Arial" pitchFamily="34" charset="0"/>
-                          <a:ea typeface="Arial" pitchFamily="34" charset="-122"/>
-                          <a:cs typeface="Arial" pitchFamily="34" charset="-120"/>
-                        </a:rPr>
-                        <a:t>36</a:t>
-                      </a:r>
                       <a:endParaRPr lang="en-US" sz="1100" dirty="0">
                         <a:latin typeface="Arial" charset="0"/>
                         <a:ea typeface="Arial" charset="0"/>
@@ -3688,17 +3208,6 @@
                       <a:pPr algn="ctr" indent="0" marL="0">
                         <a:buNone/>
                       </a:pPr>
-                      <a:r>
-                        <a:rPr lang="en-US" sz="1100" b="1" dirty="0">
-                          <a:solidFill>
-                            <a:srgbClr val="EEF1F4"/>
-                          </a:solidFill>
-                          <a:latin typeface="Arial" pitchFamily="34" charset="0"/>
-                          <a:ea typeface="Arial" pitchFamily="34" charset="-122"/>
-                          <a:cs typeface="Arial" pitchFamily="34" charset="-120"/>
-                        </a:rPr>
-                        <a:t>7441C</a:t>
-                      </a:r>
                       <a:endParaRPr lang="en-US" sz="1100" dirty="0">
                         <a:latin typeface="Arial" charset="0"/>
                         <a:ea typeface="Arial" charset="0"/>
@@ -3756,17 +3265,6 @@
                       <a:pPr algn="ctr" indent="0" marL="0">
                         <a:buNone/>
                       </a:pPr>
-                      <a:r>
-                        <a:rPr lang="en-US" sz="1100" dirty="0">
-                          <a:solidFill>
-                            <a:srgbClr val="EEF1F4"/>
-                          </a:solidFill>
-                          <a:latin typeface="Arial" pitchFamily="34" charset="0"/>
-                          <a:ea typeface="Arial" pitchFamily="34" charset="-122"/>
-                          <a:cs typeface="Arial" pitchFamily="34" charset="-120"/>
-                        </a:rPr>
-                        <a:t>37.7</a:t>
-                      </a:r>
                       <a:endParaRPr lang="en-US" sz="1100" dirty="0">
                         <a:latin typeface="Arial" charset="0"/>
                         <a:ea typeface="Arial" charset="0"/>
@@ -3906,7 +3404,7 @@
                   </a:tcPr>
                 </a:tc>
               </a:tr>
-              <a:tr h="731520">
+              <a:tr h="960120">
                 <a:tc>
                   <a:txBody>
                     <a:bodyPr/>
@@ -3992,7 +3490,7 @@
                           <a:ea typeface="Arial" pitchFamily="34" charset="-122"/>
                           <a:cs typeface="Arial" pitchFamily="34" charset="-120"/>
                         </a:rPr>
-                        <a:t>26</a:t>
+                        <a:t>23</a:t>
                       </a:r>
                       <a:endParaRPr lang="en-US" sz="1100" dirty="0">
                         <a:latin typeface="Arial" charset="0"/>
@@ -4108,17 +3606,6 @@
                       <a:pPr algn="ctr" indent="0" marL="0">
                         <a:buNone/>
                       </a:pPr>
-                      <a:r>
-                        <a:rPr lang="en-US" sz="1100" b="1" dirty="0">
-                          <a:solidFill>
-                            <a:srgbClr val="EEF1F4"/>
-                          </a:solidFill>
-                          <a:latin typeface="Arial" pitchFamily="34" charset="0"/>
-                          <a:ea typeface="Arial" pitchFamily="34" charset="-122"/>
-                          <a:cs typeface="Arial" pitchFamily="34" charset="-120"/>
-                        </a:rPr>
-                        <a:t>SPK42502</a:t>
-                      </a:r>
                       <a:endParaRPr lang="en-US" sz="1100" dirty="0">
                         <a:latin typeface="Arial" charset="0"/>
                         <a:ea typeface="Arial" charset="0"/>
@@ -4185,75 +3672,7 @@
                           <a:ea typeface="Arial" pitchFamily="34" charset="-122"/>
                           <a:cs typeface="Arial" pitchFamily="34" charset="-120"/>
                         </a:rPr>
-                        <a:t>42.5</a:t>
-                      </a:r>
-                      <a:endParaRPr lang="en-US" sz="1100" dirty="0">
-                        <a:latin typeface="Arial" charset="0"/>
-                        <a:ea typeface="Arial" charset="0"/>
-                        <a:cs typeface="Arial" charset="0"/>
-                      </a:endParaRPr>
-                    </a:p>
-                  </a:txBody>
-                  <a:tcPr marL="45720" marR="45720" marT="18288" marB="18288" anchor="ctr">
-                    <a:lnL w="12700" cap="flat" cmpd="sng" algn="ctr">
-                      <a:solidFill>
-                        <a:srgbClr val="0F141A"/>
-                      </a:solidFill>
-                      <a:prstDash val="solid"/>
-                      <a:round/>
-                      <a:headEnd type="none" w="med" len="med"/>
-                      <a:tailEnd type="none" w="med" len="med"/>
-                    </a:lnL>
-                    <a:lnR w="12700" cap="flat" cmpd="sng" algn="ctr">
-                      <a:solidFill>
-                        <a:srgbClr val="0F141A"/>
-                      </a:solidFill>
-                      <a:prstDash val="solid"/>
-                      <a:round/>
-                      <a:headEnd type="none" w="med" len="med"/>
-                      <a:tailEnd type="none" w="med" len="med"/>
-                    </a:lnR>
-                    <a:lnT w="12700" cap="flat" cmpd="sng" algn="ctr">
-                      <a:solidFill>
-                        <a:srgbClr val="0F141A"/>
-                      </a:solidFill>
-                      <a:prstDash val="solid"/>
-                      <a:round/>
-                      <a:headEnd type="none" w="med" len="med"/>
-                      <a:tailEnd type="none" w="med" len="med"/>
-                    </a:lnT>
-                    <a:lnB w="12700" cap="flat" cmpd="sng" algn="ctr">
-                      <a:solidFill>
-                        <a:srgbClr val="0F141A"/>
-                      </a:solidFill>
-                      <a:prstDash val="solid"/>
-                      <a:round/>
-                      <a:headEnd type="none" w="med" len="med"/>
-                      <a:tailEnd type="none" w="med" len="med"/>
-                    </a:lnB>
-                    <a:solidFill>
-                      <a:srgbClr val="161D25"/>
-                    </a:solidFill>
-                  </a:tcPr>
-                </a:tc>
-                <a:tc>
-                  <a:txBody>
-                    <a:bodyPr/>
-                    <a:lstStyle/>
-                    <a:p>
-                      <a:pPr algn="ctr" indent="0" marL="0">
-                        <a:buNone/>
-                      </a:pPr>
-                      <a:r>
-                        <a:rPr lang="en-US" sz="1100" dirty="0">
-                          <a:solidFill>
-                            <a:srgbClr val="EEF1F4"/>
-                          </a:solidFill>
-                          <a:latin typeface="Arial" pitchFamily="34" charset="0"/>
-                          <a:ea typeface="Arial" pitchFamily="34" charset="-122"/>
-                          <a:cs typeface="Arial" pitchFamily="34" charset="-120"/>
-                        </a:rPr>
-                        <a:t>18 · 69%</a:t>
+                        <a:t>18 · 78%</a:t>
                       </a:r>
                       <a:endParaRPr lang="en-US" sz="1100" dirty="0">
                         <a:latin typeface="Arial" charset="0"/>
@@ -4380,17 +3799,6 @@
                       <a:pPr algn="ctr" indent="0" marL="0">
                         <a:buNone/>
                       </a:pPr>
-                      <a:r>
-                        <a:rPr lang="en-US" sz="1100" b="1" dirty="0">
-                          <a:solidFill>
-                            <a:srgbClr val="EEF1F4"/>
-                          </a:solidFill>
-                          <a:latin typeface="Arial" pitchFamily="34" charset="0"/>
-                          <a:ea typeface="Arial" pitchFamily="34" charset="-122"/>
-                          <a:cs typeface="Arial" pitchFamily="34" charset="-120"/>
-                        </a:rPr>
-                        <a:t>746 A4</a:t>
-                      </a:r>
                       <a:endParaRPr lang="en-US" sz="1100" dirty="0">
                         <a:latin typeface="Arial" charset="0"/>
                         <a:ea typeface="Arial" charset="0"/>
@@ -4448,17 +3856,6 @@
                       <a:pPr algn="ctr" indent="0" marL="0">
                         <a:buNone/>
                       </a:pPr>
-                      <a:r>
-                        <a:rPr lang="en-US" sz="1100" dirty="0">
-                          <a:solidFill>
-                            <a:srgbClr val="EEF1F4"/>
-                          </a:solidFill>
-                          <a:latin typeface="Arial" pitchFamily="34" charset="0"/>
-                          <a:ea typeface="Arial" pitchFamily="34" charset="-122"/>
-                          <a:cs typeface="Arial" pitchFamily="34" charset="-120"/>
-                        </a:rPr>
-                        <a:t>43.4</a:t>
-                      </a:r>
                       <a:endParaRPr lang="en-US" sz="1100" dirty="0">
                         <a:latin typeface="Arial" charset="0"/>
                         <a:ea typeface="Arial" charset="0"/>
@@ -4581,20 +3978,43 @@
           </a:graphicData>
         </a:graphic>
       </p:graphicFrame>
+      <p:pic>
+        <p:nvPicPr>
+          <p:cNvPr id="9" name="Image 0" descr="assets/photo_v825.jpg">    </p:cNvPr>
+          <p:cNvPicPr>
+            <a:picLocks noChangeAspect="1"/>
+          </p:cNvPicPr>
+          <p:nvPr/>
+        </p:nvPicPr>
+        <p:blipFill>
+          <a:blip r:embed="rId1"/>
+          <a:srcRect l="0" r="0" t="0" b="0"/>
+          <a:stretch/>
+        </p:blipFill>
+        <p:spPr>
+          <a:xfrm>
+            <a:off x="2432304" y="2002536"/>
+            <a:ext cx="1261872" cy="850392"/>
+          </a:xfrm>
+          <a:prstGeom prst="rect">
+            <a:avLst/>
+          </a:prstGeom>
+        </p:spPr>
+      </p:pic>
       <p:sp>
         <p:nvSpPr>
-          <p:cNvPr id="9" name="Shape 6"/>
+          <p:cNvPr id="10" name="Shape 6"/>
           <p:cNvSpPr/>
           <p:nvPr/>
         </p:nvSpPr>
         <p:spPr>
           <a:xfrm>
-            <a:off x="2514600" y="2194560"/>
-            <a:ext cx="1143000" cy="329184"/>
+            <a:off x="3886200" y="2043684"/>
+            <a:ext cx="1325880" cy="274320"/>
           </a:xfrm>
           <a:prstGeom prst="roundRect">
             <a:avLst>
-              <a:gd name="adj" fmla="val 11111"/>
+              <a:gd name="adj" fmla="val 13333"/>
             </a:avLst>
           </a:prstGeom>
           <a:solidFill>
@@ -4610,22 +4030,22 @@
       </p:sp>
       <p:pic>
         <p:nvPicPr>
-          <p:cNvPr id="10" name="Image 0" descr="assets/logo_amcoveba.png">    </p:cNvPr>
+          <p:cNvPr id="11" name="Image 1" descr="assets/logo_amcoveba.png">    </p:cNvPr>
           <p:cNvPicPr>
             <a:picLocks noChangeAspect="1"/>
           </p:cNvPicPr>
           <p:nvPr/>
         </p:nvPicPr>
         <p:blipFill>
-          <a:blip r:embed="rId1"/>
+          <a:blip r:embed="rId2"/>
           <a:stretch>
             <a:fillRect/>
           </a:stretch>
         </p:blipFill>
         <p:spPr>
           <a:xfrm>
-            <a:off x="2560320" y="2241502"/>
-            <a:ext cx="1051560" cy="235301"/>
+            <a:off x="4099630" y="2080260"/>
+            <a:ext cx="899020" cy="201168"/>
           </a:xfrm>
           <a:prstGeom prst="rect">
             <a:avLst/>
@@ -4634,18 +4054,176 @@
       </p:pic>
       <p:sp>
         <p:nvSpPr>
-          <p:cNvPr id="11" name="Shape 7"/>
+          <p:cNvPr id="12" name="Text 7"/>
+          <p:cNvSpPr txBox="1"/>
+          <p:nvPr/>
+        </p:nvSpPr>
+        <p:spPr>
+          <a:xfrm>
+            <a:off x="3749040" y="2372868"/>
+            <a:ext cx="1600200" cy="411480"/>
+          </a:xfrm>
+          <a:prstGeom prst="rect">
+            <a:avLst/>
+          </a:prstGeom>
+          <a:noFill/>
+          <a:ln/>
+        </p:spPr>
+        <p:txBody>
+          <a:bodyPr wrap="square" lIns="0" tIns="0" rIns="0" bIns="0" rtlCol="0" anchor="t"/>
+          <a:lstStyle/>
+          <a:p>
+            <a:pPr algn="ctr" indent="0" marL="0">
+              <a:buNone/>
+            </a:pPr>
+            <a:r>
+              <a:rPr lang="en-US" sz="1100" b="1" dirty="0">
+                <a:solidFill>
+                  <a:srgbClr val="EEF1F4"/>
+                </a:solidFill>
+                <a:latin typeface="Arial" pitchFamily="34" charset="0"/>
+                <a:ea typeface="Arial" pitchFamily="34" charset="-122"/>
+                <a:cs typeface="Arial" pitchFamily="34" charset="-120"/>
+              </a:rPr>
+              <a:t>V825</a:t>
+            </a:r>
+            <a:endParaRPr lang="en-US" sz="1100" dirty="0"/>
+          </a:p>
+          <a:p>
+            <a:pPr algn="ctr" indent="0" marL="0">
+              <a:buNone/>
+            </a:pPr>
+            <a:r>
+              <a:rPr lang="en-US" sz="900" dirty="0">
+                <a:solidFill>
+                  <a:srgbClr val="9AA6B2"/>
+                </a:solidFill>
+                <a:latin typeface="Arial" pitchFamily="34" charset="0"/>
+                <a:ea typeface="Arial" pitchFamily="34" charset="-122"/>
+                <a:cs typeface="Arial" pitchFamily="34" charset="-120"/>
+              </a:rPr>
+              <a:t>25.6 tm</a:t>
+            </a:r>
+            <a:endParaRPr lang="en-US" sz="1100" dirty="0"/>
+          </a:p>
+        </p:txBody>
+      </p:sp>
+      <p:pic>
+        <p:nvPicPr>
+          <p:cNvPr id="13" name="Image 2" descr="assets/photo_268.jpg">    </p:cNvPr>
+          <p:cNvPicPr>
+            <a:picLocks noChangeAspect="1"/>
+          </p:cNvPicPr>
+          <p:nvPr/>
+        </p:nvPicPr>
+        <p:blipFill>
+          <a:blip r:embed="rId3"/>
+          <a:srcRect l="0" r="0" t="0" b="0"/>
+          <a:stretch/>
+        </p:blipFill>
+        <p:spPr>
+          <a:xfrm>
+            <a:off x="7598664" y="2002536"/>
+            <a:ext cx="1261872" cy="850392"/>
+          </a:xfrm>
+          <a:prstGeom prst="rect">
+            <a:avLst/>
+          </a:prstGeom>
+        </p:spPr>
+      </p:pic>
+      <p:sp>
+        <p:nvSpPr>
+          <p:cNvPr id="14" name="Text 8"/>
+          <p:cNvSpPr txBox="1"/>
+          <p:nvPr/>
+        </p:nvSpPr>
+        <p:spPr>
+          <a:xfrm>
+            <a:off x="8915400" y="1947672"/>
+            <a:ext cx="1325880" cy="960120"/>
+          </a:xfrm>
+          <a:prstGeom prst="rect">
+            <a:avLst/>
+          </a:prstGeom>
+          <a:noFill/>
+          <a:ln/>
+        </p:spPr>
+        <p:txBody>
+          <a:bodyPr wrap="square" lIns="0" tIns="0" rIns="0" bIns="0" rtlCol="0" anchor="ctr"/>
+          <a:lstStyle/>
+          <a:p>
+            <a:pPr algn="ctr" indent="0" marL="0">
+              <a:buNone/>
+            </a:pPr>
+            <a:r>
+              <a:rPr lang="en-US" sz="1100" b="1" dirty="0">
+                <a:solidFill>
+                  <a:srgbClr val="EEF1F4"/>
+                </a:solidFill>
+                <a:latin typeface="Arial" pitchFamily="34" charset="0"/>
+                <a:ea typeface="Arial" pitchFamily="34" charset="-122"/>
+                <a:cs typeface="Arial" pitchFamily="34" charset="-120"/>
+              </a:rPr>
+              <a:t>268 A4</a:t>
+            </a:r>
+            <a:endParaRPr lang="en-US" sz="1100" dirty="0"/>
+          </a:p>
+          <a:p>
+            <a:pPr algn="ctr" indent="0" marL="0">
+              <a:buNone/>
+            </a:pPr>
+            <a:r>
+              <a:rPr lang="en-US" sz="900" dirty="0">
+                <a:solidFill>
+                  <a:srgbClr val="9AA6B2"/>
+                </a:solidFill>
+                <a:latin typeface="Arial" pitchFamily="34" charset="0"/>
+                <a:ea typeface="Arial" pitchFamily="34" charset="-122"/>
+                <a:cs typeface="Arial" pitchFamily="34" charset="-120"/>
+              </a:rPr>
+              <a:t>25.4 tm</a:t>
+            </a:r>
+            <a:endParaRPr lang="en-US" sz="1100" dirty="0"/>
+          </a:p>
+        </p:txBody>
+      </p:sp>
+      <p:pic>
+        <p:nvPicPr>
+          <p:cNvPr id="15" name="Image 3" descr="assets/photo_spk32080.jpg">    </p:cNvPr>
+          <p:cNvPicPr>
+            <a:picLocks noChangeAspect="1"/>
+          </p:cNvPicPr>
+          <p:nvPr/>
+        </p:nvPicPr>
+        <p:blipFill>
+          <a:blip r:embed="rId4"/>
+          <a:srcRect l="0" r="0" t="0" b="0"/>
+          <a:stretch/>
+        </p:blipFill>
+        <p:spPr>
+          <a:xfrm>
+            <a:off x="2432304" y="2962656"/>
+            <a:ext cx="1261872" cy="850392"/>
+          </a:xfrm>
+          <a:prstGeom prst="rect">
+            <a:avLst/>
+          </a:prstGeom>
+        </p:spPr>
+      </p:pic>
+      <p:sp>
+        <p:nvSpPr>
+          <p:cNvPr id="16" name="Shape 9"/>
           <p:cNvSpPr/>
           <p:nvPr/>
         </p:nvSpPr>
         <p:spPr>
           <a:xfrm>
-            <a:off x="2514600" y="2926080"/>
-            <a:ext cx="1143000" cy="329184"/>
+            <a:off x="3886200" y="3003804"/>
+            <a:ext cx="1325880" cy="274320"/>
           </a:xfrm>
           <a:prstGeom prst="roundRect">
             <a:avLst>
-              <a:gd name="adj" fmla="val 11111"/>
+              <a:gd name="adj" fmla="val 13333"/>
             </a:avLst>
           </a:prstGeom>
           <a:solidFill>
@@ -4661,22 +4239,22 @@
       </p:sp>
       <p:pic>
         <p:nvPicPr>
-          <p:cNvPr id="12" name="Image 1" descr="assets/logo_sanypalfinger.png">    </p:cNvPr>
+          <p:cNvPr id="17" name="Image 4" descr="assets/logo_sanypalfinger.png">    </p:cNvPr>
           <p:cNvPicPr>
             <a:picLocks noChangeAspect="1"/>
           </p:cNvPicPr>
           <p:nvPr/>
         </p:nvPicPr>
         <p:blipFill>
-          <a:blip r:embed="rId2"/>
+          <a:blip r:embed="rId5"/>
           <a:stretch>
             <a:fillRect/>
           </a:stretch>
         </p:blipFill>
         <p:spPr>
           <a:xfrm>
-            <a:off x="2560320" y="2978661"/>
-            <a:ext cx="1051560" cy="224022"/>
+            <a:off x="4076999" y="3040380"/>
+            <a:ext cx="944283" cy="201168"/>
           </a:xfrm>
           <a:prstGeom prst="rect">
             <a:avLst/>
@@ -4685,18 +4263,176 @@
       </p:pic>
       <p:sp>
         <p:nvSpPr>
-          <p:cNvPr id="13" name="Shape 8"/>
+          <p:cNvPr id="18" name="Text 10"/>
+          <p:cNvSpPr txBox="1"/>
+          <p:nvPr/>
+        </p:nvSpPr>
+        <p:spPr>
+          <a:xfrm>
+            <a:off x="3749040" y="3332988"/>
+            <a:ext cx="1600200" cy="411480"/>
+          </a:xfrm>
+          <a:prstGeom prst="rect">
+            <a:avLst/>
+          </a:prstGeom>
+          <a:noFill/>
+          <a:ln/>
+        </p:spPr>
+        <p:txBody>
+          <a:bodyPr wrap="square" lIns="0" tIns="0" rIns="0" bIns="0" rtlCol="0" anchor="t"/>
+          <a:lstStyle/>
+          <a:p>
+            <a:pPr algn="ctr" indent="0" marL="0">
+              <a:buNone/>
+            </a:pPr>
+            <a:r>
+              <a:rPr lang="en-US" sz="1100" b="1" dirty="0">
+                <a:solidFill>
+                  <a:srgbClr val="EEF1F4"/>
+                </a:solidFill>
+                <a:latin typeface="Arial" pitchFamily="34" charset="0"/>
+                <a:ea typeface="Arial" pitchFamily="34" charset="-122"/>
+                <a:cs typeface="Arial" pitchFamily="34" charset="-120"/>
+              </a:rPr>
+              <a:t>SPK32080</a:t>
+            </a:r>
+            <a:endParaRPr lang="en-US" sz="1100" dirty="0"/>
+          </a:p>
+          <a:p>
+            <a:pPr algn="ctr" indent="0" marL="0">
+              <a:buNone/>
+            </a:pPr>
+            <a:r>
+              <a:rPr lang="en-US" sz="900" dirty="0">
+                <a:solidFill>
+                  <a:srgbClr val="9AA6B2"/>
+                </a:solidFill>
+                <a:latin typeface="Arial" pitchFamily="34" charset="0"/>
+                <a:ea typeface="Arial" pitchFamily="34" charset="-122"/>
+                <a:cs typeface="Arial" pitchFamily="34" charset="-120"/>
+              </a:rPr>
+              <a:t>30.4 tm</a:t>
+            </a:r>
+            <a:endParaRPr lang="en-US" sz="1100" dirty="0"/>
+          </a:p>
+        </p:txBody>
+      </p:sp>
+      <p:pic>
+        <p:nvPicPr>
+          <p:cNvPr id="19" name="Image 5" descr="assets/photo_fbr350r.jpg">    </p:cNvPr>
+          <p:cNvPicPr>
+            <a:picLocks noChangeAspect="1"/>
+          </p:cNvPicPr>
+          <p:nvPr/>
+        </p:nvPicPr>
+        <p:blipFill>
+          <a:blip r:embed="rId6"/>
+          <a:srcRect l="0" r="0" t="0" b="0"/>
+          <a:stretch/>
+        </p:blipFill>
+        <p:spPr>
+          <a:xfrm>
+            <a:off x="7598664" y="2962656"/>
+            <a:ext cx="1261872" cy="850392"/>
+          </a:xfrm>
+          <a:prstGeom prst="rect">
+            <a:avLst/>
+          </a:prstGeom>
+        </p:spPr>
+      </p:pic>
+      <p:sp>
+        <p:nvSpPr>
+          <p:cNvPr id="20" name="Text 11"/>
+          <p:cNvSpPr txBox="1"/>
+          <p:nvPr/>
+        </p:nvSpPr>
+        <p:spPr>
+          <a:xfrm>
+            <a:off x="8915400" y="2907792"/>
+            <a:ext cx="1325880" cy="960120"/>
+          </a:xfrm>
+          <a:prstGeom prst="rect">
+            <a:avLst/>
+          </a:prstGeom>
+          <a:noFill/>
+          <a:ln/>
+        </p:spPr>
+        <p:txBody>
+          <a:bodyPr wrap="square" lIns="0" tIns="0" rIns="0" bIns="0" rtlCol="0" anchor="ctr"/>
+          <a:lstStyle/>
+          <a:p>
+            <a:pPr algn="ctr" indent="0" marL="0">
+              <a:buNone/>
+            </a:pPr>
+            <a:r>
+              <a:rPr lang="en-US" sz="1100" b="1" dirty="0">
+                <a:solidFill>
+                  <a:srgbClr val="EEF1F4"/>
+                </a:solidFill>
+                <a:latin typeface="Arial" pitchFamily="34" charset="0"/>
+                <a:ea typeface="Arial" pitchFamily="34" charset="-122"/>
+                <a:cs typeface="Arial" pitchFamily="34" charset="-120"/>
+              </a:rPr>
+              <a:t>FBR350R A4</a:t>
+            </a:r>
+            <a:endParaRPr lang="en-US" sz="1100" dirty="0"/>
+          </a:p>
+          <a:p>
+            <a:pPr algn="ctr" indent="0" marL="0">
+              <a:buNone/>
+            </a:pPr>
+            <a:r>
+              <a:rPr lang="en-US" sz="900" dirty="0">
+                <a:solidFill>
+                  <a:srgbClr val="9AA6B2"/>
+                </a:solidFill>
+                <a:latin typeface="Arial" pitchFamily="34" charset="0"/>
+                <a:ea typeface="Arial" pitchFamily="34" charset="-122"/>
+                <a:cs typeface="Arial" pitchFamily="34" charset="-120"/>
+              </a:rPr>
+              <a:t>32.8 tm</a:t>
+            </a:r>
+            <a:endParaRPr lang="en-US" sz="1100" dirty="0"/>
+          </a:p>
+        </p:txBody>
+      </p:sp>
+      <p:pic>
+        <p:nvPicPr>
+          <p:cNvPr id="21" name="Image 6" descr="assets/photo_spk36080.jpg">    </p:cNvPr>
+          <p:cNvPicPr>
+            <a:picLocks noChangeAspect="1"/>
+          </p:cNvPicPr>
+          <p:nvPr/>
+        </p:nvPicPr>
+        <p:blipFill>
+          <a:blip r:embed="rId7"/>
+          <a:srcRect l="0" r="0" t="0" b="0"/>
+          <a:stretch/>
+        </p:blipFill>
+        <p:spPr>
+          <a:xfrm>
+            <a:off x="2432304" y="3922776"/>
+            <a:ext cx="1261872" cy="850392"/>
+          </a:xfrm>
+          <a:prstGeom prst="rect">
+            <a:avLst/>
+          </a:prstGeom>
+        </p:spPr>
+      </p:pic>
+      <p:sp>
+        <p:nvSpPr>
+          <p:cNvPr id="22" name="Shape 12"/>
           <p:cNvSpPr/>
           <p:nvPr/>
         </p:nvSpPr>
         <p:spPr>
           <a:xfrm>
-            <a:off x="2514600" y="3657600"/>
-            <a:ext cx="1143000" cy="329184"/>
+            <a:off x="3886200" y="3963924"/>
+            <a:ext cx="1325880" cy="274320"/>
           </a:xfrm>
           <a:prstGeom prst="roundRect">
             <a:avLst>
-              <a:gd name="adj" fmla="val 11111"/>
+              <a:gd name="adj" fmla="val 13333"/>
             </a:avLst>
           </a:prstGeom>
           <a:solidFill>
@@ -4712,22 +4448,22 @@
       </p:sp>
       <p:pic>
         <p:nvPicPr>
-          <p:cNvPr id="14" name="Image 2" descr="assets/logo_sanypalfinger.png">    </p:cNvPr>
+          <p:cNvPr id="23" name="Image 7" descr="assets/logo_sanypalfinger.png">    </p:cNvPr>
           <p:cNvPicPr>
             <a:picLocks noChangeAspect="1"/>
           </p:cNvPicPr>
           <p:nvPr/>
         </p:nvPicPr>
         <p:blipFill>
-          <a:blip r:embed="rId3"/>
+          <a:blip r:embed="rId8"/>
           <a:stretch>
             <a:fillRect/>
           </a:stretch>
         </p:blipFill>
         <p:spPr>
           <a:xfrm>
-            <a:off x="2560320" y="3710181"/>
-            <a:ext cx="1051560" cy="224022"/>
+            <a:off x="4076999" y="4000500"/>
+            <a:ext cx="944283" cy="201168"/>
           </a:xfrm>
           <a:prstGeom prst="rect">
             <a:avLst/>
@@ -4736,18 +4472,176 @@
       </p:pic>
       <p:sp>
         <p:nvSpPr>
-          <p:cNvPr id="15" name="Shape 9"/>
+          <p:cNvPr id="24" name="Text 13"/>
+          <p:cNvSpPr txBox="1"/>
+          <p:nvPr/>
+        </p:nvSpPr>
+        <p:spPr>
+          <a:xfrm>
+            <a:off x="3749040" y="4293108"/>
+            <a:ext cx="1600200" cy="411480"/>
+          </a:xfrm>
+          <a:prstGeom prst="rect">
+            <a:avLst/>
+          </a:prstGeom>
+          <a:noFill/>
+          <a:ln/>
+        </p:spPr>
+        <p:txBody>
+          <a:bodyPr wrap="square" lIns="0" tIns="0" rIns="0" bIns="0" rtlCol="0" anchor="t"/>
+          <a:lstStyle/>
+          <a:p>
+            <a:pPr algn="ctr" indent="0" marL="0">
+              <a:buNone/>
+            </a:pPr>
+            <a:r>
+              <a:rPr lang="en-US" sz="1100" b="1" dirty="0">
+                <a:solidFill>
+                  <a:srgbClr val="EEF1F4"/>
+                </a:solidFill>
+                <a:latin typeface="Arial" pitchFamily="34" charset="0"/>
+                <a:ea typeface="Arial" pitchFamily="34" charset="-122"/>
+                <a:cs typeface="Arial" pitchFamily="34" charset="-120"/>
+              </a:rPr>
+              <a:t>SPK36080</a:t>
+            </a:r>
+            <a:endParaRPr lang="en-US" sz="1100" dirty="0"/>
+          </a:p>
+          <a:p>
+            <a:pPr algn="ctr" indent="0" marL="0">
+              <a:buNone/>
+            </a:pPr>
+            <a:r>
+              <a:rPr lang="en-US" sz="900" dirty="0">
+                <a:solidFill>
+                  <a:srgbClr val="9AA6B2"/>
+                </a:solidFill>
+                <a:latin typeface="Arial" pitchFamily="34" charset="0"/>
+                <a:ea typeface="Arial" pitchFamily="34" charset="-122"/>
+                <a:cs typeface="Arial" pitchFamily="34" charset="-120"/>
+              </a:rPr>
+              <a:t>36 tm</a:t>
+            </a:r>
+            <a:endParaRPr lang="en-US" sz="1100" dirty="0"/>
+          </a:p>
+        </p:txBody>
+      </p:sp>
+      <p:pic>
+        <p:nvPicPr>
+          <p:cNvPr id="25" name="Image 8" descr="assets/photo_7441c.jpg">    </p:cNvPr>
+          <p:cNvPicPr>
+            <a:picLocks noChangeAspect="1"/>
+          </p:cNvPicPr>
+          <p:nvPr/>
+        </p:nvPicPr>
+        <p:blipFill>
+          <a:blip r:embed="rId9"/>
+          <a:srcRect l="0" r="0" t="0" b="0"/>
+          <a:stretch/>
+        </p:blipFill>
+        <p:spPr>
+          <a:xfrm>
+            <a:off x="7598664" y="3922776"/>
+            <a:ext cx="1261872" cy="850392"/>
+          </a:xfrm>
+          <a:prstGeom prst="rect">
+            <a:avLst/>
+          </a:prstGeom>
+        </p:spPr>
+      </p:pic>
+      <p:sp>
+        <p:nvSpPr>
+          <p:cNvPr id="26" name="Text 14"/>
+          <p:cNvSpPr txBox="1"/>
+          <p:nvPr/>
+        </p:nvSpPr>
+        <p:spPr>
+          <a:xfrm>
+            <a:off x="8915400" y="3867912"/>
+            <a:ext cx="1325880" cy="960120"/>
+          </a:xfrm>
+          <a:prstGeom prst="rect">
+            <a:avLst/>
+          </a:prstGeom>
+          <a:noFill/>
+          <a:ln/>
+        </p:spPr>
+        <p:txBody>
+          <a:bodyPr wrap="square" lIns="0" tIns="0" rIns="0" bIns="0" rtlCol="0" anchor="ctr"/>
+          <a:lstStyle/>
+          <a:p>
+            <a:pPr algn="ctr" indent="0" marL="0">
+              <a:buNone/>
+            </a:pPr>
+            <a:r>
+              <a:rPr lang="en-US" sz="1100" b="1" dirty="0">
+                <a:solidFill>
+                  <a:srgbClr val="EEF1F4"/>
+                </a:solidFill>
+                <a:latin typeface="Arial" pitchFamily="34" charset="0"/>
+                <a:ea typeface="Arial" pitchFamily="34" charset="-122"/>
+                <a:cs typeface="Arial" pitchFamily="34" charset="-120"/>
+              </a:rPr>
+              <a:t>7441C</a:t>
+            </a:r>
+            <a:endParaRPr lang="en-US" sz="1100" dirty="0"/>
+          </a:p>
+          <a:p>
+            <a:pPr algn="ctr" indent="0" marL="0">
+              <a:buNone/>
+            </a:pPr>
+            <a:r>
+              <a:rPr lang="en-US" sz="900" dirty="0">
+                <a:solidFill>
+                  <a:srgbClr val="9AA6B2"/>
+                </a:solidFill>
+                <a:latin typeface="Arial" pitchFamily="34" charset="0"/>
+                <a:ea typeface="Arial" pitchFamily="34" charset="-122"/>
+                <a:cs typeface="Arial" pitchFamily="34" charset="-120"/>
+              </a:rPr>
+              <a:t>37.7 tm</a:t>
+            </a:r>
+            <a:endParaRPr lang="en-US" sz="1100" dirty="0"/>
+          </a:p>
+        </p:txBody>
+      </p:sp>
+      <p:pic>
+        <p:nvPicPr>
+          <p:cNvPr id="27" name="Image 9" descr="assets/photo_spk42502.jpg">    </p:cNvPr>
+          <p:cNvPicPr>
+            <a:picLocks noChangeAspect="1"/>
+          </p:cNvPicPr>
+          <p:nvPr/>
+        </p:nvPicPr>
+        <p:blipFill>
+          <a:blip r:embed="rId10"/>
+          <a:srcRect l="0" r="0" t="0" b="0"/>
+          <a:stretch/>
+        </p:blipFill>
+        <p:spPr>
+          <a:xfrm>
+            <a:off x="2432304" y="4882896"/>
+            <a:ext cx="1261872" cy="850392"/>
+          </a:xfrm>
+          <a:prstGeom prst="rect">
+            <a:avLst/>
+          </a:prstGeom>
+        </p:spPr>
+      </p:pic>
+      <p:sp>
+        <p:nvSpPr>
+          <p:cNvPr id="28" name="Shape 15"/>
           <p:cNvSpPr/>
           <p:nvPr/>
         </p:nvSpPr>
         <p:spPr>
           <a:xfrm>
-            <a:off x="2514600" y="4389120"/>
-            <a:ext cx="1143000" cy="329184"/>
+            <a:off x="3886200" y="4924044"/>
+            <a:ext cx="1325880" cy="274320"/>
           </a:xfrm>
           <a:prstGeom prst="roundRect">
             <a:avLst>
-              <a:gd name="adj" fmla="val 11111"/>
+              <a:gd name="adj" fmla="val 13333"/>
             </a:avLst>
           </a:prstGeom>
           <a:solidFill>
@@ -4763,22 +4657,22 @@
       </p:sp>
       <p:pic>
         <p:nvPicPr>
-          <p:cNvPr id="16" name="Image 3" descr="assets/logo_sanypalfinger.png">    </p:cNvPr>
+          <p:cNvPr id="29" name="Image 10" descr="assets/logo_sanypalfinger.png">    </p:cNvPr>
           <p:cNvPicPr>
             <a:picLocks noChangeAspect="1"/>
           </p:cNvPicPr>
           <p:nvPr/>
         </p:nvPicPr>
         <p:blipFill>
-          <a:blip r:embed="rId4"/>
+          <a:blip r:embed="rId11"/>
           <a:stretch>
             <a:fillRect/>
           </a:stretch>
         </p:blipFill>
         <p:spPr>
           <a:xfrm>
-            <a:off x="2560320" y="4441701"/>
-            <a:ext cx="1051560" cy="224022"/>
+            <a:off x="4076999" y="4960620"/>
+            <a:ext cx="944283" cy="201168"/>
           </a:xfrm>
           <a:prstGeom prst="rect">
             <a:avLst/>
@@ -4787,14 +4681,149 @@
       </p:pic>
       <p:sp>
         <p:nvSpPr>
-          <p:cNvPr id="17" name="Shape 10"/>
+          <p:cNvPr id="30" name="Text 16"/>
+          <p:cNvSpPr txBox="1"/>
+          <p:nvPr/>
+        </p:nvSpPr>
+        <p:spPr>
+          <a:xfrm>
+            <a:off x="3749040" y="5253228"/>
+            <a:ext cx="1600200" cy="411480"/>
+          </a:xfrm>
+          <a:prstGeom prst="rect">
+            <a:avLst/>
+          </a:prstGeom>
+          <a:noFill/>
+          <a:ln/>
+        </p:spPr>
+        <p:txBody>
+          <a:bodyPr wrap="square" lIns="0" tIns="0" rIns="0" bIns="0" rtlCol="0" anchor="t"/>
+          <a:lstStyle/>
+          <a:p>
+            <a:pPr algn="ctr" indent="0" marL="0">
+              <a:buNone/>
+            </a:pPr>
+            <a:r>
+              <a:rPr lang="en-US" sz="1100" b="1" dirty="0">
+                <a:solidFill>
+                  <a:srgbClr val="EEF1F4"/>
+                </a:solidFill>
+                <a:latin typeface="Arial" pitchFamily="34" charset="0"/>
+                <a:ea typeface="Arial" pitchFamily="34" charset="-122"/>
+                <a:cs typeface="Arial" pitchFamily="34" charset="-120"/>
+              </a:rPr>
+              <a:t>SPK42502</a:t>
+            </a:r>
+            <a:endParaRPr lang="en-US" sz="1100" dirty="0"/>
+          </a:p>
+          <a:p>
+            <a:pPr algn="ctr" indent="0" marL="0">
+              <a:buNone/>
+            </a:pPr>
+            <a:r>
+              <a:rPr lang="en-US" sz="900" dirty="0">
+                <a:solidFill>
+                  <a:srgbClr val="9AA6B2"/>
+                </a:solidFill>
+                <a:latin typeface="Arial" pitchFamily="34" charset="0"/>
+                <a:ea typeface="Arial" pitchFamily="34" charset="-122"/>
+                <a:cs typeface="Arial" pitchFamily="34" charset="-120"/>
+              </a:rPr>
+              <a:t>42.5 tm</a:t>
+            </a:r>
+            <a:endParaRPr lang="en-US" sz="1100" dirty="0"/>
+          </a:p>
+        </p:txBody>
+      </p:sp>
+      <p:pic>
+        <p:nvPicPr>
+          <p:cNvPr id="31" name="Image 11" descr="assets/photo_746r.jpg">    </p:cNvPr>
+          <p:cNvPicPr>
+            <a:picLocks noChangeAspect="1"/>
+          </p:cNvPicPr>
+          <p:nvPr/>
+        </p:nvPicPr>
+        <p:blipFill>
+          <a:blip r:embed="rId12"/>
+          <a:srcRect l="0" r="0" t="0" b="0"/>
+          <a:stretch/>
+        </p:blipFill>
+        <p:spPr>
+          <a:xfrm>
+            <a:off x="7598664" y="4882896"/>
+            <a:ext cx="1261872" cy="850392"/>
+          </a:xfrm>
+          <a:prstGeom prst="rect">
+            <a:avLst/>
+          </a:prstGeom>
+        </p:spPr>
+      </p:pic>
+      <p:sp>
+        <p:nvSpPr>
+          <p:cNvPr id="32" name="Text 17"/>
+          <p:cNvSpPr txBox="1"/>
+          <p:nvPr/>
+        </p:nvSpPr>
+        <p:spPr>
+          <a:xfrm>
+            <a:off x="8915400" y="4828032"/>
+            <a:ext cx="1325880" cy="960120"/>
+          </a:xfrm>
+          <a:prstGeom prst="rect">
+            <a:avLst/>
+          </a:prstGeom>
+          <a:noFill/>
+          <a:ln/>
+        </p:spPr>
+        <p:txBody>
+          <a:bodyPr wrap="square" lIns="0" tIns="0" rIns="0" bIns="0" rtlCol="0" anchor="ctr"/>
+          <a:lstStyle/>
+          <a:p>
+            <a:pPr algn="ctr" indent="0" marL="0">
+              <a:buNone/>
+            </a:pPr>
+            <a:r>
+              <a:rPr lang="en-US" sz="1100" b="1" dirty="0">
+                <a:solidFill>
+                  <a:srgbClr val="EEF1F4"/>
+                </a:solidFill>
+                <a:latin typeface="Arial" pitchFamily="34" charset="0"/>
+                <a:ea typeface="Arial" pitchFamily="34" charset="-122"/>
+                <a:cs typeface="Arial" pitchFamily="34" charset="-120"/>
+              </a:rPr>
+              <a:t>746 A4</a:t>
+            </a:r>
+            <a:endParaRPr lang="en-US" sz="1100" dirty="0"/>
+          </a:p>
+          <a:p>
+            <a:pPr algn="ctr" indent="0" marL="0">
+              <a:buNone/>
+            </a:pPr>
+            <a:r>
+              <a:rPr lang="en-US" sz="900" dirty="0">
+                <a:solidFill>
+                  <a:srgbClr val="9AA6B2"/>
+                </a:solidFill>
+                <a:latin typeface="Arial" pitchFamily="34" charset="0"/>
+                <a:ea typeface="Arial" pitchFamily="34" charset="-122"/>
+                <a:cs typeface="Arial" pitchFamily="34" charset="-120"/>
+              </a:rPr>
+              <a:t>43.4 tm</a:t>
+            </a:r>
+            <a:endParaRPr lang="en-US" sz="1100" dirty="0"/>
+          </a:p>
+        </p:txBody>
+      </p:sp>
+      <p:sp>
+        <p:nvSpPr>
+          <p:cNvPr id="33" name="Shape 18"/>
           <p:cNvSpPr/>
           <p:nvPr/>
         </p:nvSpPr>
         <p:spPr>
           <a:xfrm>
-            <a:off x="411480" y="2011680"/>
-            <a:ext cx="411480" cy="2889504"/>
+            <a:off x="411480" y="1965960"/>
+            <a:ext cx="411480" cy="3803904"/>
           </a:xfrm>
           <a:prstGeom prst="rect">
             <a:avLst/>
@@ -4812,14 +4841,14 @@
       </p:sp>
       <p:sp>
         <p:nvSpPr>
-          <p:cNvPr id="18" name="Text 11"/>
+          <p:cNvPr id="34" name="Text 19"/>
           <p:cNvSpPr txBox="1"/>
           <p:nvPr/>
         </p:nvSpPr>
         <p:spPr>
           <a:xfrm rot="16200000">
-            <a:off x="-845820" y="3250692"/>
-            <a:ext cx="2926080" cy="411480"/>
+            <a:off x="-1303020" y="3662172"/>
+            <a:ext cx="3840480" cy="411480"/>
           </a:xfrm>
           <a:prstGeom prst="rect">
             <a:avLst/>
@@ -4851,13 +4880,13 @@
       </p:sp>
       <p:sp>
         <p:nvSpPr>
-          <p:cNvPr id="19" name="Shape 12"/>
+          <p:cNvPr id="35" name="Shape 20"/>
           <p:cNvSpPr/>
           <p:nvPr/>
         </p:nvSpPr>
         <p:spPr>
           <a:xfrm>
-            <a:off x="868680" y="5074920"/>
+            <a:off x="868680" y="5943600"/>
             <a:ext cx="164592" cy="128016"/>
           </a:xfrm>
           <a:prstGeom prst="rect">
@@ -4876,13 +4905,13 @@
       </p:sp>
       <p:sp>
         <p:nvSpPr>
-          <p:cNvPr id="20" name="Text 13"/>
+          <p:cNvPr id="36" name="Text 21"/>
           <p:cNvSpPr txBox="1"/>
           <p:nvPr/>
         </p:nvSpPr>
         <p:spPr>
           <a:xfrm>
-            <a:off x="1106424" y="5047488"/>
+            <a:off x="1106424" y="5916168"/>
             <a:ext cx="2834640" cy="201168"/>
           </a:xfrm>
           <a:prstGeom prst="rect">
@@ -4915,7 +4944,7 @@
       </p:sp>
       <p:sp>
         <p:nvSpPr>
-          <p:cNvPr id="21" name="Text 14"/>
+          <p:cNvPr id="37" name="Text 22"/>
           <p:cNvSpPr txBox="1"/>
           <p:nvPr/>
         </p:nvSpPr>
@@ -4946,7 +4975,7 @@
                 <a:ea typeface="Arial" pitchFamily="34" charset="-122"/>
                 <a:cs typeface="Arial" pitchFamily="34" charset="-120"/>
               </a:rPr>
-              <a:t>Source: Indonesia import records, HS 84269100 + 84264900, Jan 2023 – 14 Aug 2026; truck-mounted knuckle boom cranes only, Zoomlion excluded. Best-selling model = most units in the class (variants merged). Competitor price = average import unit price × Rp 17.803/USD (JISDOR 23 Sep 2026) + import duty (0% China – ACFTA; 5% Europe, assumed), PPN 11%, PPh 22 2.5% — import cost before distributor margin. Ferrari = catalogue model closest in tm to the best seller; price = TSP selling price to customers, crane only, incl. GP, warranty and tax. 7441C estimate = FBR350R A4 price + 4.9 tm × Rp 40.311.952 per tm (price step from FBR350R A4 to 746 A4 in the price list). Prices rounded to Rp 10.000.000.</a:t>
+              <a:t>Source: Indonesia import records, HS 84269100 + 84264900, Jan 2023 – 14 Aug 2026; truck-mounted knuckle boom cranes only, Zoomlion and Hyva excluded. Best-selling model = most units in the class (variants merged). Competitor price = average import unit price × Rp 17.803/USD (JISDOR 23 Sep 2026) + import duty (0% China – ACFTA; 5% Europe, assumed), PPN 11%, PPh 22 2.5% — import cost before distributor margin. Ferrari = catalogue model closest in tm to the best seller; price = TSP selling price to customers, crane only, incl. GP, warranty and tax. 7441C estimate = FBR350R A4 price + 4.9 tm × Rp 40.311.952 per tm (price step from FBR350R A4 to 746 A4 in the price list). Ferrari photos: pocket catalogue 2026 (application photos). Prices rounded to Rp 10.000.000.</a:t>
             </a:r>
             <a:endParaRPr lang="en-US" sz="750" dirty="0"/>
           </a:p>
@@ -5056,7 +5085,7 @@
                 <a:ea typeface="Arial" pitchFamily="34" charset="-122"/>
                 <a:cs typeface="Arial" pitchFamily="34" charset="-120"/>
               </a:rPr>
-              <a:t>In Heavy, F.lli Ferrari has a priced crane for 45% of units; the &gt;50–55 tm class (55%) has no Ferrari model (PK 53002 leads)</a:t>
+              <a:t>In Heavy, F.lli Ferrari has a priced crane for 39% of units; the &gt;50–55 tm class (61%) has no Ferrari model (PK 53002 leads)</a:t>
             </a:r>
             <a:endParaRPr lang="en-US" sz="1800" dirty="0"/>
           </a:p>
@@ -5200,17 +5229,16 @@
               <a:tblPr/>
               <a:tblGrid>
                 <a:gridCol w="868680"/>
-                <a:gridCol w="685800"/>
+                <a:gridCol w="640080"/>
+                <a:gridCol w="1371600"/>
+                <a:gridCol w="1600200"/>
+                <a:gridCol w="822960"/>
+                <a:gridCol w="1371600"/>
+                <a:gridCol w="1371600"/>
                 <a:gridCol w="1325880"/>
-                <a:gridCol w="1371600"/>
-                <a:gridCol w="731520"/>
-                <a:gridCol w="914400"/>
-                <a:gridCol w="1417320"/>
-                <a:gridCol w="1325880"/>
-                <a:gridCol w="731520"/>
                 <a:gridCol w="1536192"/>
               </a:tblGrid>
-              <a:tr h="457200">
+              <a:tr h="411480">
                 <a:tc>
                   <a:txBody>
                     <a:bodyPr/>
@@ -5347,75 +5375,7 @@
                     </a:solidFill>
                   </a:tcPr>
                 </a:tc>
-                <a:tc>
-                  <a:txBody>
-                    <a:bodyPr/>
-                    <a:lstStyle/>
-                    <a:p>
-                      <a:pPr algn="ctr" indent="0" marL="0">
-                        <a:buNone/>
-                      </a:pPr>
-                      <a:r>
-                        <a:rPr lang="en-US" sz="900" b="1" dirty="0">
-                          <a:solidFill>
-                            <a:srgbClr val="9AA6B2"/>
-                          </a:solidFill>
-                          <a:latin typeface="Arial" pitchFamily="34" charset="0"/>
-                          <a:ea typeface="Arial" pitchFamily="34" charset="-122"/>
-                          <a:cs typeface="Arial" pitchFamily="34" charset="-120"/>
-                        </a:rPr>
-                        <a:t>Brand</a:t>
-                      </a:r>
-                      <a:endParaRPr lang="en-US" sz="900" dirty="0">
-                        <a:latin typeface="Arial" charset="0"/>
-                        <a:ea typeface="Arial" charset="0"/>
-                        <a:cs typeface="Arial" charset="0"/>
-                      </a:endParaRPr>
-                    </a:p>
-                  </a:txBody>
-                  <a:tcPr marL="45720" marR="45720" marT="18288" marB="18288" anchor="ctr">
-                    <a:lnL w="12700" cap="flat" cmpd="sng" algn="ctr">
-                      <a:solidFill>
-                        <a:srgbClr val="0F141A"/>
-                      </a:solidFill>
-                      <a:prstDash val="solid"/>
-                      <a:round/>
-                      <a:headEnd type="none" w="med" len="med"/>
-                      <a:tailEnd type="none" w="med" len="med"/>
-                    </a:lnL>
-                    <a:lnR w="12700" cap="flat" cmpd="sng" algn="ctr">
-                      <a:solidFill>
-                        <a:srgbClr val="0F141A"/>
-                      </a:solidFill>
-                      <a:prstDash val="solid"/>
-                      <a:round/>
-                      <a:headEnd type="none" w="med" len="med"/>
-                      <a:tailEnd type="none" w="med" len="med"/>
-                    </a:lnR>
-                    <a:lnT w="12700" cap="flat" cmpd="sng" algn="ctr">
-                      <a:solidFill>
-                        <a:srgbClr val="0F141A"/>
-                      </a:solidFill>
-                      <a:prstDash val="solid"/>
-                      <a:round/>
-                      <a:headEnd type="none" w="med" len="med"/>
-                      <a:tailEnd type="none" w="med" len="med"/>
-                    </a:lnT>
-                    <a:lnB w="12700" cap="flat" cmpd="sng" algn="ctr">
-                      <a:solidFill>
-                        <a:srgbClr val="0F141A"/>
-                      </a:solidFill>
-                      <a:prstDash val="solid"/>
-                      <a:round/>
-                      <a:headEnd type="none" w="med" len="med"/>
-                      <a:tailEnd type="none" w="med" len="med"/>
-                    </a:lnB>
-                    <a:solidFill>
-                      <a:srgbClr val="26303A"/>
-                    </a:solidFill>
-                  </a:tcPr>
-                </a:tc>
-                <a:tc>
+                <a:tc gridSpan="2">
                   <a:txBody>
                     <a:bodyPr/>
                     <a:lstStyle/>
@@ -5483,73 +5443,8 @@
                     </a:solidFill>
                   </a:tcPr>
                 </a:tc>
-                <a:tc>
-                  <a:txBody>
-                    <a:bodyPr/>
-                    <a:lstStyle/>
-                    <a:p>
-                      <a:pPr algn="ctr" indent="0" marL="0">
-                        <a:buNone/>
-                      </a:pPr>
-                      <a:r>
-                        <a:rPr lang="en-US" sz="900" b="1" dirty="0">
-                          <a:solidFill>
-                            <a:srgbClr val="9AA6B2"/>
-                          </a:solidFill>
-                          <a:latin typeface="Arial" pitchFamily="34" charset="0"/>
-                          <a:ea typeface="Arial" pitchFamily="34" charset="-122"/>
-                          <a:cs typeface="Arial" pitchFamily="34" charset="-120"/>
-                        </a:rPr>
-                        <a:t>Max Lifting Moment (tm)</a:t>
-                      </a:r>
-                      <a:endParaRPr lang="en-US" sz="900" dirty="0">
-                        <a:latin typeface="Arial" charset="0"/>
-                        <a:ea typeface="Arial" charset="0"/>
-                        <a:cs typeface="Arial" charset="0"/>
-                      </a:endParaRPr>
-                    </a:p>
-                  </a:txBody>
-                  <a:tcPr marL="45720" marR="45720" marT="18288" marB="18288" anchor="ctr">
-                    <a:lnL w="12700" cap="flat" cmpd="sng" algn="ctr">
-                      <a:solidFill>
-                        <a:srgbClr val="0F141A"/>
-                      </a:solidFill>
-                      <a:prstDash val="solid"/>
-                      <a:round/>
-                      <a:headEnd type="none" w="med" len="med"/>
-                      <a:tailEnd type="none" w="med" len="med"/>
-                    </a:lnL>
-                    <a:lnR w="12700" cap="flat" cmpd="sng" algn="ctr">
-                      <a:solidFill>
-                        <a:srgbClr val="0F141A"/>
-                      </a:solidFill>
-                      <a:prstDash val="solid"/>
-                      <a:round/>
-                      <a:headEnd type="none" w="med" len="med"/>
-                      <a:tailEnd type="none" w="med" len="med"/>
-                    </a:lnR>
-                    <a:lnT w="12700" cap="flat" cmpd="sng" algn="ctr">
-                      <a:solidFill>
-                        <a:srgbClr val="0F141A"/>
-                      </a:solidFill>
-                      <a:prstDash val="solid"/>
-                      <a:round/>
-                      <a:headEnd type="none" w="med" len="med"/>
-                      <a:tailEnd type="none" w="med" len="med"/>
-                    </a:lnT>
-                    <a:lnB w="12700" cap="flat" cmpd="sng" algn="ctr">
-                      <a:solidFill>
-                        <a:srgbClr val="0F141A"/>
-                      </a:solidFill>
-                      <a:prstDash val="solid"/>
-                      <a:round/>
-                      <a:headEnd type="none" w="med" len="med"/>
-                      <a:tailEnd type="none" w="med" len="med"/>
-                    </a:lnB>
-                    <a:solidFill>
-                      <a:srgbClr val="26303A"/>
-                    </a:solidFill>
-                  </a:tcPr>
+                <a:tc hMerge="1">
+                  <a:tcPr/>
                 </a:tc>
                 <a:tc>
                   <a:txBody>
@@ -5687,7 +5582,7 @@
                     </a:solidFill>
                   </a:tcPr>
                 </a:tc>
-                <a:tc>
+                <a:tc gridSpan="2">
                   <a:txBody>
                     <a:bodyPr/>
                     <a:lstStyle/>
@@ -5755,73 +5650,8 @@
                     </a:solidFill>
                   </a:tcPr>
                 </a:tc>
-                <a:tc>
-                  <a:txBody>
-                    <a:bodyPr/>
-                    <a:lstStyle/>
-                    <a:p>
-                      <a:pPr algn="ctr" indent="0" marL="0">
-                        <a:buNone/>
-                      </a:pPr>
-                      <a:r>
-                        <a:rPr lang="en-US" sz="900" b="1" dirty="0">
-                          <a:solidFill>
-                            <a:srgbClr val="FFFFFF"/>
-                          </a:solidFill>
-                          <a:latin typeface="Arial" pitchFamily="34" charset="0"/>
-                          <a:ea typeface="Arial" pitchFamily="34" charset="-122"/>
-                          <a:cs typeface="Arial" pitchFamily="34" charset="-120"/>
-                        </a:rPr>
-                        <a:t>Max Lifting Moment (tm)</a:t>
-                      </a:r>
-                      <a:endParaRPr lang="en-US" sz="900" dirty="0">
-                        <a:latin typeface="Arial" charset="0"/>
-                        <a:ea typeface="Arial" charset="0"/>
-                        <a:cs typeface="Arial" charset="0"/>
-                      </a:endParaRPr>
-                    </a:p>
-                  </a:txBody>
-                  <a:tcPr marL="45720" marR="45720" marT="18288" marB="18288" anchor="ctr">
-                    <a:lnL w="12700" cap="flat" cmpd="sng" algn="ctr">
-                      <a:solidFill>
-                        <a:srgbClr val="0F141A"/>
-                      </a:solidFill>
-                      <a:prstDash val="solid"/>
-                      <a:round/>
-                      <a:headEnd type="none" w="med" len="med"/>
-                      <a:tailEnd type="none" w="med" len="med"/>
-                    </a:lnL>
-                    <a:lnR w="12700" cap="flat" cmpd="sng" algn="ctr">
-                      <a:solidFill>
-                        <a:srgbClr val="0F141A"/>
-                      </a:solidFill>
-                      <a:prstDash val="solid"/>
-                      <a:round/>
-                      <a:headEnd type="none" w="med" len="med"/>
-                      <a:tailEnd type="none" w="med" len="med"/>
-                    </a:lnR>
-                    <a:lnT w="12700" cap="flat" cmpd="sng" algn="ctr">
-                      <a:solidFill>
-                        <a:srgbClr val="0F141A"/>
-                      </a:solidFill>
-                      <a:prstDash val="solid"/>
-                      <a:round/>
-                      <a:headEnd type="none" w="med" len="med"/>
-                      <a:tailEnd type="none" w="med" len="med"/>
-                    </a:lnT>
-                    <a:lnB w="12700" cap="flat" cmpd="sng" algn="ctr">
-                      <a:solidFill>
-                        <a:srgbClr val="0F141A"/>
-                      </a:solidFill>
-                      <a:prstDash val="solid"/>
-                      <a:round/>
-                      <a:headEnd type="none" w="med" len="med"/>
-                      <a:tailEnd type="none" w="med" len="med"/>
-                    </a:lnB>
-                    <a:solidFill>
-                      <a:srgbClr val="E30613"/>
-                    </a:solidFill>
-                  </a:tcPr>
+                <a:tc hMerge="1">
+                  <a:tcPr/>
                 </a:tc>
                 <a:tc>
                   <a:txBody>
@@ -5892,7 +5722,7 @@
                   </a:tcPr>
                 </a:tc>
               </a:tr>
-              <a:tr h="731520">
+              <a:tr h="960120">
                 <a:tc>
                   <a:txBody>
                     <a:bodyPr/>
@@ -5978,7 +5808,7 @@
                           <a:ea typeface="Arial" pitchFamily="34" charset="-122"/>
                           <a:cs typeface="Arial" pitchFamily="34" charset="-120"/>
                         </a:rPr>
-                        <a:t>22</a:t>
+                        <a:t>18</a:t>
                       </a:r>
                       <a:endParaRPr lang="en-US" sz="1100" dirty="0">
                         <a:latin typeface="Arial" charset="0"/>
@@ -6094,17 +5924,6 @@
                       <a:pPr algn="ctr" indent="0" marL="0">
                         <a:buNone/>
                       </a:pPr>
-                      <a:r>
-                        <a:rPr lang="en-US" sz="1100" b="1" dirty="0">
-                          <a:solidFill>
-                            <a:srgbClr val="EEF1F4"/>
-                          </a:solidFill>
-                          <a:latin typeface="Arial" pitchFamily="34" charset="0"/>
-                          <a:ea typeface="Arial" pitchFamily="34" charset="-122"/>
-                          <a:cs typeface="Arial" pitchFamily="34" charset="-120"/>
-                        </a:rPr>
-                        <a:t>V950</a:t>
-                      </a:r>
                       <a:endParaRPr lang="en-US" sz="1100" dirty="0">
                         <a:latin typeface="Arial" charset="0"/>
                         <a:ea typeface="Arial" charset="0"/>
@@ -6171,75 +5990,7 @@
                           <a:ea typeface="Arial" pitchFamily="34" charset="-122"/>
                           <a:cs typeface="Arial" pitchFamily="34" charset="-120"/>
                         </a:rPr>
-                        <a:t>45.9</a:t>
-                      </a:r>
-                      <a:endParaRPr lang="en-US" sz="1100" dirty="0">
-                        <a:latin typeface="Arial" charset="0"/>
-                        <a:ea typeface="Arial" charset="0"/>
-                        <a:cs typeface="Arial" charset="0"/>
-                      </a:endParaRPr>
-                    </a:p>
-                  </a:txBody>
-                  <a:tcPr marL="45720" marR="45720" marT="18288" marB="18288" anchor="ctr">
-                    <a:lnL w="12700" cap="flat" cmpd="sng" algn="ctr">
-                      <a:solidFill>
-                        <a:srgbClr val="0F141A"/>
-                      </a:solidFill>
-                      <a:prstDash val="solid"/>
-                      <a:round/>
-                      <a:headEnd type="none" w="med" len="med"/>
-                      <a:tailEnd type="none" w="med" len="med"/>
-                    </a:lnL>
-                    <a:lnR w="12700" cap="flat" cmpd="sng" algn="ctr">
-                      <a:solidFill>
-                        <a:srgbClr val="0F141A"/>
-                      </a:solidFill>
-                      <a:prstDash val="solid"/>
-                      <a:round/>
-                      <a:headEnd type="none" w="med" len="med"/>
-                      <a:tailEnd type="none" w="med" len="med"/>
-                    </a:lnR>
-                    <a:lnT w="12700" cap="flat" cmpd="sng" algn="ctr">
-                      <a:solidFill>
-                        <a:srgbClr val="0F141A"/>
-                      </a:solidFill>
-                      <a:prstDash val="solid"/>
-                      <a:round/>
-                      <a:headEnd type="none" w="med" len="med"/>
-                      <a:tailEnd type="none" w="med" len="med"/>
-                    </a:lnT>
-                    <a:lnB w="12700" cap="flat" cmpd="sng" algn="ctr">
-                      <a:solidFill>
-                        <a:srgbClr val="0F141A"/>
-                      </a:solidFill>
-                      <a:prstDash val="solid"/>
-                      <a:round/>
-                      <a:headEnd type="none" w="med" len="med"/>
-                      <a:tailEnd type="none" w="med" len="med"/>
-                    </a:lnB>
-                    <a:solidFill>
-                      <a:srgbClr val="161D25"/>
-                    </a:solidFill>
-                  </a:tcPr>
-                </a:tc>
-                <a:tc>
-                  <a:txBody>
-                    <a:bodyPr/>
-                    <a:lstStyle/>
-                    <a:p>
-                      <a:pPr algn="ctr" indent="0" marL="0">
-                        <a:buNone/>
-                      </a:pPr>
-                      <a:r>
-                        <a:rPr lang="en-US" sz="1100" dirty="0">
-                          <a:solidFill>
-                            <a:srgbClr val="EEF1F4"/>
-                          </a:solidFill>
-                          <a:latin typeface="Arial" pitchFamily="34" charset="0"/>
-                          <a:ea typeface="Arial" pitchFamily="34" charset="-122"/>
-                          <a:cs typeface="Arial" pitchFamily="34" charset="-120"/>
-                        </a:rPr>
-                        <a:t>12 · 55%</a:t>
+                        <a:t>12 · 67%</a:t>
                       </a:r>
                       <a:endParaRPr lang="en-US" sz="1100" dirty="0">
                         <a:latin typeface="Arial" charset="0"/>
@@ -6366,17 +6117,6 @@
                       <a:pPr algn="ctr" indent="0" marL="0">
                         <a:buNone/>
                       </a:pPr>
-                      <a:r>
-                        <a:rPr lang="en-US" sz="1100" b="1" dirty="0">
-                          <a:solidFill>
-                            <a:srgbClr val="EEF1F4"/>
-                          </a:solidFill>
-                          <a:latin typeface="Arial" pitchFamily="34" charset="0"/>
-                          <a:ea typeface="Arial" pitchFamily="34" charset="-122"/>
-                          <a:cs typeface="Arial" pitchFamily="34" charset="-120"/>
-                        </a:rPr>
-                        <a:t>FBR450R A4</a:t>
-                      </a:r>
                       <a:endParaRPr lang="en-US" sz="1100" dirty="0">
                         <a:latin typeface="Arial" charset="0"/>
                         <a:ea typeface="Arial" charset="0"/>
@@ -6434,17 +6174,6 @@
                       <a:pPr algn="ctr" indent="0" marL="0">
                         <a:buNone/>
                       </a:pPr>
-                      <a:r>
-                        <a:rPr lang="en-US" sz="1100" dirty="0">
-                          <a:solidFill>
-                            <a:srgbClr val="EEF1F4"/>
-                          </a:solidFill>
-                          <a:latin typeface="Arial" pitchFamily="34" charset="0"/>
-                          <a:ea typeface="Arial" pitchFamily="34" charset="-122"/>
-                          <a:cs typeface="Arial" pitchFamily="34" charset="-120"/>
-                        </a:rPr>
-                        <a:t>45.5</a:t>
-                      </a:r>
                       <a:endParaRPr lang="en-US" sz="1100" dirty="0">
                         <a:latin typeface="Arial" charset="0"/>
                         <a:ea typeface="Arial" charset="0"/>
@@ -6563,7 +6292,7 @@
                   </a:tcPr>
                 </a:tc>
               </a:tr>
-              <a:tr h="731520">
+              <a:tr h="960120">
                 <a:tc>
                   <a:txBody>
                     <a:bodyPr/>
@@ -6765,85 +6494,6 @@
                       <a:pPr algn="ctr" indent="0" marL="0">
                         <a:buNone/>
                       </a:pPr>
-                      <a:r>
-                        <a:rPr lang="en-US" sz="1100" b="1" dirty="0">
-                          <a:solidFill>
-                            <a:srgbClr val="EEF1F4"/>
-                          </a:solidFill>
-                          <a:latin typeface="Arial" pitchFamily="34" charset="0"/>
-                          <a:ea typeface="Arial" pitchFamily="34" charset="-122"/>
-                          <a:cs typeface="Arial" pitchFamily="34" charset="-120"/>
-                        </a:rPr>
-                        <a:t>PK 53002</a:t>
-                      </a:r>
-                      <a:endParaRPr lang="en-US" sz="1100" dirty="0">
-                        <a:latin typeface="Arial" charset="0"/>
-                        <a:ea typeface="Arial" charset="0"/>
-                        <a:cs typeface="Arial" charset="0"/>
-                      </a:endParaRPr>
-                    </a:p>
-                  </a:txBody>
-                  <a:tcPr marL="45720" marR="45720" marT="18288" marB="18288" anchor="ctr">
-                    <a:lnL w="12700" cap="flat" cmpd="sng" algn="ctr">
-                      <a:solidFill>
-                        <a:srgbClr val="0F141A"/>
-                      </a:solidFill>
-                      <a:prstDash val="solid"/>
-                      <a:round/>
-                      <a:headEnd type="none" w="med" len="med"/>
-                      <a:tailEnd type="none" w="med" len="med"/>
-                    </a:lnL>
-                    <a:lnR w="12700" cap="flat" cmpd="sng" algn="ctr">
-                      <a:solidFill>
-                        <a:srgbClr val="0F141A"/>
-                      </a:solidFill>
-                      <a:prstDash val="solid"/>
-                      <a:round/>
-                      <a:headEnd type="none" w="med" len="med"/>
-                      <a:tailEnd type="none" w="med" len="med"/>
-                    </a:lnR>
-                    <a:lnT w="12700" cap="flat" cmpd="sng" algn="ctr">
-                      <a:solidFill>
-                        <a:srgbClr val="0F141A"/>
-                      </a:solidFill>
-                      <a:prstDash val="solid"/>
-                      <a:round/>
-                      <a:headEnd type="none" w="med" len="med"/>
-                      <a:tailEnd type="none" w="med" len="med"/>
-                    </a:lnT>
-                    <a:lnB w="12700" cap="flat" cmpd="sng" algn="ctr">
-                      <a:solidFill>
-                        <a:srgbClr val="0F141A"/>
-                      </a:solidFill>
-                      <a:prstDash val="solid"/>
-                      <a:round/>
-                      <a:headEnd type="none" w="med" len="med"/>
-                      <a:tailEnd type="none" w="med" len="med"/>
-                    </a:lnB>
-                    <a:solidFill>
-                      <a:srgbClr val="161D25"/>
-                    </a:solidFill>
-                  </a:tcPr>
-                </a:tc>
-                <a:tc>
-                  <a:txBody>
-                    <a:bodyPr/>
-                    <a:lstStyle/>
-                    <a:p>
-                      <a:pPr algn="ctr" indent="0" marL="0">
-                        <a:buNone/>
-                      </a:pPr>
-                      <a:r>
-                        <a:rPr lang="en-US" sz="1100" dirty="0">
-                          <a:solidFill>
-                            <a:srgbClr val="EEF1F4"/>
-                          </a:solidFill>
-                          <a:latin typeface="Arial" pitchFamily="34" charset="0"/>
-                          <a:ea typeface="Arial" pitchFamily="34" charset="-122"/>
-                          <a:cs typeface="Arial" pitchFamily="34" charset="-120"/>
-                        </a:rPr>
-                        <a:t>50.1</a:t>
-                      </a:r>
                       <a:endParaRPr lang="en-US" sz="1100" dirty="0">
                         <a:latin typeface="Arial" charset="0"/>
                         <a:ea typeface="Arial" charset="0"/>
@@ -7104,7 +6754,7 @@
                   <a:tcPr/>
                 </a:tc>
               </a:tr>
-              <a:tr h="731520">
+              <a:tr h="960120">
                 <a:tc>
                   <a:txBody>
                     <a:bodyPr/>
@@ -7143,7 +6793,7 @@
                           <a:ea typeface="Arial" pitchFamily="34" charset="-122"/>
                           <a:cs typeface="Arial" pitchFamily="34" charset="-120"/>
                         </a:rPr>
-                        <a:t>7 models</a:t>
+                        <a:t>5 models</a:t>
                       </a:r>
                       <a:endParaRPr lang="en-US" sz="1100" dirty="0">
                         <a:latin typeface="Arial" charset="0"/>
@@ -7211,7 +6861,7 @@
                           <a:ea typeface="Arial" pitchFamily="34" charset="-122"/>
                           <a:cs typeface="Arial" pitchFamily="34" charset="-120"/>
                         </a:rPr>
-                        <a:t>11</a:t>
+                        <a:t>8</a:t>
                       </a:r>
                       <a:endParaRPr lang="en-US" sz="1100" dirty="0">
                         <a:latin typeface="Arial" charset="0"/>
@@ -7327,17 +6977,6 @@
                       <a:pPr algn="ctr" indent="0" marL="0">
                         <a:buNone/>
                       </a:pPr>
-                      <a:r>
-                        <a:rPr lang="en-US" sz="1100" b="1" dirty="0">
-                          <a:solidFill>
-                            <a:srgbClr val="EEF1F4"/>
-                          </a:solidFill>
-                          <a:latin typeface="Arial" pitchFamily="34" charset="0"/>
-                          <a:ea typeface="Arial" pitchFamily="34" charset="-122"/>
-                          <a:cs typeface="Arial" pitchFamily="34" charset="-120"/>
-                        </a:rPr>
-                        <a:t>PK 76002 EH D</a:t>
-                      </a:r>
                       <a:endParaRPr lang="en-US" sz="1100" dirty="0">
                         <a:latin typeface="Arial" charset="0"/>
                         <a:ea typeface="Arial" charset="0"/>
@@ -7404,75 +7043,7 @@
                           <a:ea typeface="Arial" pitchFamily="34" charset="-122"/>
                           <a:cs typeface="Arial" pitchFamily="34" charset="-120"/>
                         </a:rPr>
-                        <a:t>71.6</a:t>
-                      </a:r>
-                      <a:endParaRPr lang="en-US" sz="1100" dirty="0">
-                        <a:latin typeface="Arial" charset="0"/>
-                        <a:ea typeface="Arial" charset="0"/>
-                        <a:cs typeface="Arial" charset="0"/>
-                      </a:endParaRPr>
-                    </a:p>
-                  </a:txBody>
-                  <a:tcPr marL="45720" marR="45720" marT="18288" marB="18288" anchor="ctr">
-                    <a:lnL w="12700" cap="flat" cmpd="sng" algn="ctr">
-                      <a:solidFill>
-                        <a:srgbClr val="0F141A"/>
-                      </a:solidFill>
-                      <a:prstDash val="solid"/>
-                      <a:round/>
-                      <a:headEnd type="none" w="med" len="med"/>
-                      <a:tailEnd type="none" w="med" len="med"/>
-                    </a:lnL>
-                    <a:lnR w="12700" cap="flat" cmpd="sng" algn="ctr">
-                      <a:solidFill>
-                        <a:srgbClr val="0F141A"/>
-                      </a:solidFill>
-                      <a:prstDash val="solid"/>
-                      <a:round/>
-                      <a:headEnd type="none" w="med" len="med"/>
-                      <a:tailEnd type="none" w="med" len="med"/>
-                    </a:lnR>
-                    <a:lnT w="12700" cap="flat" cmpd="sng" algn="ctr">
-                      <a:solidFill>
-                        <a:srgbClr val="0F141A"/>
-                      </a:solidFill>
-                      <a:prstDash val="solid"/>
-                      <a:round/>
-                      <a:headEnd type="none" w="med" len="med"/>
-                      <a:tailEnd type="none" w="med" len="med"/>
-                    </a:lnT>
-                    <a:lnB w="12700" cap="flat" cmpd="sng" algn="ctr">
-                      <a:solidFill>
-                        <a:srgbClr val="0F141A"/>
-                      </a:solidFill>
-                      <a:prstDash val="solid"/>
-                      <a:round/>
-                      <a:headEnd type="none" w="med" len="med"/>
-                      <a:tailEnd type="none" w="med" len="med"/>
-                    </a:lnB>
-                    <a:solidFill>
-                      <a:srgbClr val="161D25"/>
-                    </a:solidFill>
-                  </a:tcPr>
-                </a:tc>
-                <a:tc>
-                  <a:txBody>
-                    <a:bodyPr/>
-                    <a:lstStyle/>
-                    <a:p>
-                      <a:pPr algn="ctr" indent="0" marL="0">
-                        <a:buNone/>
-                      </a:pPr>
-                      <a:r>
-                        <a:rPr lang="en-US" sz="1100" dirty="0">
-                          <a:solidFill>
-                            <a:srgbClr val="EEF1F4"/>
-                          </a:solidFill>
-                          <a:latin typeface="Arial" pitchFamily="34" charset="0"/>
-                          <a:ea typeface="Arial" pitchFamily="34" charset="-122"/>
-                          <a:cs typeface="Arial" pitchFamily="34" charset="-120"/>
-                        </a:rPr>
-                        <a:t>2 · 18%</a:t>
+                        <a:t>2 · 25%</a:t>
                       </a:r>
                       <a:endParaRPr lang="en-US" sz="1100" dirty="0">
                         <a:latin typeface="Arial" charset="0"/>
@@ -7599,17 +7170,6 @@
                       <a:pPr algn="ctr" indent="0" marL="0">
                         <a:buNone/>
                       </a:pPr>
-                      <a:r>
-                        <a:rPr lang="en-US" sz="1100" b="1" dirty="0">
-                          <a:solidFill>
-                            <a:srgbClr val="EEF1F4"/>
-                          </a:solidFill>
-                          <a:latin typeface="Arial" pitchFamily="34" charset="0"/>
-                          <a:ea typeface="Arial" pitchFamily="34" charset="-122"/>
-                          <a:cs typeface="Arial" pitchFamily="34" charset="-120"/>
-                        </a:rPr>
-                        <a:t>FBR660R A4</a:t>
-                      </a:r>
                       <a:endParaRPr lang="en-US" sz="1100" dirty="0">
                         <a:latin typeface="Arial" charset="0"/>
                         <a:ea typeface="Arial" charset="0"/>
@@ -7667,17 +7227,6 @@
                       <a:pPr algn="ctr" indent="0" marL="0">
                         <a:buNone/>
                       </a:pPr>
-                      <a:r>
-                        <a:rPr lang="en-US" sz="1100" dirty="0">
-                          <a:solidFill>
-                            <a:srgbClr val="EEF1F4"/>
-                          </a:solidFill>
-                          <a:latin typeface="Arial" pitchFamily="34" charset="0"/>
-                          <a:ea typeface="Arial" pitchFamily="34" charset="-122"/>
-                          <a:cs typeface="Arial" pitchFamily="34" charset="-120"/>
-                        </a:rPr>
-                        <a:t>58.8</a:t>
-                      </a:r>
                       <a:endParaRPr lang="en-US" sz="1100" dirty="0">
                         <a:latin typeface="Arial" charset="0"/>
                         <a:ea typeface="Arial" charset="0"/>
@@ -7800,20 +7349,43 @@
           </a:graphicData>
         </a:graphic>
       </p:graphicFrame>
+      <p:pic>
+        <p:nvPicPr>
+          <p:cNvPr id="9" name="Image 0" descr="assets/photo_v950.jpg">    </p:cNvPr>
+          <p:cNvPicPr>
+            <a:picLocks noChangeAspect="1"/>
+          </p:cNvPicPr>
+          <p:nvPr/>
+        </p:nvPicPr>
+        <p:blipFill>
+          <a:blip r:embed="rId1"/>
+          <a:srcRect l="0" r="0" t="0" b="0"/>
+          <a:stretch/>
+        </p:blipFill>
+        <p:spPr>
+          <a:xfrm>
+            <a:off x="2432304" y="2002536"/>
+            <a:ext cx="1261872" cy="850392"/>
+          </a:xfrm>
+          <a:prstGeom prst="rect">
+            <a:avLst/>
+          </a:prstGeom>
+        </p:spPr>
+      </p:pic>
       <p:sp>
         <p:nvSpPr>
-          <p:cNvPr id="9" name="Shape 6"/>
+          <p:cNvPr id="10" name="Shape 6"/>
           <p:cNvSpPr/>
           <p:nvPr/>
         </p:nvSpPr>
         <p:spPr>
           <a:xfrm>
-            <a:off x="2514600" y="2194560"/>
-            <a:ext cx="1143000" cy="329184"/>
+            <a:off x="3886200" y="2043684"/>
+            <a:ext cx="1325880" cy="274320"/>
           </a:xfrm>
           <a:prstGeom prst="roundRect">
             <a:avLst>
-              <a:gd name="adj" fmla="val 11111"/>
+              <a:gd name="adj" fmla="val 13333"/>
             </a:avLst>
           </a:prstGeom>
           <a:solidFill>
@@ -7829,22 +7401,22 @@
       </p:sp>
       <p:pic>
         <p:nvPicPr>
-          <p:cNvPr id="10" name="Image 0" descr="assets/logo_amcoveba.png">    </p:cNvPr>
+          <p:cNvPr id="11" name="Image 1" descr="assets/logo_amcoveba.png">    </p:cNvPr>
           <p:cNvPicPr>
             <a:picLocks noChangeAspect="1"/>
           </p:cNvPicPr>
           <p:nvPr/>
         </p:nvPicPr>
         <p:blipFill>
-          <a:blip r:embed="rId1"/>
+          <a:blip r:embed="rId2"/>
           <a:stretch>
             <a:fillRect/>
           </a:stretch>
         </p:blipFill>
         <p:spPr>
           <a:xfrm>
-            <a:off x="2560320" y="2241502"/>
-            <a:ext cx="1051560" cy="235301"/>
+            <a:off x="4099630" y="2080260"/>
+            <a:ext cx="899020" cy="201168"/>
           </a:xfrm>
           <a:prstGeom prst="rect">
             <a:avLst/>
@@ -7853,18 +7425,176 @@
       </p:pic>
       <p:sp>
         <p:nvSpPr>
-          <p:cNvPr id="11" name="Shape 7"/>
+          <p:cNvPr id="12" name="Text 7"/>
+          <p:cNvSpPr txBox="1"/>
+          <p:nvPr/>
+        </p:nvSpPr>
+        <p:spPr>
+          <a:xfrm>
+            <a:off x="3749040" y="2372868"/>
+            <a:ext cx="1600200" cy="411480"/>
+          </a:xfrm>
+          <a:prstGeom prst="rect">
+            <a:avLst/>
+          </a:prstGeom>
+          <a:noFill/>
+          <a:ln/>
+        </p:spPr>
+        <p:txBody>
+          <a:bodyPr wrap="square" lIns="0" tIns="0" rIns="0" bIns="0" rtlCol="0" anchor="t"/>
+          <a:lstStyle/>
+          <a:p>
+            <a:pPr algn="ctr" indent="0" marL="0">
+              <a:buNone/>
+            </a:pPr>
+            <a:r>
+              <a:rPr lang="en-US" sz="1100" b="1" dirty="0">
+                <a:solidFill>
+                  <a:srgbClr val="EEF1F4"/>
+                </a:solidFill>
+                <a:latin typeface="Arial" pitchFamily="34" charset="0"/>
+                <a:ea typeface="Arial" pitchFamily="34" charset="-122"/>
+                <a:cs typeface="Arial" pitchFamily="34" charset="-120"/>
+              </a:rPr>
+              <a:t>V950</a:t>
+            </a:r>
+            <a:endParaRPr lang="en-US" sz="1100" dirty="0"/>
+          </a:p>
+          <a:p>
+            <a:pPr algn="ctr" indent="0" marL="0">
+              <a:buNone/>
+            </a:pPr>
+            <a:r>
+              <a:rPr lang="en-US" sz="900" dirty="0">
+                <a:solidFill>
+                  <a:srgbClr val="9AA6B2"/>
+                </a:solidFill>
+                <a:latin typeface="Arial" pitchFamily="34" charset="0"/>
+                <a:ea typeface="Arial" pitchFamily="34" charset="-122"/>
+                <a:cs typeface="Arial" pitchFamily="34" charset="-120"/>
+              </a:rPr>
+              <a:t>45.9 tm</a:t>
+            </a:r>
+            <a:endParaRPr lang="en-US" sz="1100" dirty="0"/>
+          </a:p>
+        </p:txBody>
+      </p:sp>
+      <p:pic>
+        <p:nvPicPr>
+          <p:cNvPr id="13" name="Image 2" descr="assets/photo_fbr450r.jpg">    </p:cNvPr>
+          <p:cNvPicPr>
+            <a:picLocks noChangeAspect="1"/>
+          </p:cNvPicPr>
+          <p:nvPr/>
+        </p:nvPicPr>
+        <p:blipFill>
+          <a:blip r:embed="rId3"/>
+          <a:srcRect l="0" r="0" t="0" b="0"/>
+          <a:stretch/>
+        </p:blipFill>
+        <p:spPr>
+          <a:xfrm>
+            <a:off x="7598664" y="2002536"/>
+            <a:ext cx="1261872" cy="850392"/>
+          </a:xfrm>
+          <a:prstGeom prst="rect">
+            <a:avLst/>
+          </a:prstGeom>
+        </p:spPr>
+      </p:pic>
+      <p:sp>
+        <p:nvSpPr>
+          <p:cNvPr id="14" name="Text 8"/>
+          <p:cNvSpPr txBox="1"/>
+          <p:nvPr/>
+        </p:nvSpPr>
+        <p:spPr>
+          <a:xfrm>
+            <a:off x="8915400" y="1947672"/>
+            <a:ext cx="1325880" cy="960120"/>
+          </a:xfrm>
+          <a:prstGeom prst="rect">
+            <a:avLst/>
+          </a:prstGeom>
+          <a:noFill/>
+          <a:ln/>
+        </p:spPr>
+        <p:txBody>
+          <a:bodyPr wrap="square" lIns="0" tIns="0" rIns="0" bIns="0" rtlCol="0" anchor="ctr"/>
+          <a:lstStyle/>
+          <a:p>
+            <a:pPr algn="ctr" indent="0" marL="0">
+              <a:buNone/>
+            </a:pPr>
+            <a:r>
+              <a:rPr lang="en-US" sz="1100" b="1" dirty="0">
+                <a:solidFill>
+                  <a:srgbClr val="EEF1F4"/>
+                </a:solidFill>
+                <a:latin typeface="Arial" pitchFamily="34" charset="0"/>
+                <a:ea typeface="Arial" pitchFamily="34" charset="-122"/>
+                <a:cs typeface="Arial" pitchFamily="34" charset="-120"/>
+              </a:rPr>
+              <a:t>FBR450R A4</a:t>
+            </a:r>
+            <a:endParaRPr lang="en-US" sz="1100" dirty="0"/>
+          </a:p>
+          <a:p>
+            <a:pPr algn="ctr" indent="0" marL="0">
+              <a:buNone/>
+            </a:pPr>
+            <a:r>
+              <a:rPr lang="en-US" sz="900" dirty="0">
+                <a:solidFill>
+                  <a:srgbClr val="9AA6B2"/>
+                </a:solidFill>
+                <a:latin typeface="Arial" pitchFamily="34" charset="0"/>
+                <a:ea typeface="Arial" pitchFamily="34" charset="-122"/>
+                <a:cs typeface="Arial" pitchFamily="34" charset="-120"/>
+              </a:rPr>
+              <a:t>45.5 tm</a:t>
+            </a:r>
+            <a:endParaRPr lang="en-US" sz="1100" dirty="0"/>
+          </a:p>
+        </p:txBody>
+      </p:sp>
+      <p:pic>
+        <p:nvPicPr>
+          <p:cNvPr id="15" name="Image 3" descr="assets/photo_pk53002.jpg">    </p:cNvPr>
+          <p:cNvPicPr>
+            <a:picLocks noChangeAspect="1"/>
+          </p:cNvPicPr>
+          <p:nvPr/>
+        </p:nvPicPr>
+        <p:blipFill>
+          <a:blip r:embed="rId4"/>
+          <a:srcRect l="0" r="0" t="0" b="0"/>
+          <a:stretch/>
+        </p:blipFill>
+        <p:spPr>
+          <a:xfrm>
+            <a:off x="2432304" y="2962656"/>
+            <a:ext cx="1261872" cy="850392"/>
+          </a:xfrm>
+          <a:prstGeom prst="rect">
+            <a:avLst/>
+          </a:prstGeom>
+        </p:spPr>
+      </p:pic>
+      <p:sp>
+        <p:nvSpPr>
+          <p:cNvPr id="16" name="Shape 9"/>
           <p:cNvSpPr/>
           <p:nvPr/>
         </p:nvSpPr>
         <p:spPr>
           <a:xfrm>
-            <a:off x="2514600" y="2926080"/>
-            <a:ext cx="1143000" cy="329184"/>
+            <a:off x="3886200" y="3003804"/>
+            <a:ext cx="1325880" cy="274320"/>
           </a:xfrm>
           <a:prstGeom prst="roundRect">
             <a:avLst>
-              <a:gd name="adj" fmla="val 11111"/>
+              <a:gd name="adj" fmla="val 13333"/>
             </a:avLst>
           </a:prstGeom>
           <a:solidFill>
@@ -7880,22 +7610,22 @@
       </p:sp>
       <p:pic>
         <p:nvPicPr>
-          <p:cNvPr id="12" name="Image 1" descr="assets/logo_palfinger.png">    </p:cNvPr>
+          <p:cNvPr id="17" name="Image 4" descr="assets/logo_palfinger.png">    </p:cNvPr>
           <p:cNvPicPr>
             <a:picLocks noChangeAspect="1"/>
           </p:cNvPicPr>
           <p:nvPr/>
         </p:nvPicPr>
         <p:blipFill>
-          <a:blip r:embed="rId2"/>
+          <a:blip r:embed="rId5"/>
           <a:stretch>
             <a:fillRect/>
           </a:stretch>
         </p:blipFill>
         <p:spPr>
           <a:xfrm>
-            <a:off x="2560320" y="2974246"/>
-            <a:ext cx="1051560" cy="232852"/>
+            <a:off x="4094903" y="3040380"/>
+            <a:ext cx="908475" cy="201168"/>
           </a:xfrm>
           <a:prstGeom prst="rect">
             <a:avLst/>
@@ -7904,18 +7634,113 @@
       </p:pic>
       <p:sp>
         <p:nvSpPr>
-          <p:cNvPr id="13" name="Shape 8"/>
+          <p:cNvPr id="18" name="Text 10"/>
+          <p:cNvSpPr txBox="1"/>
+          <p:nvPr/>
+        </p:nvSpPr>
+        <p:spPr>
+          <a:xfrm>
+            <a:off x="3749040" y="3332988"/>
+            <a:ext cx="1600200" cy="411480"/>
+          </a:xfrm>
+          <a:prstGeom prst="rect">
+            <a:avLst/>
+          </a:prstGeom>
+          <a:noFill/>
+          <a:ln/>
+        </p:spPr>
+        <p:txBody>
+          <a:bodyPr wrap="square" lIns="0" tIns="0" rIns="0" bIns="0" rtlCol="0" anchor="t"/>
+          <a:lstStyle/>
+          <a:p>
+            <a:pPr algn="ctr" indent="0" marL="0">
+              <a:buNone/>
+            </a:pPr>
+            <a:r>
+              <a:rPr lang="en-US" sz="1100" b="1" dirty="0">
+                <a:solidFill>
+                  <a:srgbClr val="EEF1F4"/>
+                </a:solidFill>
+                <a:latin typeface="Arial" pitchFamily="34" charset="0"/>
+                <a:ea typeface="Arial" pitchFamily="34" charset="-122"/>
+                <a:cs typeface="Arial" pitchFamily="34" charset="-120"/>
+              </a:rPr>
+              <a:t>PK 53002</a:t>
+            </a:r>
+            <a:endParaRPr lang="en-US" sz="1100" dirty="0"/>
+          </a:p>
+          <a:p>
+            <a:pPr algn="ctr" indent="0" marL="0">
+              <a:buNone/>
+            </a:pPr>
+            <a:r>
+              <a:rPr lang="en-US" sz="900" dirty="0">
+                <a:solidFill>
+                  <a:srgbClr val="9AA6B2"/>
+                </a:solidFill>
+                <a:latin typeface="Arial" pitchFamily="34" charset="0"/>
+                <a:ea typeface="Arial" pitchFamily="34" charset="-122"/>
+                <a:cs typeface="Arial" pitchFamily="34" charset="-120"/>
+              </a:rPr>
+              <a:t>50.1 tm</a:t>
+            </a:r>
+            <a:endParaRPr lang="en-US" sz="1100" dirty="0"/>
+          </a:p>
+        </p:txBody>
+      </p:sp>
+      <p:sp>
+        <p:nvSpPr>
+          <p:cNvPr id="19" name="Text 11"/>
+          <p:cNvSpPr txBox="1"/>
+          <p:nvPr/>
+        </p:nvSpPr>
+        <p:spPr>
+          <a:xfrm>
+            <a:off x="2432304" y="3922776"/>
+            <a:ext cx="1261872" cy="850392"/>
+          </a:xfrm>
+          <a:prstGeom prst="rect">
+            <a:avLst/>
+          </a:prstGeom>
+          <a:noFill/>
+          <a:ln/>
+        </p:spPr>
+        <p:txBody>
+          <a:bodyPr wrap="square" lIns="0" tIns="0" rIns="0" bIns="0" rtlCol="0" anchor="ctr"/>
+          <a:lstStyle/>
+          <a:p>
+            <a:pPr algn="ctr" indent="0" marL="0">
+              <a:buNone/>
+            </a:pPr>
+            <a:r>
+              <a:rPr lang="en-US" sz="800" i="1" dirty="0">
+                <a:solidFill>
+                  <a:srgbClr val="5C6773"/>
+                </a:solidFill>
+                <a:latin typeface="Arial" pitchFamily="34" charset="0"/>
+                <a:ea typeface="Arial" pitchFamily="34" charset="-122"/>
+                <a:cs typeface="Arial" pitchFamily="34" charset="-120"/>
+              </a:rPr>
+              <a:t>Photo to follow</a:t>
+            </a:r>
+            <a:endParaRPr lang="en-US" sz="800" dirty="0"/>
+          </a:p>
+        </p:txBody>
+      </p:sp>
+      <p:sp>
+        <p:nvSpPr>
+          <p:cNvPr id="20" name="Shape 12"/>
           <p:cNvSpPr/>
           <p:nvPr/>
         </p:nvSpPr>
         <p:spPr>
           <a:xfrm>
-            <a:off x="2514600" y="3657600"/>
-            <a:ext cx="1143000" cy="329184"/>
+            <a:off x="3886200" y="3963924"/>
+            <a:ext cx="1325880" cy="274320"/>
           </a:xfrm>
           <a:prstGeom prst="roundRect">
             <a:avLst>
-              <a:gd name="adj" fmla="val 11111"/>
+              <a:gd name="adj" fmla="val 13333"/>
             </a:avLst>
           </a:prstGeom>
           <a:solidFill>
@@ -7931,22 +7756,22 @@
       </p:sp>
       <p:pic>
         <p:nvPicPr>
-          <p:cNvPr id="14" name="Image 2" descr="assets/logo_palfinger.png">    </p:cNvPr>
+          <p:cNvPr id="21" name="Image 5" descr="assets/logo_palfinger.png">    </p:cNvPr>
           <p:cNvPicPr>
             <a:picLocks noChangeAspect="1"/>
           </p:cNvPicPr>
           <p:nvPr/>
         </p:nvPicPr>
         <p:blipFill>
-          <a:blip r:embed="rId3"/>
+          <a:blip r:embed="rId6"/>
           <a:stretch>
             <a:fillRect/>
           </a:stretch>
         </p:blipFill>
         <p:spPr>
           <a:xfrm>
-            <a:off x="2560320" y="3705766"/>
-            <a:ext cx="1051560" cy="232852"/>
+            <a:off x="4094903" y="4000500"/>
+            <a:ext cx="908475" cy="201168"/>
           </a:xfrm>
           <a:prstGeom prst="rect">
             <a:avLst/>
@@ -7955,14 +7780,149 @@
       </p:pic>
       <p:sp>
         <p:nvSpPr>
-          <p:cNvPr id="15" name="Shape 9"/>
+          <p:cNvPr id="22" name="Text 13"/>
+          <p:cNvSpPr txBox="1"/>
+          <p:nvPr/>
+        </p:nvSpPr>
+        <p:spPr>
+          <a:xfrm>
+            <a:off x="3749040" y="4293108"/>
+            <a:ext cx="1600200" cy="411480"/>
+          </a:xfrm>
+          <a:prstGeom prst="rect">
+            <a:avLst/>
+          </a:prstGeom>
+          <a:noFill/>
+          <a:ln/>
+        </p:spPr>
+        <p:txBody>
+          <a:bodyPr wrap="square" lIns="0" tIns="0" rIns="0" bIns="0" rtlCol="0" anchor="t"/>
+          <a:lstStyle/>
+          <a:p>
+            <a:pPr algn="ctr" indent="0" marL="0">
+              <a:buNone/>
+            </a:pPr>
+            <a:r>
+              <a:rPr lang="en-US" sz="1100" b="1" dirty="0">
+                <a:solidFill>
+                  <a:srgbClr val="EEF1F4"/>
+                </a:solidFill>
+                <a:latin typeface="Arial" pitchFamily="34" charset="0"/>
+                <a:ea typeface="Arial" pitchFamily="34" charset="-122"/>
+                <a:cs typeface="Arial" pitchFamily="34" charset="-120"/>
+              </a:rPr>
+              <a:t>PK 76002 EH D</a:t>
+            </a:r>
+            <a:endParaRPr lang="en-US" sz="1100" dirty="0"/>
+          </a:p>
+          <a:p>
+            <a:pPr algn="ctr" indent="0" marL="0">
+              <a:buNone/>
+            </a:pPr>
+            <a:r>
+              <a:rPr lang="en-US" sz="900" dirty="0">
+                <a:solidFill>
+                  <a:srgbClr val="9AA6B2"/>
+                </a:solidFill>
+                <a:latin typeface="Arial" pitchFamily="34" charset="0"/>
+                <a:ea typeface="Arial" pitchFamily="34" charset="-122"/>
+                <a:cs typeface="Arial" pitchFamily="34" charset="-120"/>
+              </a:rPr>
+              <a:t>71.6 tm</a:t>
+            </a:r>
+            <a:endParaRPr lang="en-US" sz="1100" dirty="0"/>
+          </a:p>
+        </p:txBody>
+      </p:sp>
+      <p:pic>
+        <p:nvPicPr>
+          <p:cNvPr id="23" name="Image 6" descr="assets/photo_fbr660r.jpg">    </p:cNvPr>
+          <p:cNvPicPr>
+            <a:picLocks noChangeAspect="1"/>
+          </p:cNvPicPr>
+          <p:nvPr/>
+        </p:nvPicPr>
+        <p:blipFill>
+          <a:blip r:embed="rId7"/>
+          <a:srcRect l="0" r="0" t="0" b="0"/>
+          <a:stretch/>
+        </p:blipFill>
+        <p:spPr>
+          <a:xfrm>
+            <a:off x="7598664" y="3922776"/>
+            <a:ext cx="1261872" cy="850392"/>
+          </a:xfrm>
+          <a:prstGeom prst="rect">
+            <a:avLst/>
+          </a:prstGeom>
+        </p:spPr>
+      </p:pic>
+      <p:sp>
+        <p:nvSpPr>
+          <p:cNvPr id="24" name="Text 14"/>
+          <p:cNvSpPr txBox="1"/>
+          <p:nvPr/>
+        </p:nvSpPr>
+        <p:spPr>
+          <a:xfrm>
+            <a:off x="8915400" y="3867912"/>
+            <a:ext cx="1325880" cy="960120"/>
+          </a:xfrm>
+          <a:prstGeom prst="rect">
+            <a:avLst/>
+          </a:prstGeom>
+          <a:noFill/>
+          <a:ln/>
+        </p:spPr>
+        <p:txBody>
+          <a:bodyPr wrap="square" lIns="0" tIns="0" rIns="0" bIns="0" rtlCol="0" anchor="ctr"/>
+          <a:lstStyle/>
+          <a:p>
+            <a:pPr algn="ctr" indent="0" marL="0">
+              <a:buNone/>
+            </a:pPr>
+            <a:r>
+              <a:rPr lang="en-US" sz="1100" b="1" dirty="0">
+                <a:solidFill>
+                  <a:srgbClr val="EEF1F4"/>
+                </a:solidFill>
+                <a:latin typeface="Arial" pitchFamily="34" charset="0"/>
+                <a:ea typeface="Arial" pitchFamily="34" charset="-122"/>
+                <a:cs typeface="Arial" pitchFamily="34" charset="-120"/>
+              </a:rPr>
+              <a:t>FBR660R A4</a:t>
+            </a:r>
+            <a:endParaRPr lang="en-US" sz="1100" dirty="0"/>
+          </a:p>
+          <a:p>
+            <a:pPr algn="ctr" indent="0" marL="0">
+              <a:buNone/>
+            </a:pPr>
+            <a:r>
+              <a:rPr lang="en-US" sz="900" dirty="0">
+                <a:solidFill>
+                  <a:srgbClr val="9AA6B2"/>
+                </a:solidFill>
+                <a:latin typeface="Arial" pitchFamily="34" charset="0"/>
+                <a:ea typeface="Arial" pitchFamily="34" charset="-122"/>
+                <a:cs typeface="Arial" pitchFamily="34" charset="-120"/>
+              </a:rPr>
+              <a:t>58.8 tm</a:t>
+            </a:r>
+            <a:endParaRPr lang="en-US" sz="1100" dirty="0"/>
+          </a:p>
+        </p:txBody>
+      </p:sp>
+      <p:sp>
+        <p:nvSpPr>
+          <p:cNvPr id="25" name="Shape 15"/>
           <p:cNvSpPr/>
           <p:nvPr/>
         </p:nvSpPr>
         <p:spPr>
           <a:xfrm>
-            <a:off x="411480" y="2011680"/>
-            <a:ext cx="411480" cy="2157984"/>
+            <a:off x="411480" y="1965960"/>
+            <a:ext cx="411480" cy="2843784"/>
           </a:xfrm>
           <a:prstGeom prst="rect">
             <a:avLst/>
@@ -7980,14 +7940,14 @@
       </p:sp>
       <p:sp>
         <p:nvSpPr>
-          <p:cNvPr id="16" name="Text 10"/>
+          <p:cNvPr id="26" name="Text 16"/>
           <p:cNvSpPr txBox="1"/>
           <p:nvPr/>
         </p:nvSpPr>
         <p:spPr>
           <a:xfrm rot="16200000">
-            <a:off x="-480060" y="2884932"/>
-            <a:ext cx="2194560" cy="411480"/>
+            <a:off x="-822960" y="3182112"/>
+            <a:ext cx="2880360" cy="411480"/>
           </a:xfrm>
           <a:prstGeom prst="rect">
             <a:avLst/>
@@ -8019,13 +7979,13 @@
       </p:sp>
       <p:sp>
         <p:nvSpPr>
-          <p:cNvPr id="17" name="Shape 11"/>
+          <p:cNvPr id="27" name="Shape 17"/>
           <p:cNvSpPr/>
           <p:nvPr/>
         </p:nvSpPr>
         <p:spPr>
           <a:xfrm>
-            <a:off x="868680" y="4343400"/>
+            <a:off x="868680" y="4983480"/>
             <a:ext cx="164592" cy="128016"/>
           </a:xfrm>
           <a:prstGeom prst="rect">
@@ -8044,13 +8004,13 @@
       </p:sp>
       <p:sp>
         <p:nvSpPr>
-          <p:cNvPr id="18" name="Text 12"/>
+          <p:cNvPr id="28" name="Text 18"/>
           <p:cNvSpPr txBox="1"/>
           <p:nvPr/>
         </p:nvSpPr>
         <p:spPr>
           <a:xfrm>
-            <a:off x="1106424" y="4315968"/>
+            <a:off x="1106424" y="4956048"/>
             <a:ext cx="2834640" cy="201168"/>
           </a:xfrm>
           <a:prstGeom prst="rect">
@@ -8083,13 +8043,13 @@
       </p:sp>
       <p:sp>
         <p:nvSpPr>
-          <p:cNvPr id="19" name="Shape 13"/>
+          <p:cNvPr id="29" name="Shape 19"/>
           <p:cNvSpPr/>
           <p:nvPr/>
         </p:nvSpPr>
         <p:spPr>
           <a:xfrm>
-            <a:off x="3977640" y="4343400"/>
+            <a:off x="3977640" y="4983480"/>
             <a:ext cx="164592" cy="128016"/>
           </a:xfrm>
           <a:prstGeom prst="rect">
@@ -8108,13 +8068,13 @@
       </p:sp>
       <p:sp>
         <p:nvSpPr>
-          <p:cNvPr id="20" name="Text 14"/>
+          <p:cNvPr id="30" name="Text 20"/>
           <p:cNvSpPr txBox="1"/>
           <p:nvPr/>
         </p:nvSpPr>
         <p:spPr>
           <a:xfrm>
-            <a:off x="4215384" y="4315968"/>
+            <a:off x="4215384" y="4956048"/>
             <a:ext cx="2834640" cy="201168"/>
           </a:xfrm>
           <a:prstGeom prst="rect">
@@ -8147,7 +8107,7 @@
       </p:sp>
       <p:sp>
         <p:nvSpPr>
-          <p:cNvPr id="21" name="Text 15"/>
+          <p:cNvPr id="31" name="Text 21"/>
           <p:cNvSpPr txBox="1"/>
           <p:nvPr/>
         </p:nvSpPr>
@@ -8178,7 +8138,7 @@
                 <a:ea typeface="Arial" pitchFamily="34" charset="-122"/>
                 <a:cs typeface="Arial" pitchFamily="34" charset="-120"/>
               </a:rPr>
-              <a:t>Source: Indonesia import records, HS 84269100 + 84264900, Jan 2023 – 14 Aug 2026; truck-mounted knuckle boom cranes only, Zoomlion excluded. Best-selling model = most units in the class (variants merged). Competitor price = average import unit price × Rp 17.803/USD (JISDOR 23 Sep 2026) + import duty (0% China – ACFTA; 5% Europe, assumed), PPN 11%, PPh 22 2.5% — import cost before distributor margin. Ferrari = catalogue model closest in tm to the best seller; price = TSP selling price to customers, crane only, incl. GP, warranty and tax. Classes above 55 tm merged (few units each); tied best sellers ranked by import value. Prices rounded to Rp 10.000.000.</a:t>
+              <a:t>Source: Indonesia import records, HS 84269100 + 84264900, Jan 2023 – 14 Aug 2026; truck-mounted knuckle boom cranes only, Zoomlion and Hyva excluded. Best-selling model = most units in the class (variants merged). Competitor price = average import unit price × Rp 17.803/USD (JISDOR 23 Sep 2026) + import duty (0% China – ACFTA; 5% Europe, assumed), PPN 11%, PPh 22 2.5% — import cost before distributor margin. Ferrari = catalogue model closest in tm to the best seller; price = TSP selling price to customers, crane only, incl. GP, warranty and tax. Classes above 55 tm merged (few units each); tied best sellers ranked by import value.Ferrari photos: pocket catalogue 2026 (application photos). Prices rounded to Rp 10.000.000.</a:t>
             </a:r>
             <a:endParaRPr lang="en-US" sz="750" dirty="0"/>
           </a:p>

</xml_diff>

<commit_message>
Add PK 76002 photo; rename column to Total qty in class
Co-Authored-By: Claude Opus 5.5 <noreply@anthropic.com>
Claude-Session: https://claude.ai/code/session_01Pbxjp9hvsGyGE8VjiFxi6d
</commit_message>
<xml_diff>
--- a/slides/Slide_tm_Positioning.pptx
+++ b/slides/Slide_tm_Positioning.pptx
@@ -1275,7 +1275,7 @@
                           <a:ea typeface="Arial" pitchFamily="34" charset="-122"/>
                           <a:cs typeface="Arial" pitchFamily="34" charset="-120"/>
                         </a:rPr>
-                        <a:t>Units in class</a:t>
+                        <a:t>Total qty in class</a:t>
                       </a:r>
                       <a:endParaRPr lang="en-US" sz="900" dirty="0">
                         <a:latin typeface="Arial" charset="0"/>
@@ -5324,7 +5324,7 @@
                           <a:ea typeface="Arial" pitchFamily="34" charset="-122"/>
                           <a:cs typeface="Arial" pitchFamily="34" charset="-120"/>
                         </a:rPr>
-                        <a:t>Units in class</a:t>
+                        <a:t>Total qty in class</a:t>
                       </a:r>
                       <a:endParaRPr lang="en-US" sz="900" dirty="0">
                         <a:latin typeface="Arial" charset="0"/>
@@ -7688,12 +7688,19 @@
           </a:p>
         </p:txBody>
       </p:sp>
-      <p:sp>
-        <p:nvSpPr>
-          <p:cNvPr id="19" name="Text 11"/>
-          <p:cNvSpPr txBox="1"/>
+      <p:pic>
+        <p:nvPicPr>
+          <p:cNvPr id="19" name="Image 5" descr="assets/photo_pk76002.jpg">    </p:cNvPr>
+          <p:cNvPicPr>
+            <a:picLocks noChangeAspect="1"/>
+          </p:cNvPicPr>
           <p:nvPr/>
-        </p:nvSpPr>
+        </p:nvPicPr>
+        <p:blipFill>
+          <a:blip r:embed="rId6"/>
+          <a:srcRect l="0" r="0" t="0" b="0"/>
+          <a:stretch/>
+        </p:blipFill>
         <p:spPr>
           <a:xfrm>
             <a:off x="2432304" y="3922776"/>
@@ -7702,34 +7709,11 @@
           <a:prstGeom prst="rect">
             <a:avLst/>
           </a:prstGeom>
-          <a:noFill/>
-          <a:ln/>
         </p:spPr>
-        <p:txBody>
-          <a:bodyPr wrap="square" lIns="0" tIns="0" rIns="0" bIns="0" rtlCol="0" anchor="ctr"/>
-          <a:lstStyle/>
-          <a:p>
-            <a:pPr algn="ctr" indent="0" marL="0">
-              <a:buNone/>
-            </a:pPr>
-            <a:r>
-              <a:rPr lang="en-US" sz="800" i="1" dirty="0">
-                <a:solidFill>
-                  <a:srgbClr val="5C6773"/>
-                </a:solidFill>
-                <a:latin typeface="Arial" pitchFamily="34" charset="0"/>
-                <a:ea typeface="Arial" pitchFamily="34" charset="-122"/>
-                <a:cs typeface="Arial" pitchFamily="34" charset="-120"/>
-              </a:rPr>
-              <a:t>Photo to follow</a:t>
-            </a:r>
-            <a:endParaRPr lang="en-US" sz="800" dirty="0"/>
-          </a:p>
-        </p:txBody>
-      </p:sp>
+      </p:pic>
       <p:sp>
         <p:nvSpPr>
-          <p:cNvPr id="20" name="Shape 12"/>
+          <p:cNvPr id="20" name="Shape 11"/>
           <p:cNvSpPr/>
           <p:nvPr/>
         </p:nvSpPr>
@@ -7756,14 +7740,14 @@
       </p:sp>
       <p:pic>
         <p:nvPicPr>
-          <p:cNvPr id="21" name="Image 5" descr="assets/logo_palfinger.png">    </p:cNvPr>
+          <p:cNvPr id="21" name="Image 6" descr="assets/logo_palfinger.png">    </p:cNvPr>
           <p:cNvPicPr>
             <a:picLocks noChangeAspect="1"/>
           </p:cNvPicPr>
           <p:nvPr/>
         </p:nvPicPr>
         <p:blipFill>
-          <a:blip r:embed="rId6"/>
+          <a:blip r:embed="rId7"/>
           <a:stretch>
             <a:fillRect/>
           </a:stretch>
@@ -7780,7 +7764,7 @@
       </p:pic>
       <p:sp>
         <p:nvSpPr>
-          <p:cNvPr id="22" name="Text 13"/>
+          <p:cNvPr id="22" name="Text 12"/>
           <p:cNvSpPr txBox="1"/>
           <p:nvPr/>
         </p:nvSpPr>
@@ -7836,14 +7820,14 @@
       </p:sp>
       <p:pic>
         <p:nvPicPr>
-          <p:cNvPr id="23" name="Image 6" descr="assets/photo_fbr660r.jpg">    </p:cNvPr>
+          <p:cNvPr id="23" name="Image 7" descr="assets/photo_fbr660r.jpg">    </p:cNvPr>
           <p:cNvPicPr>
             <a:picLocks noChangeAspect="1"/>
           </p:cNvPicPr>
           <p:nvPr/>
         </p:nvPicPr>
         <p:blipFill>
-          <a:blip r:embed="rId7"/>
+          <a:blip r:embed="rId8"/>
           <a:srcRect l="0" r="0" t="0" b="0"/>
           <a:stretch/>
         </p:blipFill>
@@ -7859,7 +7843,7 @@
       </p:pic>
       <p:sp>
         <p:nvSpPr>
-          <p:cNvPr id="24" name="Text 14"/>
+          <p:cNvPr id="24" name="Text 13"/>
           <p:cNvSpPr txBox="1"/>
           <p:nvPr/>
         </p:nvSpPr>
@@ -7915,7 +7899,7 @@
       </p:sp>
       <p:sp>
         <p:nvSpPr>
-          <p:cNvPr id="25" name="Shape 15"/>
+          <p:cNvPr id="25" name="Shape 14"/>
           <p:cNvSpPr/>
           <p:nvPr/>
         </p:nvSpPr>
@@ -7940,7 +7924,7 @@
       </p:sp>
       <p:sp>
         <p:nvSpPr>
-          <p:cNvPr id="26" name="Text 16"/>
+          <p:cNvPr id="26" name="Text 15"/>
           <p:cNvSpPr txBox="1"/>
           <p:nvPr/>
         </p:nvSpPr>
@@ -7979,7 +7963,7 @@
       </p:sp>
       <p:sp>
         <p:nvSpPr>
-          <p:cNvPr id="27" name="Shape 17"/>
+          <p:cNvPr id="27" name="Shape 16"/>
           <p:cNvSpPr/>
           <p:nvPr/>
         </p:nvSpPr>
@@ -8004,7 +7988,7 @@
       </p:sp>
       <p:sp>
         <p:nvSpPr>
-          <p:cNvPr id="28" name="Text 18"/>
+          <p:cNvPr id="28" name="Text 17"/>
           <p:cNvSpPr txBox="1"/>
           <p:nvPr/>
         </p:nvSpPr>
@@ -8043,7 +8027,7 @@
       </p:sp>
       <p:sp>
         <p:nvSpPr>
-          <p:cNvPr id="29" name="Shape 19"/>
+          <p:cNvPr id="29" name="Shape 18"/>
           <p:cNvSpPr/>
           <p:nvPr/>
         </p:nvSpPr>
@@ -8068,7 +8052,7 @@
       </p:sp>
       <p:sp>
         <p:nvSpPr>
-          <p:cNvPr id="30" name="Text 20"/>
+          <p:cNvPr id="30" name="Text 19"/>
           <p:cNvSpPr txBox="1"/>
           <p:nvPr/>
         </p:nvSpPr>
@@ -8107,7 +8091,7 @@
       </p:sp>
       <p:sp>
         <p:nvSpPr>
-          <p:cNvPr id="31" name="Text 21"/>
+          <p:cNvPr id="31" name="Text 20"/>
           <p:cNvSpPr txBox="1"/>
           <p:nvPr/>
         </p:nvSpPr>

</xml_diff>